<commit_message>
docs: strengthen sourced presentation story
</commit_message>
<xml_diff>
--- a/docs/deck/FreshSaver-AI-Builders-Hackathon.pptx
+++ b/docs/deck/FreshSaver-AI-Builders-Hackathon.pptx
@@ -511,7 +511,7 @@
           <a:p>
             <a:r>
               <a:rPr lang="en-US" dirty="0"/>
-              <a:t>Open with the merchant tension: discount too early and lose margin; too late and lose the product. FreshSaver recommends a reviewable intervention before food becomes surplus.</a:t>
+              <a:t>Open as a story: It is closing time. A neighborhood grocer has 18 cartons of milk and four days left. Discount too deeply and margin disappears; wait too long and the product may be lost. FreshSaver turns that recurring shelf decision into a reviewable intervention.</a:t>
             </a:r>
             <a:endParaRPr lang="en-US" dirty="0"/>
           </a:p>
@@ -687,7 +687,7 @@
           <a:p>
             <a:r>
               <a:rPr lang="en-US" dirty="0"/>
-              <a:t>Avoid unsupported global waste statistics. Explain the operating tension and why timing plus product-level demand context matters.</a:t>
+              <a:t>Tell the story from global to local. UNEP reports 1.05 billion tonnes of food waste in 2022 across retail, food service and households; 12% occurred at retail. Food loss and waste cost roughly US$1 trillion and generate 8–10% of global greenhouse gas emissions. Separately, the European Commission estimates up to 10% of EU food waste is linked to date marking. Do not say all global food waste is caused by expiry dates. Bring the story back to the grocer choosing between holding, marking down, or losing stock.</a:t>
             </a:r>
             <a:endParaRPr lang="en-US" dirty="0"/>
           </a:p>
@@ -2156,7 +2156,7 @@
                 <a:ea typeface="Aptos Display" pitchFamily="34" charset="-122"/>
                 <a:cs typeface="Aptos Display" pitchFamily="34" charset="-120"/>
               </a:rPr>
-              <a:t>Protect margin</a:t>
+              <a:t>At closing time,</a:t>
             </a:r>
             <a:endParaRPr lang="en-US" sz="3700" dirty="0"/>
           </a:p>
@@ -2173,7 +2173,7 @@
                 <a:ea typeface="Aptos Display" pitchFamily="34" charset="-122"/>
                 <a:cs typeface="Aptos Display" pitchFamily="34" charset="-120"/>
               </a:rPr>
-              <a:t>before food</a:t>
+              <a:t>18 cartons still</a:t>
             </a:r>
             <a:endParaRPr lang="en-US" sz="3700" dirty="0"/>
           </a:p>
@@ -2190,7 +2190,7 @@
                 <a:ea typeface="Aptos Display" pitchFamily="34" charset="-122"/>
                 <a:cs typeface="Aptos Display" pitchFamily="34" charset="-120"/>
               </a:rPr>
-              <a:t>becomes waste.</a:t>
+              <a:t>have value.</a:t>
             </a:r>
             <a:endParaRPr lang="en-US" sz="3700" dirty="0"/>
           </a:p>
@@ -2231,7 +2231,7 @@
                 <a:ea typeface="Aptos" pitchFamily="34" charset="-122"/>
                 <a:cs typeface="Aptos" pitchFamily="34" charset="-120"/>
               </a:rPr>
-              <a:t>An explainable markdown copilot for independent grocers — from inventory risk to an approved customer offer.</a:t>
+              <a:t>FreshSaver helps a grocer choose the right intervention before good food becomes waste.</a:t>
             </a:r>
             <a:endParaRPr lang="en-US" sz="1500" dirty="0"/>
           </a:p>
@@ -2282,25 +2282,25 @@
         <p:spPr>
           <a:xfrm>
             <a:off x="6995160" y="1444752"/>
-            <a:ext cx="2011680" cy="228600"/>
-          </a:xfrm>
-          <a:prstGeom prst="rect">
-            <a:avLst/>
-          </a:prstGeom>
-          <a:noFill/>
-          <a:ln/>
-        </p:spPr>
-        <p:txBody>
-          <a:bodyPr wrap="square" lIns="0" tIns="0" rIns="0" bIns="0" rtlCol="0" anchor="ctr">
-            <a:normAutofit/>
-          </a:bodyPr>
-          <a:lstStyle/>
-          <a:p>
-            <a:pPr algn="l" indent="0" marL="0">
-              <a:buNone/>
-            </a:pPr>
-            <a:r>
-              <a:rPr lang="en-US" sz="900" b="1" spc="150" kern="0" dirty="0">
+            <a:ext cx="2514600" cy="228600"/>
+          </a:xfrm>
+          <a:prstGeom prst="rect">
+            <a:avLst/>
+          </a:prstGeom>
+          <a:noFill/>
+          <a:ln/>
+        </p:spPr>
+        <p:txBody>
+          <a:bodyPr wrap="square" lIns="0" tIns="0" rIns="0" bIns="0" rtlCol="0" anchor="ctr">
+            <a:normAutofit/>
+          </a:bodyPr>
+          <a:lstStyle/>
+          <a:p>
+            <a:pPr algn="l" indent="0" marL="0">
+              <a:buNone/>
+            </a:pPr>
+            <a:r>
+              <a:rPr lang="en-US" sz="900" b="1" spc="120" kern="0" dirty="0">
                 <a:solidFill>
                   <a:srgbClr val="10B981"/>
                 </a:solidFill>
@@ -2308,7 +2308,7 @@
                 <a:ea typeface="Aptos" pitchFamily="34" charset="-122"/>
                 <a:cs typeface="Aptos" pitchFamily="34" charset="-120"/>
               </a:rPr>
-              <a:t>TODAY'S DECISION</a:t>
+              <a:t>ILLUSTRATIVE STORE DECISION</a:t>
             </a:r>
             <a:endParaRPr lang="en-US" sz="900" dirty="0"/>
           </a:p>
@@ -3230,7 +3230,7 @@
                 <a:ea typeface="Aptos" pitchFamily="34" charset="-122"/>
                 <a:cs typeface="Aptos" pitchFamily="34" charset="-120"/>
               </a:rPr>
-              <a:t>Demand-aware markdowns for independent grocery stores</a:t>
+              <a:t>The global waste problem appears as a local pricing decision</a:t>
             </a:r>
             <a:endParaRPr lang="en-US" sz="750" dirty="0"/>
           </a:p>
@@ -4639,7 +4639,7 @@
                 <a:ea typeface="Aptos" pitchFamily="34" charset="-122"/>
                 <a:cs typeface="Aptos" pitchFamily="34" charset="-120"/>
               </a:rPr>
-              <a:t>THE DECISION GAP</a:t>
+              <a:t>PROBLEM STATEMENT</a:t>
             </a:r>
             <a:endParaRPr lang="en-US" sz="900" dirty="0"/>
           </a:p>
@@ -4680,7 +4680,7 @@
                 <a:ea typeface="Aptos Display" pitchFamily="34" charset="-122"/>
                 <a:cs typeface="Aptos Display" pitchFamily="34" charset="-120"/>
               </a:rPr>
-              <a:t>Fixed markdown rules miss the context.</a:t>
+              <a:t>The waste is global. The decision is local.</a:t>
             </a:r>
             <a:endParaRPr lang="en-US" sz="2700" dirty="0"/>
           </a:p>
@@ -4721,7 +4721,7 @@
                 <a:ea typeface="Aptos" pitchFamily="34" charset="-122"/>
                 <a:cs typeface="Aptos" pitchFamily="34" charset="-120"/>
               </a:rPr>
-              <a:t>Two products can share an expiry date and still need opposite decisions.</a:t>
+              <a:t>Every number below is sourced; not all global food waste is caused by expiry dates.</a:t>
             </a:r>
             <a:endParaRPr lang="en-US" sz="1250" dirty="0"/>
           </a:p>
@@ -4735,271 +4735,12 @@
         </p:nvSpPr>
         <p:spPr>
           <a:xfrm>
-            <a:off x="594360" y="2103120"/>
-            <a:ext cx="3154680" cy="3246120"/>
+            <a:off x="621792" y="1975104"/>
+            <a:ext cx="2971800" cy="1627632"/>
           </a:xfrm>
           <a:prstGeom prst="roundRect">
             <a:avLst>
-              <a:gd name="adj" fmla="val 7246"/>
-            </a:avLst>
-          </a:prstGeom>
-          <a:solidFill>
-            <a:srgbClr val="FFF0E7"/>
-          </a:solidFill>
-          <a:ln w="12700">
-            <a:solidFill>
-              <a:srgbClr val="FFF0E7">
-                <a:alpha val="0"/>
-              </a:srgbClr>
-            </a:solidFill>
-            <a:prstDash val="solid"/>
-          </a:ln>
-        </p:spPr>
-      </p:sp>
-      <p:sp>
-        <p:nvSpPr>
-          <p:cNvPr id="6" name="Shape 4"/>
-          <p:cNvSpPr/>
-          <p:nvPr/>
-        </p:nvSpPr>
-        <p:spPr>
-          <a:xfrm>
-            <a:off x="868680" y="2395728"/>
-            <a:ext cx="438912" cy="438912"/>
-          </a:xfrm>
-          <a:prstGeom prst="ellipse">
-            <a:avLst/>
-          </a:prstGeom>
-          <a:solidFill>
-            <a:srgbClr val="F97316"/>
-          </a:solidFill>
-          <a:ln w="12700">
-            <a:solidFill>
-              <a:srgbClr val="F97316"/>
-            </a:solidFill>
-            <a:prstDash val="solid"/>
-          </a:ln>
-        </p:spPr>
-      </p:sp>
-      <p:sp>
-        <p:nvSpPr>
-          <p:cNvPr id="7" name="Text 5"/>
-          <p:cNvSpPr/>
-          <p:nvPr/>
-        </p:nvSpPr>
-        <p:spPr>
-          <a:xfrm>
-            <a:off x="868680" y="2395728"/>
-            <a:ext cx="438912" cy="438912"/>
-          </a:xfrm>
-          <a:prstGeom prst="rect">
-            <a:avLst/>
-          </a:prstGeom>
-          <a:noFill/>
-          <a:ln/>
-        </p:spPr>
-        <p:txBody>
-          <a:bodyPr wrap="square" lIns="0" tIns="0" rIns="0" bIns="0" rtlCol="0" anchor="ctr">
-            <a:normAutofit/>
-          </a:bodyPr>
-          <a:lstStyle/>
-          <a:p>
-            <a:pPr algn="ctr" indent="0" marL="0">
-              <a:buNone/>
-            </a:pPr>
-            <a:r>
-              <a:rPr lang="en-US" sz="2000" b="1" dirty="0">
-                <a:solidFill>
-                  <a:srgbClr val="FFFFFF"/>
-                </a:solidFill>
-                <a:latin typeface="Aptos" pitchFamily="34" charset="0"/>
-                <a:ea typeface="Aptos" pitchFamily="34" charset="-122"/>
-                <a:cs typeface="Aptos" pitchFamily="34" charset="-120"/>
-              </a:rPr>
-              <a:t>−</a:t>
-            </a:r>
-            <a:endParaRPr lang="en-US" sz="2000" dirty="0"/>
-          </a:p>
-        </p:txBody>
-      </p:sp>
-      <p:sp>
-        <p:nvSpPr>
-          <p:cNvPr id="8" name="Text 6"/>
-          <p:cNvSpPr/>
-          <p:nvPr/>
-        </p:nvSpPr>
-        <p:spPr>
-          <a:xfrm>
-            <a:off x="868680" y="2999232"/>
-            <a:ext cx="2423160" cy="384048"/>
-          </a:xfrm>
-          <a:prstGeom prst="rect">
-            <a:avLst/>
-          </a:prstGeom>
-          <a:noFill/>
-          <a:ln/>
-        </p:spPr>
-        <p:txBody>
-          <a:bodyPr wrap="square" lIns="0" tIns="0" rIns="0" bIns="0" rtlCol="0" anchor="ctr">
-            <a:normAutofit/>
-          </a:bodyPr>
-          <a:lstStyle/>
-          <a:p>
-            <a:pPr algn="l" indent="0" marL="0">
-              <a:buNone/>
-            </a:pPr>
-            <a:r>
-              <a:rPr lang="en-US" sz="2200" b="1" dirty="0">
-                <a:solidFill>
-                  <a:srgbClr val="F97316"/>
-                </a:solidFill>
-                <a:latin typeface="Aptos Display" pitchFamily="34" charset="0"/>
-                <a:ea typeface="Aptos Display" pitchFamily="34" charset="-122"/>
-                <a:cs typeface="Aptos Display" pitchFamily="34" charset="-120"/>
-              </a:rPr>
-              <a:t>Discount too early</a:t>
-            </a:r>
-            <a:endParaRPr lang="en-US" sz="2200" dirty="0"/>
-          </a:p>
-        </p:txBody>
-      </p:sp>
-      <p:sp>
-        <p:nvSpPr>
-          <p:cNvPr id="9" name="Text 7"/>
-          <p:cNvSpPr/>
-          <p:nvPr/>
-        </p:nvSpPr>
-        <p:spPr>
-          <a:xfrm>
-            <a:off x="868680" y="3566160"/>
-            <a:ext cx="2468880" cy="777240"/>
-          </a:xfrm>
-          <a:prstGeom prst="rect">
-            <a:avLst/>
-          </a:prstGeom>
-          <a:noFill/>
-          <a:ln/>
-        </p:spPr>
-        <p:txBody>
-          <a:bodyPr wrap="square" lIns="0" tIns="0" rIns="0" bIns="0" rtlCol="0" anchor="t">
-            <a:normAutofit/>
-          </a:bodyPr>
-          <a:lstStyle/>
-          <a:p>
-            <a:pPr algn="l" indent="0" marL="0">
-              <a:buNone/>
-            </a:pPr>
-            <a:r>
-              <a:rPr lang="en-US" sz="1300" dirty="0">
-                <a:solidFill>
-                  <a:srgbClr val="8D4A25"/>
-                </a:solidFill>
-                <a:latin typeface="Aptos" pitchFamily="34" charset="0"/>
-                <a:ea typeface="Aptos" pitchFamily="34" charset="-122"/>
-                <a:cs typeface="Aptos" pitchFamily="34" charset="-120"/>
-              </a:rPr>
-              <a:t>Fast-moving stock gets marked down even when full-price demand can clear it.</a:t>
-            </a:r>
-            <a:endParaRPr lang="en-US" sz="1300" dirty="0"/>
-          </a:p>
-        </p:txBody>
-      </p:sp>
-      <p:sp>
-        <p:nvSpPr>
-          <p:cNvPr id="10" name="Text 8"/>
-          <p:cNvSpPr/>
-          <p:nvPr/>
-        </p:nvSpPr>
-        <p:spPr>
-          <a:xfrm>
-            <a:off x="868680" y="4617720"/>
-            <a:ext cx="548640" cy="201168"/>
-          </a:xfrm>
-          <a:prstGeom prst="rect">
-            <a:avLst/>
-          </a:prstGeom>
-          <a:noFill/>
-          <a:ln/>
-        </p:spPr>
-        <p:txBody>
-          <a:bodyPr wrap="square" lIns="0" tIns="0" rIns="0" bIns="0" rtlCol="0" anchor="ctr">
-            <a:normAutofit/>
-          </a:bodyPr>
-          <a:lstStyle/>
-          <a:p>
-            <a:pPr algn="l" indent="0" marL="0">
-              <a:buNone/>
-            </a:pPr>
-            <a:r>
-              <a:rPr lang="en-US" sz="900" b="1" spc="100" kern="0" dirty="0">
-                <a:solidFill>
-                  <a:srgbClr val="F97316"/>
-                </a:solidFill>
-                <a:latin typeface="Aptos" pitchFamily="34" charset="0"/>
-                <a:ea typeface="Aptos" pitchFamily="34" charset="-122"/>
-                <a:cs typeface="Aptos" pitchFamily="34" charset="-120"/>
-              </a:rPr>
-              <a:t>Result</a:t>
-            </a:r>
-            <a:endParaRPr lang="en-US" sz="900" dirty="0"/>
-          </a:p>
-        </p:txBody>
-      </p:sp>
-      <p:sp>
-        <p:nvSpPr>
-          <p:cNvPr id="11" name="Text 9"/>
-          <p:cNvSpPr/>
-          <p:nvPr/>
-        </p:nvSpPr>
-        <p:spPr>
-          <a:xfrm>
-            <a:off x="868680" y="4873752"/>
-            <a:ext cx="2194560" cy="274320"/>
-          </a:xfrm>
-          <a:prstGeom prst="rect">
-            <a:avLst/>
-          </a:prstGeom>
-          <a:noFill/>
-          <a:ln/>
-        </p:spPr>
-        <p:txBody>
-          <a:bodyPr wrap="square" lIns="0" tIns="0" rIns="0" bIns="0" rtlCol="0" anchor="ctr">
-            <a:normAutofit/>
-          </a:bodyPr>
-          <a:lstStyle/>
-          <a:p>
-            <a:pPr algn="l" indent="0" marL="0">
-              <a:buNone/>
-            </a:pPr>
-            <a:r>
-              <a:rPr lang="en-US" sz="1600" b="1" dirty="0">
-                <a:solidFill>
-                  <a:srgbClr val="F97316"/>
-                </a:solidFill>
-                <a:latin typeface="Aptos" pitchFamily="34" charset="0"/>
-                <a:ea typeface="Aptos" pitchFamily="34" charset="-122"/>
-                <a:cs typeface="Aptos" pitchFamily="34" charset="-120"/>
-              </a:rPr>
-              <a:t>Margin surrendered</a:t>
-            </a:r>
-            <a:endParaRPr lang="en-US" sz="1600" dirty="0"/>
-          </a:p>
-        </p:txBody>
-      </p:sp>
-      <p:sp>
-        <p:nvSpPr>
-          <p:cNvPr id="12" name="Shape 10"/>
-          <p:cNvSpPr/>
-          <p:nvPr/>
-        </p:nvSpPr>
-        <p:spPr>
-          <a:xfrm>
-            <a:off x="3986784" y="1874520"/>
-            <a:ext cx="3675888" cy="3703320"/>
-          </a:xfrm>
-          <a:prstGeom prst="roundRect">
-            <a:avLst>
-              <a:gd name="adj" fmla="val 6965"/>
+              <a:gd name="adj" fmla="val 12921"/>
             </a:avLst>
           </a:prstGeom>
           <a:solidFill>
@@ -5024,26 +4765,463 @@
       </p:sp>
       <p:sp>
         <p:nvSpPr>
-          <p:cNvPr id="13" name="Shape 11"/>
-          <p:cNvSpPr/>
-          <p:nvPr/>
-        </p:nvSpPr>
-        <p:spPr>
-          <a:xfrm>
-            <a:off x="4773168" y="2240280"/>
-            <a:ext cx="2103120" cy="292608"/>
+          <p:cNvPr id="6" name="Text 4"/>
+          <p:cNvSpPr/>
+          <p:nvPr/>
+        </p:nvSpPr>
+        <p:spPr>
+          <a:xfrm>
+            <a:off x="841248" y="2212848"/>
+            <a:ext cx="1600200" cy="502920"/>
+          </a:xfrm>
+          <a:prstGeom prst="rect">
+            <a:avLst/>
+          </a:prstGeom>
+          <a:noFill/>
+          <a:ln/>
+        </p:spPr>
+        <p:txBody>
+          <a:bodyPr wrap="square" lIns="0" tIns="0" rIns="0" bIns="0" rtlCol="0" anchor="ctr">
+            <a:normAutofit/>
+          </a:bodyPr>
+          <a:lstStyle/>
+          <a:p>
+            <a:pPr algn="l" indent="0" marL="0">
+              <a:buNone/>
+            </a:pPr>
+            <a:r>
+              <a:rPr lang="en-US" sz="3100" b="1" dirty="0">
+                <a:solidFill>
+                  <a:srgbClr val="BEF264"/>
+                </a:solidFill>
+                <a:latin typeface="Aptos Display" pitchFamily="34" charset="0"/>
+                <a:ea typeface="Aptos Display" pitchFamily="34" charset="-122"/>
+                <a:cs typeface="Aptos Display" pitchFamily="34" charset="-120"/>
+              </a:rPr>
+              <a:t>1.05B</a:t>
+            </a:r>
+            <a:endParaRPr lang="en-US" sz="3100" dirty="0"/>
+          </a:p>
+        </p:txBody>
+      </p:sp>
+      <p:sp>
+        <p:nvSpPr>
+          <p:cNvPr id="7" name="Text 5"/>
+          <p:cNvSpPr/>
+          <p:nvPr/>
+        </p:nvSpPr>
+        <p:spPr>
+          <a:xfrm>
+            <a:off x="2359152" y="2414016"/>
+            <a:ext cx="914400" cy="219456"/>
+          </a:xfrm>
+          <a:prstGeom prst="rect">
+            <a:avLst/>
+          </a:prstGeom>
+          <a:noFill/>
+          <a:ln/>
+        </p:spPr>
+        <p:txBody>
+          <a:bodyPr wrap="square" lIns="0" tIns="0" rIns="0" bIns="0" rtlCol="0" anchor="ctr">
+            <a:normAutofit/>
+          </a:bodyPr>
+          <a:lstStyle/>
+          <a:p>
+            <a:pPr algn="r" indent="0" marL="0">
+              <a:buNone/>
+            </a:pPr>
+            <a:r>
+              <a:rPr lang="en-US" sz="1000" b="1" dirty="0">
+                <a:solidFill>
+                  <a:srgbClr val="FFFFFF"/>
+                </a:solidFill>
+                <a:latin typeface="Aptos" pitchFamily="34" charset="0"/>
+                <a:ea typeface="Aptos" pitchFamily="34" charset="-122"/>
+                <a:cs typeface="Aptos" pitchFamily="34" charset="-120"/>
+              </a:rPr>
+              <a:t>tonnes</a:t>
+            </a:r>
+            <a:endParaRPr lang="en-US" sz="1000" dirty="0"/>
+          </a:p>
+        </p:txBody>
+      </p:sp>
+      <p:sp>
+        <p:nvSpPr>
+          <p:cNvPr id="8" name="Text 6"/>
+          <p:cNvSpPr/>
+          <p:nvPr/>
+        </p:nvSpPr>
+        <p:spPr>
+          <a:xfrm>
+            <a:off x="841248" y="2852928"/>
+            <a:ext cx="2468880" cy="530352"/>
+          </a:xfrm>
+          <a:prstGeom prst="rect">
+            <a:avLst/>
+          </a:prstGeom>
+          <a:noFill/>
+          <a:ln/>
+        </p:spPr>
+        <p:txBody>
+          <a:bodyPr wrap="square" lIns="0" tIns="0" rIns="0" bIns="0" rtlCol="0" anchor="t">
+            <a:normAutofit/>
+          </a:bodyPr>
+          <a:lstStyle/>
+          <a:p>
+            <a:pPr algn="l" indent="0" marL="0">
+              <a:buNone/>
+            </a:pPr>
+            <a:r>
+              <a:rPr lang="en-US" sz="1050" dirty="0">
+                <a:solidFill>
+                  <a:srgbClr val="CAD9D3"/>
+                </a:solidFill>
+                <a:latin typeface="Aptos" pitchFamily="34" charset="0"/>
+                <a:ea typeface="Aptos" pitchFamily="34" charset="-122"/>
+                <a:cs typeface="Aptos" pitchFamily="34" charset="-120"/>
+              </a:rPr>
+              <a:t>food waste generated at retail, food service and household level in 2022</a:t>
+            </a:r>
+            <a:endParaRPr lang="en-US" sz="1050" dirty="0"/>
+          </a:p>
+        </p:txBody>
+      </p:sp>
+      <p:sp>
+        <p:nvSpPr>
+          <p:cNvPr id="9" name="Shape 7"/>
+          <p:cNvSpPr/>
+          <p:nvPr/>
+        </p:nvSpPr>
+        <p:spPr>
+          <a:xfrm>
+            <a:off x="3986784" y="1975104"/>
+            <a:ext cx="2971800" cy="1627632"/>
           </a:xfrm>
           <a:prstGeom prst="roundRect">
             <a:avLst>
-              <a:gd name="adj" fmla="val 50000"/>
+              <a:gd name="adj" fmla="val 12921"/>
             </a:avLst>
           </a:prstGeom>
           <a:solidFill>
-            <a:srgbClr val="2C574A"/>
+            <a:srgbClr val="F2ECFF"/>
           </a:solidFill>
           <a:ln w="12700">
             <a:solidFill>
-              <a:srgbClr val="2C574A">
+              <a:srgbClr val="D9E3DD"/>
+            </a:solidFill>
+            <a:prstDash val="solid"/>
+          </a:ln>
+          <a:effectLst>
+            <a:outerShdw sx="100000" sy="100000" kx="0" ky="0" algn="bl" rotWithShape="0" blurRad="4096766000000" dist="8193532000000" dir="9720000000000000">
+              <a:srgbClr val="0A241C">
+                <a:alpha val="130000000000000"/>
+              </a:srgbClr>
+            </a:outerShdw>
+          </a:effectLst>
+        </p:spPr>
+      </p:sp>
+      <p:sp>
+        <p:nvSpPr>
+          <p:cNvPr id="10" name="Text 8"/>
+          <p:cNvSpPr/>
+          <p:nvPr/>
+        </p:nvSpPr>
+        <p:spPr>
+          <a:xfrm>
+            <a:off x="4206240" y="2212848"/>
+            <a:ext cx="1600200" cy="502920"/>
+          </a:xfrm>
+          <a:prstGeom prst="rect">
+            <a:avLst/>
+          </a:prstGeom>
+          <a:noFill/>
+          <a:ln/>
+        </p:spPr>
+        <p:txBody>
+          <a:bodyPr wrap="square" lIns="0" tIns="0" rIns="0" bIns="0" rtlCol="0" anchor="ctr">
+            <a:normAutofit/>
+          </a:bodyPr>
+          <a:lstStyle/>
+          <a:p>
+            <a:pPr algn="l" indent="0" marL="0">
+              <a:buNone/>
+            </a:pPr>
+            <a:r>
+              <a:rPr lang="en-US" sz="3100" b="1" dirty="0">
+                <a:solidFill>
+                  <a:srgbClr val="7C3AED"/>
+                </a:solidFill>
+                <a:latin typeface="Aptos Display" pitchFamily="34" charset="0"/>
+                <a:ea typeface="Aptos Display" pitchFamily="34" charset="-122"/>
+                <a:cs typeface="Aptos Display" pitchFamily="34" charset="-120"/>
+              </a:rPr>
+              <a:t>~$1T</a:t>
+            </a:r>
+            <a:endParaRPr lang="en-US" sz="3100" dirty="0"/>
+          </a:p>
+        </p:txBody>
+      </p:sp>
+      <p:sp>
+        <p:nvSpPr>
+          <p:cNvPr id="11" name="Text 9"/>
+          <p:cNvSpPr/>
+          <p:nvPr/>
+        </p:nvSpPr>
+        <p:spPr>
+          <a:xfrm>
+            <a:off x="5724144" y="2414016"/>
+            <a:ext cx="914400" cy="219456"/>
+          </a:xfrm>
+          <a:prstGeom prst="rect">
+            <a:avLst/>
+          </a:prstGeom>
+          <a:noFill/>
+          <a:ln/>
+        </p:spPr>
+        <p:txBody>
+          <a:bodyPr wrap="square" lIns="0" tIns="0" rIns="0" bIns="0" rtlCol="0" anchor="ctr">
+            <a:normAutofit/>
+          </a:bodyPr>
+          <a:lstStyle/>
+          <a:p>
+            <a:pPr algn="r" indent="0" marL="0">
+              <a:buNone/>
+            </a:pPr>
+            <a:r>
+              <a:rPr lang="en-US" sz="1000" b="1" dirty="0">
+                <a:solidFill>
+                  <a:srgbClr val="7C3AED"/>
+                </a:solidFill>
+                <a:latin typeface="Aptos" pitchFamily="34" charset="0"/>
+                <a:ea typeface="Aptos" pitchFamily="34" charset="-122"/>
+                <a:cs typeface="Aptos" pitchFamily="34" charset="-120"/>
+              </a:rPr>
+              <a:t>each year</a:t>
+            </a:r>
+            <a:endParaRPr lang="en-US" sz="1000" dirty="0"/>
+          </a:p>
+        </p:txBody>
+      </p:sp>
+      <p:sp>
+        <p:nvSpPr>
+          <p:cNvPr id="12" name="Text 10"/>
+          <p:cNvSpPr/>
+          <p:nvPr/>
+        </p:nvSpPr>
+        <p:spPr>
+          <a:xfrm>
+            <a:off x="4206240" y="2852928"/>
+            <a:ext cx="2468880" cy="530352"/>
+          </a:xfrm>
+          <a:prstGeom prst="rect">
+            <a:avLst/>
+          </a:prstGeom>
+          <a:noFill/>
+          <a:ln/>
+        </p:spPr>
+        <p:txBody>
+          <a:bodyPr wrap="square" lIns="0" tIns="0" rIns="0" bIns="0" rtlCol="0" anchor="t">
+            <a:normAutofit/>
+          </a:bodyPr>
+          <a:lstStyle/>
+          <a:p>
+            <a:pPr algn="l" indent="0" marL="0">
+              <a:buNone/>
+            </a:pPr>
+            <a:r>
+              <a:rPr lang="en-US" sz="1050" dirty="0">
+                <a:solidFill>
+                  <a:srgbClr val="667D75"/>
+                </a:solidFill>
+                <a:latin typeface="Aptos" pitchFamily="34" charset="0"/>
+                <a:ea typeface="Aptos" pitchFamily="34" charset="-122"/>
+                <a:cs typeface="Aptos" pitchFamily="34" charset="-120"/>
+              </a:rPr>
+              <a:t>estimated global economic toll of food loss and waste</a:t>
+            </a:r>
+            <a:endParaRPr lang="en-US" sz="1050" dirty="0"/>
+          </a:p>
+        </p:txBody>
+      </p:sp>
+      <p:sp>
+        <p:nvSpPr>
+          <p:cNvPr id="13" name="Shape 11"/>
+          <p:cNvSpPr/>
+          <p:nvPr/>
+        </p:nvSpPr>
+        <p:spPr>
+          <a:xfrm>
+            <a:off x="7351776" y="1975104"/>
+            <a:ext cx="2971800" cy="1627632"/>
+          </a:xfrm>
+          <a:prstGeom prst="roundRect">
+            <a:avLst>
+              <a:gd name="adj" fmla="val 12921"/>
+            </a:avLst>
+          </a:prstGeom>
+          <a:solidFill>
+            <a:srgbClr val="FFF0E7"/>
+          </a:solidFill>
+          <a:ln w="12700">
+            <a:solidFill>
+              <a:srgbClr val="D9E3DD"/>
+            </a:solidFill>
+            <a:prstDash val="solid"/>
+          </a:ln>
+          <a:effectLst>
+            <a:outerShdw sx="100000" sy="100000" kx="0" ky="0" algn="bl" rotWithShape="0" blurRad="52028928200000000" dist="104057856400000000" dir="583200000000000000000">
+              <a:srgbClr val="0A241C">
+                <a:alpha val="13000000000000000000"/>
+              </a:srgbClr>
+            </a:outerShdw>
+          </a:effectLst>
+        </p:spPr>
+      </p:sp>
+      <p:sp>
+        <p:nvSpPr>
+          <p:cNvPr id="14" name="Text 12"/>
+          <p:cNvSpPr/>
+          <p:nvPr/>
+        </p:nvSpPr>
+        <p:spPr>
+          <a:xfrm>
+            <a:off x="7571232" y="2212848"/>
+            <a:ext cx="1600200" cy="502920"/>
+          </a:xfrm>
+          <a:prstGeom prst="rect">
+            <a:avLst/>
+          </a:prstGeom>
+          <a:noFill/>
+          <a:ln/>
+        </p:spPr>
+        <p:txBody>
+          <a:bodyPr wrap="square" lIns="0" tIns="0" rIns="0" bIns="0" rtlCol="0" anchor="ctr">
+            <a:normAutofit/>
+          </a:bodyPr>
+          <a:lstStyle/>
+          <a:p>
+            <a:pPr algn="l" indent="0" marL="0">
+              <a:buNone/>
+            </a:pPr>
+            <a:r>
+              <a:rPr lang="en-US" sz="3100" b="1" dirty="0">
+                <a:solidFill>
+                  <a:srgbClr val="F97316"/>
+                </a:solidFill>
+                <a:latin typeface="Aptos Display" pitchFamily="34" charset="0"/>
+                <a:ea typeface="Aptos Display" pitchFamily="34" charset="-122"/>
+                <a:cs typeface="Aptos Display" pitchFamily="34" charset="-120"/>
+              </a:rPr>
+              <a:t>8–10%</a:t>
+            </a:r>
+            <a:endParaRPr lang="en-US" sz="3100" dirty="0"/>
+          </a:p>
+        </p:txBody>
+      </p:sp>
+      <p:sp>
+        <p:nvSpPr>
+          <p:cNvPr id="15" name="Text 13"/>
+          <p:cNvSpPr/>
+          <p:nvPr/>
+        </p:nvSpPr>
+        <p:spPr>
+          <a:xfrm>
+            <a:off x="9089136" y="2414016"/>
+            <a:ext cx="914400" cy="219456"/>
+          </a:xfrm>
+          <a:prstGeom prst="rect">
+            <a:avLst/>
+          </a:prstGeom>
+          <a:noFill/>
+          <a:ln/>
+        </p:spPr>
+        <p:txBody>
+          <a:bodyPr wrap="square" lIns="0" tIns="0" rIns="0" bIns="0" rtlCol="0" anchor="ctr">
+            <a:normAutofit/>
+          </a:bodyPr>
+          <a:lstStyle/>
+          <a:p>
+            <a:pPr algn="r" indent="0" marL="0">
+              <a:buNone/>
+            </a:pPr>
+            <a:r>
+              <a:rPr lang="en-US" sz="1000" b="1" dirty="0">
+                <a:solidFill>
+                  <a:srgbClr val="F97316"/>
+                </a:solidFill>
+                <a:latin typeface="Aptos" pitchFamily="34" charset="0"/>
+                <a:ea typeface="Aptos" pitchFamily="34" charset="-122"/>
+                <a:cs typeface="Aptos" pitchFamily="34" charset="-120"/>
+              </a:rPr>
+              <a:t>of GHGs</a:t>
+            </a:r>
+            <a:endParaRPr lang="en-US" sz="1000" dirty="0"/>
+          </a:p>
+        </p:txBody>
+      </p:sp>
+      <p:sp>
+        <p:nvSpPr>
+          <p:cNvPr id="16" name="Text 14"/>
+          <p:cNvSpPr/>
+          <p:nvPr/>
+        </p:nvSpPr>
+        <p:spPr>
+          <a:xfrm>
+            <a:off x="7571232" y="2852928"/>
+            <a:ext cx="2468880" cy="530352"/>
+          </a:xfrm>
+          <a:prstGeom prst="rect">
+            <a:avLst/>
+          </a:prstGeom>
+          <a:noFill/>
+          <a:ln/>
+        </p:spPr>
+        <p:txBody>
+          <a:bodyPr wrap="square" lIns="0" tIns="0" rIns="0" bIns="0" rtlCol="0" anchor="t">
+            <a:normAutofit/>
+          </a:bodyPr>
+          <a:lstStyle/>
+          <a:p>
+            <a:pPr algn="l" indent="0" marL="0">
+              <a:buNone/>
+            </a:pPr>
+            <a:r>
+              <a:rPr lang="en-US" sz="1050" dirty="0">
+                <a:solidFill>
+                  <a:srgbClr val="667D75"/>
+                </a:solidFill>
+                <a:latin typeface="Aptos" pitchFamily="34" charset="0"/>
+                <a:ea typeface="Aptos" pitchFamily="34" charset="-122"/>
+                <a:cs typeface="Aptos" pitchFamily="34" charset="-120"/>
+              </a:rPr>
+              <a:t>annual global emissions attributed to food loss and waste</a:t>
+            </a:r>
+            <a:endParaRPr lang="en-US" sz="1050" dirty="0"/>
+          </a:p>
+        </p:txBody>
+      </p:sp>
+      <p:sp>
+        <p:nvSpPr>
+          <p:cNvPr id="17" name="Shape 15"/>
+          <p:cNvSpPr/>
+          <p:nvPr/>
+        </p:nvSpPr>
+        <p:spPr>
+          <a:xfrm>
+            <a:off x="621792" y="3858768"/>
+            <a:ext cx="5349240" cy="1444752"/>
+          </a:xfrm>
+          <a:prstGeom prst="roundRect">
+            <a:avLst>
+              <a:gd name="adj" fmla="val 14557"/>
+            </a:avLst>
+          </a:prstGeom>
+          <a:solidFill>
+            <a:srgbClr val="173D31"/>
+          </a:solidFill>
+          <a:ln w="12700">
+            <a:solidFill>
+              <a:srgbClr val="173D31">
                 <a:alpha val="0"/>
               </a:srgbClr>
             </a:solidFill>
@@ -5053,158 +5231,368 @@
       </p:sp>
       <p:sp>
         <p:nvSpPr>
-          <p:cNvPr id="14" name="Text 12"/>
-          <p:cNvSpPr/>
-          <p:nvPr/>
-        </p:nvSpPr>
-        <p:spPr>
-          <a:xfrm>
-            <a:off x="4846320" y="2240280"/>
-            <a:ext cx="1956816" cy="292608"/>
-          </a:xfrm>
-          <a:prstGeom prst="rect">
-            <a:avLst/>
-          </a:prstGeom>
-          <a:noFill/>
-          <a:ln/>
-        </p:spPr>
-        <p:txBody>
-          <a:bodyPr wrap="square" lIns="0" tIns="0" rIns="0" bIns="0" rtlCol="0" anchor="ctr">
-            <a:normAutofit/>
-          </a:bodyPr>
-          <a:lstStyle/>
-          <a:p>
-            <a:pPr algn="ctr" indent="0" marL="0">
-              <a:buNone/>
-            </a:pPr>
-            <a:r>
-              <a:rPr lang="en-US" sz="900" b="1" dirty="0">
+          <p:cNvPr id="18" name="Text 16"/>
+          <p:cNvSpPr/>
+          <p:nvPr/>
+        </p:nvSpPr>
+        <p:spPr>
+          <a:xfrm>
+            <a:off x="914400" y="4114800"/>
+            <a:ext cx="1207008" cy="502920"/>
+          </a:xfrm>
+          <a:prstGeom prst="rect">
+            <a:avLst/>
+          </a:prstGeom>
+          <a:noFill/>
+          <a:ln/>
+        </p:spPr>
+        <p:txBody>
+          <a:bodyPr wrap="square" lIns="0" tIns="0" rIns="0" bIns="0" rtlCol="0" anchor="ctr">
+            <a:normAutofit/>
+          </a:bodyPr>
+          <a:lstStyle/>
+          <a:p>
+            <a:pPr algn="l" indent="0" marL="0">
+              <a:buNone/>
+            </a:pPr>
+            <a:r>
+              <a:rPr lang="en-US" sz="3100" b="1" dirty="0">
                 <a:solidFill>
                   <a:srgbClr val="BEF264"/>
-                </a:solidFill>
-                <a:latin typeface="Aptos" pitchFamily="34" charset="0"/>
-                <a:ea typeface="Aptos" pitchFamily="34" charset="-122"/>
-                <a:cs typeface="Aptos" pitchFamily="34" charset="-120"/>
-              </a:rPr>
-              <a:t>THE FRESHSAVER WINDOW</a:t>
-            </a:r>
-            <a:endParaRPr lang="en-US" sz="900" dirty="0"/>
-          </a:p>
-        </p:txBody>
-      </p:sp>
-      <p:sp>
-        <p:nvSpPr>
-          <p:cNvPr id="15" name="Text 13"/>
-          <p:cNvSpPr/>
-          <p:nvPr/>
-        </p:nvSpPr>
-        <p:spPr>
-          <a:xfrm>
-            <a:off x="4443984" y="2816352"/>
-            <a:ext cx="2743200" cy="1051560"/>
-          </a:xfrm>
-          <a:prstGeom prst="rect">
-            <a:avLst/>
-          </a:prstGeom>
-          <a:noFill/>
-          <a:ln/>
-        </p:spPr>
-        <p:txBody>
-          <a:bodyPr wrap="square" lIns="0" tIns="0" rIns="0" bIns="0" rtlCol="0" anchor="ctr">
-            <a:normAutofit/>
-          </a:bodyPr>
-          <a:lstStyle/>
-          <a:p>
-            <a:pPr algn="ctr" indent="0" marL="0">
-              <a:buNone/>
-            </a:pPr>
-            <a:r>
-              <a:rPr lang="en-US" sz="2600" b="1" dirty="0">
-                <a:solidFill>
-                  <a:srgbClr val="FFFFFF"/>
                 </a:solidFill>
                 <a:latin typeface="Aptos Display" pitchFamily="34" charset="0"/>
                 <a:ea typeface="Aptos Display" pitchFamily="34" charset="-122"/>
                 <a:cs typeface="Aptos Display" pitchFamily="34" charset="-120"/>
               </a:rPr>
-              <a:t>Act while the</a:t>
-            </a:r>
-            <a:endParaRPr lang="en-US" sz="2600" dirty="0"/>
-          </a:p>
+              <a:t>12%</a:t>
+            </a:r>
+            <a:endParaRPr lang="en-US" sz="3100" dirty="0"/>
+          </a:p>
+        </p:txBody>
+      </p:sp>
+      <p:sp>
+        <p:nvSpPr>
+          <p:cNvPr id="19" name="Text 17"/>
+          <p:cNvSpPr/>
+          <p:nvPr/>
+        </p:nvSpPr>
+        <p:spPr>
+          <a:xfrm>
+            <a:off x="2057400" y="4142232"/>
+            <a:ext cx="3401568" cy="292608"/>
+          </a:xfrm>
+          <a:prstGeom prst="rect">
+            <a:avLst/>
+          </a:prstGeom>
+          <a:noFill/>
+          <a:ln/>
+        </p:spPr>
+        <p:txBody>
+          <a:bodyPr wrap="square" lIns="0" tIns="0" rIns="0" bIns="0" rtlCol="0" anchor="ctr">
+            <a:normAutofit/>
+          </a:bodyPr>
+          <a:lstStyle/>
+          <a:p>
+            <a:pPr algn="l" indent="0" marL="0">
+              <a:buNone/>
+            </a:pPr>
+            <a:r>
+              <a:rPr lang="en-US" sz="1400" b="1" dirty="0">
+                <a:solidFill>
+                  <a:srgbClr val="FFFFFF"/>
+                </a:solidFill>
+                <a:latin typeface="Aptos" pitchFamily="34" charset="0"/>
+                <a:ea typeface="Aptos" pitchFamily="34" charset="-122"/>
+                <a:cs typeface="Aptos" pitchFamily="34" charset="-120"/>
+              </a:rPr>
+              <a:t>of 2022 food waste occurred at retail.</a:t>
+            </a:r>
+            <a:endParaRPr lang="en-US" sz="1400" dirty="0"/>
+          </a:p>
+        </p:txBody>
+      </p:sp>
+      <p:sp>
+        <p:nvSpPr>
+          <p:cNvPr id="20" name="Shape 18"/>
+          <p:cNvSpPr/>
+          <p:nvPr/>
+        </p:nvSpPr>
+        <p:spPr>
+          <a:xfrm>
+            <a:off x="914400" y="4718304"/>
+            <a:ext cx="868680" cy="292608"/>
+          </a:xfrm>
+          <a:prstGeom prst="roundRect">
+            <a:avLst>
+              <a:gd name="adj" fmla="val 50000"/>
+            </a:avLst>
+          </a:prstGeom>
+          <a:solidFill>
+            <a:srgbClr val="2B5548"/>
+          </a:solidFill>
+          <a:ln w="12700">
+            <a:solidFill>
+              <a:srgbClr val="2B5548">
+                <a:alpha val="0"/>
+              </a:srgbClr>
+            </a:solidFill>
+            <a:prstDash val="solid"/>
+          </a:ln>
+        </p:spPr>
+      </p:sp>
+      <p:sp>
+        <p:nvSpPr>
+          <p:cNvPr id="21" name="Text 19"/>
+          <p:cNvSpPr/>
+          <p:nvPr/>
+        </p:nvSpPr>
+        <p:spPr>
+          <a:xfrm>
+            <a:off x="987552" y="4718304"/>
+            <a:ext cx="722376" cy="292608"/>
+          </a:xfrm>
+          <a:prstGeom prst="rect">
+            <a:avLst/>
+          </a:prstGeom>
+          <a:noFill/>
+          <a:ln/>
+        </p:spPr>
+        <p:txBody>
+          <a:bodyPr wrap="square" lIns="0" tIns="0" rIns="0" bIns="0" rtlCol="0" anchor="ctr">
+            <a:normAutofit/>
+          </a:bodyPr>
+          <a:lstStyle/>
           <a:p>
             <a:pPr algn="ctr" indent="0" marL="0">
               <a:buNone/>
             </a:pPr>
             <a:r>
-              <a:rPr lang="en-US" sz="2600" b="1" dirty="0">
-                <a:solidFill>
-                  <a:srgbClr val="FFFFFF"/>
+              <a:rPr lang="en-US" sz="900" b="1" dirty="0">
+                <a:solidFill>
+                  <a:srgbClr val="BEF264"/>
+                </a:solidFill>
+                <a:latin typeface="Aptos" pitchFamily="34" charset="0"/>
+                <a:ea typeface="Aptos" pitchFamily="34" charset="-122"/>
+                <a:cs typeface="Aptos" pitchFamily="34" charset="-120"/>
+              </a:rPr>
+              <a:t>OUR WEDGE</a:t>
+            </a:r>
+            <a:endParaRPr lang="en-US" sz="900" dirty="0"/>
+          </a:p>
+        </p:txBody>
+      </p:sp>
+      <p:sp>
+        <p:nvSpPr>
+          <p:cNvPr id="22" name="Text 20"/>
+          <p:cNvSpPr/>
+          <p:nvPr/>
+        </p:nvSpPr>
+        <p:spPr>
+          <a:xfrm>
+            <a:off x="1965960" y="4690872"/>
+            <a:ext cx="3456432" cy="310896"/>
+          </a:xfrm>
+          <a:prstGeom prst="rect">
+            <a:avLst/>
+          </a:prstGeom>
+          <a:noFill/>
+          <a:ln/>
+        </p:spPr>
+        <p:txBody>
+          <a:bodyPr wrap="square" lIns="0" tIns="0" rIns="0" bIns="0" rtlCol="0" anchor="ctr">
+            <a:normAutofit/>
+          </a:bodyPr>
+          <a:lstStyle/>
+          <a:p>
+            <a:pPr algn="l" indent="0" marL="0">
+              <a:buNone/>
+            </a:pPr>
+            <a:r>
+              <a:rPr lang="en-US" sz="1050" dirty="0">
+                <a:solidFill>
+                  <a:srgbClr val="C5D7D0"/>
+                </a:solidFill>
+                <a:latin typeface="Aptos" pitchFamily="34" charset="0"/>
+                <a:ea typeface="Aptos" pitchFamily="34" charset="-122"/>
+                <a:cs typeface="Aptos" pitchFamily="34" charset="-120"/>
+              </a:rPr>
+              <a:t>Independent grocers making product-level decisions every day.</a:t>
+            </a:r>
+            <a:endParaRPr lang="en-US" sz="1050" dirty="0"/>
+          </a:p>
+        </p:txBody>
+      </p:sp>
+      <p:sp>
+        <p:nvSpPr>
+          <p:cNvPr id="23" name="Shape 21"/>
+          <p:cNvSpPr/>
+          <p:nvPr/>
+        </p:nvSpPr>
+        <p:spPr>
+          <a:xfrm>
+            <a:off x="6199632" y="3858768"/>
+            <a:ext cx="5330952" cy="1444752"/>
+          </a:xfrm>
+          <a:prstGeom prst="roundRect">
+            <a:avLst>
+              <a:gd name="adj" fmla="val 14557"/>
+            </a:avLst>
+          </a:prstGeom>
+          <a:solidFill>
+            <a:srgbClr val="FFFFFF"/>
+          </a:solidFill>
+          <a:ln w="12700">
+            <a:solidFill>
+              <a:srgbClr val="D9E3DD"/>
+            </a:solidFill>
+            <a:prstDash val="solid"/>
+          </a:ln>
+          <a:effectLst>
+            <a:outerShdw sx="100000" sy="100000" kx="0" ky="0" algn="bl" rotWithShape="0" blurRad="660767388140000000000" dist="1.32153477628e+21" dir="3.4992e+25">
+              <a:srgbClr val="0A241C">
+                <a:alpha val="1.3e+24"/>
+              </a:srgbClr>
+            </a:outerShdw>
+          </a:effectLst>
+        </p:spPr>
+      </p:sp>
+      <p:sp>
+        <p:nvSpPr>
+          <p:cNvPr id="24" name="Text 22"/>
+          <p:cNvSpPr/>
+          <p:nvPr/>
+        </p:nvSpPr>
+        <p:spPr>
+          <a:xfrm>
+            <a:off x="6492240" y="4096512"/>
+            <a:ext cx="1737360" cy="502920"/>
+          </a:xfrm>
+          <a:prstGeom prst="rect">
+            <a:avLst/>
+          </a:prstGeom>
+          <a:noFill/>
+          <a:ln/>
+        </p:spPr>
+        <p:txBody>
+          <a:bodyPr wrap="square" lIns="0" tIns="0" rIns="0" bIns="0" rtlCol="0" anchor="ctr">
+            <a:normAutofit/>
+          </a:bodyPr>
+          <a:lstStyle/>
+          <a:p>
+            <a:pPr algn="l" indent="0" marL="0">
+              <a:buNone/>
+            </a:pPr>
+            <a:r>
+              <a:rPr lang="en-US" sz="2800" b="1" dirty="0">
+                <a:solidFill>
+                  <a:srgbClr val="DC5B57"/>
                 </a:solidFill>
                 <a:latin typeface="Aptos Display" pitchFamily="34" charset="0"/>
                 <a:ea typeface="Aptos Display" pitchFamily="34" charset="-122"/>
                 <a:cs typeface="Aptos Display" pitchFamily="34" charset="-120"/>
               </a:rPr>
-              <a:t>decision still matters.</a:t>
-            </a:r>
-            <a:endParaRPr lang="en-US" sz="2600" dirty="0"/>
-          </a:p>
-        </p:txBody>
-      </p:sp>
-      <p:sp>
-        <p:nvSpPr>
-          <p:cNvPr id="16" name="Text 14"/>
-          <p:cNvSpPr/>
-          <p:nvPr/>
-        </p:nvSpPr>
-        <p:spPr>
-          <a:xfrm>
-            <a:off x="4462272" y="4096512"/>
-            <a:ext cx="2724912" cy="512064"/>
-          </a:xfrm>
-          <a:prstGeom prst="rect">
-            <a:avLst/>
-          </a:prstGeom>
-          <a:noFill/>
-          <a:ln/>
-        </p:spPr>
-        <p:txBody>
-          <a:bodyPr wrap="square" lIns="0" tIns="0" rIns="0" bIns="0" rtlCol="0" anchor="ctr">
-            <a:normAutofit/>
-          </a:bodyPr>
-          <a:lstStyle/>
-          <a:p>
-            <a:pPr algn="ctr" indent="0" marL="0">
-              <a:buNone/>
-            </a:pPr>
-            <a:r>
-              <a:rPr lang="en-US" sz="1200" dirty="0">
-                <a:solidFill>
-                  <a:srgbClr val="BED1CA"/>
-                </a:solidFill>
-                <a:latin typeface="Aptos" pitchFamily="34" charset="0"/>
-                <a:ea typeface="Aptos" pitchFamily="34" charset="-122"/>
-                <a:cs typeface="Aptos" pitchFamily="34" charset="-120"/>
-              </a:rPr>
-              <a:t>Stock + expiry + recent demand + unit economics</a:t>
-            </a:r>
-            <a:endParaRPr lang="en-US" sz="1200" dirty="0"/>
-          </a:p>
-        </p:txBody>
-      </p:sp>
-      <p:sp>
-        <p:nvSpPr>
-          <p:cNvPr id="17" name="Shape 15"/>
-          <p:cNvSpPr/>
-          <p:nvPr/>
-        </p:nvSpPr>
-        <p:spPr>
-          <a:xfrm>
-            <a:off x="4626864" y="4800600"/>
-            <a:ext cx="2395728" cy="384048"/>
+              <a:t>Up to 10%</a:t>
+            </a:r>
+            <a:endParaRPr lang="en-US" sz="2800" dirty="0"/>
+          </a:p>
+        </p:txBody>
+      </p:sp>
+      <p:sp>
+        <p:nvSpPr>
+          <p:cNvPr id="25" name="Text 23"/>
+          <p:cNvSpPr/>
+          <p:nvPr/>
+        </p:nvSpPr>
+        <p:spPr>
+          <a:xfrm>
+            <a:off x="8183880" y="4087368"/>
+            <a:ext cx="2834640" cy="438912"/>
+          </a:xfrm>
+          <a:prstGeom prst="rect">
+            <a:avLst/>
+          </a:prstGeom>
+          <a:noFill/>
+          <a:ln/>
+        </p:spPr>
+        <p:txBody>
+          <a:bodyPr wrap="square" lIns="0" tIns="0" rIns="0" bIns="0" rtlCol="0" anchor="ctr">
+            <a:normAutofit/>
+          </a:bodyPr>
+          <a:lstStyle/>
+          <a:p>
+            <a:pPr algn="l" indent="0" marL="0">
+              <a:buNone/>
+            </a:pPr>
+            <a:r>
+              <a:rPr lang="en-US" sz="1350" b="1" dirty="0">
+                <a:solidFill>
+                  <a:srgbClr val="15352C"/>
+                </a:solidFill>
+                <a:latin typeface="Aptos" pitchFamily="34" charset="0"/>
+                <a:ea typeface="Aptos" pitchFamily="34" charset="-122"/>
+                <a:cs typeface="Aptos" pitchFamily="34" charset="-120"/>
+              </a:rPr>
+              <a:t>of annual EU food waste is linked to date marking.</a:t>
+            </a:r>
+            <a:endParaRPr lang="en-US" sz="1350" dirty="0"/>
+          </a:p>
+        </p:txBody>
+      </p:sp>
+      <p:sp>
+        <p:nvSpPr>
+          <p:cNvPr id="26" name="Text 24"/>
+          <p:cNvSpPr/>
+          <p:nvPr/>
+        </p:nvSpPr>
+        <p:spPr>
+          <a:xfrm>
+            <a:off x="6510528" y="4782312"/>
+            <a:ext cx="4434840" cy="219456"/>
+          </a:xfrm>
+          <a:prstGeom prst="rect">
+            <a:avLst/>
+          </a:prstGeom>
+          <a:noFill/>
+          <a:ln/>
+        </p:spPr>
+        <p:txBody>
+          <a:bodyPr wrap="square" lIns="0" tIns="0" rIns="0" bIns="0" rtlCol="0" anchor="ctr">
+            <a:normAutofit/>
+          </a:bodyPr>
+          <a:lstStyle/>
+          <a:p>
+            <a:pPr algn="l" indent="0" marL="0">
+              <a:buNone/>
+            </a:pPr>
+            <a:r>
+              <a:rPr lang="en-US" sz="900" i="1" dirty="0">
+                <a:solidFill>
+                  <a:srgbClr val="667D75"/>
+                </a:solidFill>
+                <a:latin typeface="Aptos" pitchFamily="34" charset="0"/>
+                <a:ea typeface="Aptos" pitchFamily="34" charset="-122"/>
+                <a:cs typeface="Aptos" pitchFamily="34" charset="-120"/>
+              </a:rPr>
+              <a:t>European Commission estimate — not a global expiry-waste estimate.</a:t>
+            </a:r>
+            <a:endParaRPr lang="en-US" sz="900" dirty="0"/>
+          </a:p>
+        </p:txBody>
+      </p:sp>
+      <p:sp>
+        <p:nvSpPr>
+          <p:cNvPr id="27" name="Shape 25"/>
+          <p:cNvSpPr/>
+          <p:nvPr/>
+        </p:nvSpPr>
+        <p:spPr>
+          <a:xfrm>
+            <a:off x="1024128" y="5577840"/>
+            <a:ext cx="10149840" cy="393192"/>
           </a:xfrm>
           <a:prstGeom prst="roundRect">
             <a:avLst>
-              <a:gd name="adj" fmla="val 33333"/>
+              <a:gd name="adj" fmla="val 32558"/>
             </a:avLst>
           </a:prstGeom>
           <a:solidFill>
@@ -5222,14 +5610,14 @@
       </p:sp>
       <p:sp>
         <p:nvSpPr>
-          <p:cNvPr id="18" name="Text 16"/>
-          <p:cNvSpPr/>
-          <p:nvPr/>
-        </p:nvSpPr>
-        <p:spPr>
-          <a:xfrm>
-            <a:off x="4736592" y="4800600"/>
-            <a:ext cx="2176272" cy="384048"/>
+          <p:cNvPr id="28" name="Text 26"/>
+          <p:cNvSpPr/>
+          <p:nvPr/>
+        </p:nvSpPr>
+        <p:spPr>
+          <a:xfrm>
+            <a:off x="1261872" y="5577840"/>
+            <a:ext cx="9674352" cy="393192"/>
           </a:xfrm>
           <a:prstGeom prst="rect">
             <a:avLst/>
@@ -5247,7 +5635,7 @@
               <a:buNone/>
             </a:pPr>
             <a:r>
-              <a:rPr lang="en-US" sz="900" b="1" spc="100" kern="0" dirty="0">
+              <a:rPr lang="en-US" sz="1200" b="1" dirty="0">
                 <a:solidFill>
                   <a:srgbClr val="173D31"/>
                 </a:solidFill>
@@ -5255,385 +5643,121 @@
                 <a:ea typeface="Aptos" pitchFamily="34" charset="-122"/>
                 <a:cs typeface="Aptos" pitchFamily="34" charset="-120"/>
               </a:rPr>
-              <a:t>REVIEWABLE ACTION</a:t>
-            </a:r>
-            <a:endParaRPr lang="en-US" sz="900" dirty="0"/>
-          </a:p>
-        </p:txBody>
-      </p:sp>
-      <p:sp>
-        <p:nvSpPr>
-          <p:cNvPr id="19" name="Shape 17"/>
-          <p:cNvSpPr/>
-          <p:nvPr/>
-        </p:nvSpPr>
-        <p:spPr>
-          <a:xfrm>
-            <a:off x="7909560" y="2103120"/>
-            <a:ext cx="3611880" cy="3246120"/>
-          </a:xfrm>
-          <a:prstGeom prst="roundRect">
-            <a:avLst>
-              <a:gd name="adj" fmla="val 7042"/>
-            </a:avLst>
-          </a:prstGeom>
-          <a:solidFill>
-            <a:srgbClr val="FDECEC"/>
-          </a:solidFill>
-          <a:ln w="12700">
-            <a:solidFill>
-              <a:srgbClr val="FDECEC">
-                <a:alpha val="0"/>
-              </a:srgbClr>
-            </a:solidFill>
-            <a:prstDash val="solid"/>
-          </a:ln>
-        </p:spPr>
-      </p:sp>
-      <p:sp>
-        <p:nvSpPr>
-          <p:cNvPr id="20" name="Shape 18"/>
-          <p:cNvSpPr/>
-          <p:nvPr/>
-        </p:nvSpPr>
-        <p:spPr>
-          <a:xfrm>
-            <a:off x="8183880" y="2395728"/>
-            <a:ext cx="438912" cy="438912"/>
-          </a:xfrm>
-          <a:prstGeom prst="ellipse">
-            <a:avLst/>
-          </a:prstGeom>
-          <a:solidFill>
-            <a:srgbClr val="DC5B57"/>
-          </a:solidFill>
-          <a:ln w="12700">
-            <a:solidFill>
-              <a:srgbClr val="DC5B57"/>
-            </a:solidFill>
-            <a:prstDash val="solid"/>
-          </a:ln>
-        </p:spPr>
-      </p:sp>
-      <p:sp>
-        <p:nvSpPr>
-          <p:cNvPr id="21" name="Text 19"/>
-          <p:cNvSpPr/>
-          <p:nvPr/>
-        </p:nvSpPr>
-        <p:spPr>
-          <a:xfrm>
-            <a:off x="8183880" y="2395728"/>
-            <a:ext cx="438912" cy="438912"/>
-          </a:xfrm>
-          <a:prstGeom prst="rect">
-            <a:avLst/>
-          </a:prstGeom>
-          <a:noFill/>
-          <a:ln/>
-        </p:spPr>
-        <p:txBody>
-          <a:bodyPr wrap="square" lIns="0" tIns="0" rIns="0" bIns="0" rtlCol="0" anchor="ctr">
-            <a:normAutofit/>
-          </a:bodyPr>
-          <a:lstStyle/>
-          <a:p>
-            <a:pPr algn="ctr" indent="0" marL="0">
-              <a:buNone/>
-            </a:pPr>
-            <a:r>
-              <a:rPr lang="en-US" sz="1400" b="1" dirty="0">
-                <a:solidFill>
-                  <a:srgbClr val="FFFFFF"/>
-                </a:solidFill>
-                <a:latin typeface="Aptos" pitchFamily="34" charset="0"/>
-                <a:ea typeface="Aptos" pitchFamily="34" charset="-122"/>
-                <a:cs typeface="Aptos" pitchFamily="34" charset="-120"/>
-              </a:rPr>
-              <a:t>!</a:t>
-            </a:r>
-            <a:endParaRPr lang="en-US" sz="1400" dirty="0"/>
-          </a:p>
-        </p:txBody>
-      </p:sp>
-      <p:sp>
-        <p:nvSpPr>
-          <p:cNvPr id="22" name="Text 20"/>
-          <p:cNvSpPr/>
-          <p:nvPr/>
-        </p:nvSpPr>
-        <p:spPr>
-          <a:xfrm>
-            <a:off x="8183880" y="2999232"/>
-            <a:ext cx="2423160" cy="384048"/>
-          </a:xfrm>
-          <a:prstGeom prst="rect">
-            <a:avLst/>
-          </a:prstGeom>
-          <a:noFill/>
-          <a:ln/>
-        </p:spPr>
-        <p:txBody>
-          <a:bodyPr wrap="square" lIns="0" tIns="0" rIns="0" bIns="0" rtlCol="0" anchor="ctr">
-            <a:normAutofit/>
-          </a:bodyPr>
-          <a:lstStyle/>
-          <a:p>
-            <a:pPr algn="l" indent="0" marL="0">
-              <a:buNone/>
-            </a:pPr>
-            <a:r>
-              <a:rPr lang="en-US" sz="2200" b="1" dirty="0">
-                <a:solidFill>
-                  <a:srgbClr val="DC5B57"/>
-                </a:solidFill>
-                <a:latin typeface="Aptos Display" pitchFamily="34" charset="0"/>
-                <a:ea typeface="Aptos Display" pitchFamily="34" charset="-122"/>
-                <a:cs typeface="Aptos Display" pitchFamily="34" charset="-120"/>
-              </a:rPr>
-              <a:t>Wait too long</a:t>
-            </a:r>
-            <a:endParaRPr lang="en-US" sz="2200" dirty="0"/>
-          </a:p>
-        </p:txBody>
-      </p:sp>
-      <p:sp>
-        <p:nvSpPr>
-          <p:cNvPr id="23" name="Text 21"/>
-          <p:cNvSpPr/>
-          <p:nvPr/>
-        </p:nvSpPr>
-        <p:spPr>
-          <a:xfrm>
-            <a:off x="8183880" y="3566160"/>
-            <a:ext cx="2788920" cy="777240"/>
-          </a:xfrm>
-          <a:prstGeom prst="rect">
-            <a:avLst/>
-          </a:prstGeom>
-          <a:noFill/>
-          <a:ln/>
-        </p:spPr>
-        <p:txBody>
-          <a:bodyPr wrap="square" lIns="0" tIns="0" rIns="0" bIns="0" rtlCol="0" anchor="t">
-            <a:normAutofit/>
-          </a:bodyPr>
-          <a:lstStyle/>
-          <a:p>
-            <a:pPr algn="l" indent="0" marL="0">
-              <a:buNone/>
-            </a:pPr>
-            <a:r>
-              <a:rPr lang="en-US" sz="1300" dirty="0">
-                <a:solidFill>
-                  <a:srgbClr val="8C4542"/>
-                </a:solidFill>
-                <a:latin typeface="Aptos" pitchFamily="34" charset="0"/>
-                <a:ea typeface="Aptos" pitchFamily="34" charset="-122"/>
-                <a:cs typeface="Aptos" pitchFamily="34" charset="-120"/>
-              </a:rPr>
-              <a:t>Slow-moving stock reaches the end of its shelf life before the offer reaches a buyer.</a:t>
-            </a:r>
-            <a:endParaRPr lang="en-US" sz="1300" dirty="0"/>
-          </a:p>
-        </p:txBody>
-      </p:sp>
-      <p:sp>
-        <p:nvSpPr>
-          <p:cNvPr id="24" name="Text 22"/>
-          <p:cNvSpPr/>
-          <p:nvPr/>
-        </p:nvSpPr>
-        <p:spPr>
-          <a:xfrm>
-            <a:off x="8183880" y="4617720"/>
-            <a:ext cx="548640" cy="201168"/>
-          </a:xfrm>
-          <a:prstGeom prst="rect">
-            <a:avLst/>
-          </a:prstGeom>
-          <a:noFill/>
-          <a:ln/>
-        </p:spPr>
-        <p:txBody>
-          <a:bodyPr wrap="square" lIns="0" tIns="0" rIns="0" bIns="0" rtlCol="0" anchor="ctr">
-            <a:normAutofit/>
-          </a:bodyPr>
-          <a:lstStyle/>
-          <a:p>
-            <a:pPr algn="l" indent="0" marL="0">
-              <a:buNone/>
-            </a:pPr>
-            <a:r>
-              <a:rPr lang="en-US" sz="900" b="1" spc="100" kern="0" dirty="0">
-                <a:solidFill>
-                  <a:srgbClr val="DC5B57"/>
-                </a:solidFill>
-                <a:latin typeface="Aptos" pitchFamily="34" charset="0"/>
-                <a:ea typeface="Aptos" pitchFamily="34" charset="-122"/>
-                <a:cs typeface="Aptos" pitchFamily="34" charset="-120"/>
-              </a:rPr>
-              <a:t>Result</a:t>
-            </a:r>
-            <a:endParaRPr lang="en-US" sz="900" dirty="0"/>
-          </a:p>
-        </p:txBody>
-      </p:sp>
-      <p:sp>
-        <p:nvSpPr>
-          <p:cNvPr id="25" name="Text 23"/>
-          <p:cNvSpPr/>
-          <p:nvPr/>
-        </p:nvSpPr>
-        <p:spPr>
-          <a:xfrm>
-            <a:off x="8183880" y="4873752"/>
-            <a:ext cx="2194560" cy="274320"/>
-          </a:xfrm>
-          <a:prstGeom prst="rect">
-            <a:avLst/>
-          </a:prstGeom>
-          <a:noFill/>
-          <a:ln/>
-        </p:spPr>
-        <p:txBody>
-          <a:bodyPr wrap="square" lIns="0" tIns="0" rIns="0" bIns="0" rtlCol="0" anchor="ctr">
-            <a:normAutofit/>
-          </a:bodyPr>
-          <a:lstStyle/>
-          <a:p>
-            <a:pPr algn="l" indent="0" marL="0">
-              <a:buNone/>
-            </a:pPr>
-            <a:r>
-              <a:rPr lang="en-US" sz="1600" b="1" dirty="0">
-                <a:solidFill>
-                  <a:srgbClr val="DC5B57"/>
-                </a:solidFill>
-                <a:latin typeface="Aptos" pitchFamily="34" charset="0"/>
-                <a:ea typeface="Aptos" pitchFamily="34" charset="-122"/>
-                <a:cs typeface="Aptos" pitchFamily="34" charset="-120"/>
-              </a:rPr>
-              <a:t>Avoidable waste</a:t>
-            </a:r>
-            <a:endParaRPr lang="en-US" sz="1600" dirty="0"/>
-          </a:p>
-        </p:txBody>
-      </p:sp>
-      <p:sp>
-        <p:nvSpPr>
-          <p:cNvPr id="26" name="Shape 24"/>
-          <p:cNvSpPr/>
-          <p:nvPr/>
-        </p:nvSpPr>
-        <p:spPr>
-          <a:xfrm>
-            <a:off x="658368" y="5806440"/>
-            <a:ext cx="960120" cy="292608"/>
-          </a:xfrm>
-          <a:prstGeom prst="roundRect">
-            <a:avLst>
-              <a:gd name="adj" fmla="val 50000"/>
-            </a:avLst>
-          </a:prstGeom>
-          <a:solidFill>
-            <a:srgbClr val="DDF7E8"/>
-          </a:solidFill>
-          <a:ln w="12700">
-            <a:solidFill>
-              <a:srgbClr val="DDF7E8">
-                <a:alpha val="0"/>
-              </a:srgbClr>
-            </a:solidFill>
-            <a:prstDash val="solid"/>
-          </a:ln>
-        </p:spPr>
-      </p:sp>
-      <p:sp>
-        <p:nvSpPr>
-          <p:cNvPr id="27" name="Text 25"/>
-          <p:cNvSpPr/>
-          <p:nvPr/>
-        </p:nvSpPr>
-        <p:spPr>
-          <a:xfrm>
-            <a:off x="731520" y="5806440"/>
-            <a:ext cx="813816" cy="292608"/>
-          </a:xfrm>
-          <a:prstGeom prst="rect">
-            <a:avLst/>
-          </a:prstGeom>
-          <a:noFill/>
-          <a:ln/>
-        </p:spPr>
-        <p:txBody>
-          <a:bodyPr wrap="square" lIns="0" tIns="0" rIns="0" bIns="0" rtlCol="0" anchor="ctr">
-            <a:normAutofit/>
-          </a:bodyPr>
-          <a:lstStyle/>
-          <a:p>
-            <a:pPr algn="ctr" indent="0" marL="0">
-              <a:buNone/>
-            </a:pPr>
-            <a:r>
-              <a:rPr lang="en-US" sz="900" b="1" dirty="0">
-                <a:solidFill>
-                  <a:srgbClr val="10B981"/>
-                </a:solidFill>
-                <a:latin typeface="Aptos" pitchFamily="34" charset="0"/>
-                <a:ea typeface="Aptos" pitchFamily="34" charset="-122"/>
-                <a:cs typeface="Aptos" pitchFamily="34" charset="-120"/>
-              </a:rPr>
-              <a:t>TARGET USER</a:t>
-            </a:r>
-            <a:endParaRPr lang="en-US" sz="900" dirty="0"/>
-          </a:p>
-        </p:txBody>
-      </p:sp>
-      <p:sp>
-        <p:nvSpPr>
-          <p:cNvPr id="28" name="Text 26"/>
-          <p:cNvSpPr/>
-          <p:nvPr/>
-        </p:nvSpPr>
-        <p:spPr>
-          <a:xfrm>
-            <a:off x="1783080" y="5797296"/>
-            <a:ext cx="8092440" cy="292608"/>
-          </a:xfrm>
-          <a:prstGeom prst="rect">
-            <a:avLst/>
-          </a:prstGeom>
-          <a:noFill/>
-          <a:ln/>
-        </p:spPr>
-        <p:txBody>
-          <a:bodyPr wrap="square" lIns="0" tIns="0" rIns="0" bIns="0" rtlCol="0" anchor="ctr">
-            <a:normAutofit/>
-          </a:bodyPr>
-          <a:lstStyle/>
-          <a:p>
-            <a:pPr algn="l" indent="0" marL="0">
-              <a:buNone/>
-            </a:pPr>
-            <a:r>
-              <a:rPr lang="en-US" sz="1150" b="1" dirty="0">
-                <a:solidFill>
-                  <a:srgbClr val="15352C"/>
-                </a:solidFill>
-                <a:latin typeface="Aptos" pitchFamily="34" charset="0"/>
-                <a:ea typeface="Aptos" pitchFamily="34" charset="-122"/>
-                <a:cs typeface="Aptos" pitchFamily="34" charset="-120"/>
-              </a:rPr>
-              <a:t>Independent grocers who already export inventory — no new shelf hardware required.</a:t>
-            </a:r>
-            <a:endParaRPr lang="en-US" sz="1150" dirty="0"/>
-          </a:p>
-        </p:txBody>
-      </p:sp>
-      <p:sp>
-        <p:nvSpPr>
-          <p:cNvPr id="29" name="Shape 27"/>
+              <a:t>For one grocer, this becomes a recurring question: hold, markdown, or lose the stock?</a:t>
+            </a:r>
+            <a:endParaRPr lang="en-US" sz="1200" dirty="0"/>
+          </a:p>
+        </p:txBody>
+      </p:sp>
+      <p:sp>
+        <p:nvSpPr>
+          <p:cNvPr id="29" name="Text 27"/>
+          <p:cNvSpPr/>
+          <p:nvPr/>
+        </p:nvSpPr>
+        <p:spPr>
+          <a:xfrm>
+            <a:off x="658368" y="6126480"/>
+            <a:ext cx="5166360" cy="164592"/>
+          </a:xfrm>
+          <a:prstGeom prst="rect">
+            <a:avLst/>
+          </a:prstGeom>
+          <a:noFill/>
+          <a:ln/>
+        </p:spPr>
+        <p:txBody>
+          <a:bodyPr wrap="square" lIns="0" tIns="0" rIns="0" bIns="0" rtlCol="0" anchor="ctr">
+            <a:normAutofit/>
+          </a:bodyPr>
+          <a:lstStyle/>
+          <a:p>
+            <a:pPr algn="l" indent="0" marL="0">
+              <a:buNone/>
+            </a:pPr>
+            <a:r>
+              <a:rPr lang="en-US" sz="750" b="1" u="sng" dirty="0">
+                <a:solidFill>
+                  <a:srgbClr val="667D75"/>
+                </a:solidFill>
+                <a:uFill>
+                  <a:solidFill>
+                    <a:srgbClr val="667D75"/>
+                  </a:solidFill>
+                </a:uFill>
+                <a:latin typeface="Aptos" pitchFamily="34" charset="0"/>
+                <a:ea typeface="Aptos" pitchFamily="34" charset="-122"/>
+                <a:cs typeface="Aptos" pitchFamily="34" charset="-120"/>
+                <a:hlinkClick r:id="rId1" invalidUrl="" action="" tgtFrame="" tooltip="" history="1" highlightClick="0" endSnd="0">
+                  <a:extLst>
+                    <a:ext uri="{A12FA001-AC4F-418D-AE19-62706E023703}">
+                      <ahyp:hlinkClr xmlns:ahyp="http://schemas.microsoft.com/office/drawing/2018/hyperlinkcolor" val="tx"/>
+                    </a:ext>
+                  </a:extLst>
+                </a:hlinkClick>
+              </a:rPr>
+              <a:t>Source: UNEP Food Waste Index Report 2024 (2022 data)</a:t>
+            </a:r>
+            <a:endParaRPr lang="en-US" sz="750" dirty="0"/>
+          </a:p>
+        </p:txBody>
+      </p:sp>
+      <p:sp>
+        <p:nvSpPr>
+          <p:cNvPr id="30" name="Text 28"/>
+          <p:cNvSpPr/>
+          <p:nvPr/>
+        </p:nvSpPr>
+        <p:spPr>
+          <a:xfrm>
+            <a:off x="6419088" y="6126480"/>
+            <a:ext cx="4572000" cy="164592"/>
+          </a:xfrm>
+          <a:prstGeom prst="rect">
+            <a:avLst/>
+          </a:prstGeom>
+          <a:noFill/>
+          <a:ln/>
+        </p:spPr>
+        <p:txBody>
+          <a:bodyPr wrap="square" lIns="0" tIns="0" rIns="0" bIns="0" rtlCol="0" anchor="ctr">
+            <a:normAutofit/>
+          </a:bodyPr>
+          <a:lstStyle/>
+          <a:p>
+            <a:pPr algn="r" indent="0" marL="0">
+              <a:buNone/>
+            </a:pPr>
+            <a:r>
+              <a:rPr lang="en-US" sz="750" b="1" u="sng" dirty="0">
+                <a:solidFill>
+                  <a:srgbClr val="667D75"/>
+                </a:solidFill>
+                <a:uFill>
+                  <a:solidFill>
+                    <a:srgbClr val="667D75"/>
+                  </a:solidFill>
+                </a:uFill>
+                <a:latin typeface="Aptos" pitchFamily="34" charset="0"/>
+                <a:ea typeface="Aptos" pitchFamily="34" charset="-122"/>
+                <a:cs typeface="Aptos" pitchFamily="34" charset="-120"/>
+                <a:hlinkClick r:id="rId2" invalidUrl="" action="" tgtFrame="" tooltip="" history="1" highlightClick="0" endSnd="0">
+                  <a:extLst>
+                    <a:ext uri="{A12FA001-AC4F-418D-AE19-62706E023703}">
+                      <ahyp:hlinkClr xmlns:ahyp="http://schemas.microsoft.com/office/drawing/2018/hyperlinkcolor" val="tx"/>
+                    </a:ext>
+                  </a:extLst>
+                </a:hlinkClick>
+              </a:rPr>
+              <a:t>Source: European Commission date-marking study (2018)</a:t>
+            </a:r>
+            <a:endParaRPr lang="en-US" sz="750" dirty="0"/>
+          </a:p>
+        </p:txBody>
+      </p:sp>
+      <p:sp>
+        <p:nvSpPr>
+          <p:cNvPr id="31" name="Shape 29"/>
           <p:cNvSpPr/>
           <p:nvPr/>
         </p:nvSpPr>
@@ -5656,7 +5780,7 @@
       </p:sp>
       <p:sp>
         <p:nvSpPr>
-          <p:cNvPr id="30" name="Text 28"/>
+          <p:cNvPr id="32" name="Text 30"/>
           <p:cNvSpPr/>
           <p:nvPr/>
         </p:nvSpPr>
@@ -5697,7 +5821,7 @@
       </p:sp>
       <p:sp>
         <p:nvSpPr>
-          <p:cNvPr id="31" name="Text 29"/>
+          <p:cNvPr id="33" name="Text 31"/>
           <p:cNvSpPr/>
           <p:nvPr/>
         </p:nvSpPr>
@@ -5730,7 +5854,7 @@
                 <a:ea typeface="Aptos" pitchFamily="34" charset="-122"/>
                 <a:cs typeface="Aptos" pitchFamily="34" charset="-120"/>
               </a:rPr>
-              <a:t>Problem solving &amp; impact</a:t>
+              <a:t>Problem statement · sourced global scale and local wedge</a:t>
             </a:r>
             <a:endParaRPr lang="en-US" sz="750" dirty="0"/>
           </a:p>
@@ -6446,9 +6570,9 @@
             <a:prstDash val="solid"/>
           </a:ln>
           <a:effectLst>
-            <a:outerShdw sx="100000" sy="100000" kx="0" ky="0" algn="bl" rotWithShape="0" blurRad="4096766000000" dist="8193532000000" dir="9720000000000000">
+            <a:outerShdw sx="100000" sy="100000" kx="0" ky="0" algn="bl" rotWithShape="0" blurRad="8.391745829378e+24" dist="1.6783491658756e+25" dir="2.09952e+30">
               <a:srgbClr val="0A241C">
-                <a:alpha val="130000000000000"/>
+                <a:alpha val="1.3e+29"/>
               </a:srgbClr>
             </a:outerShdw>
           </a:effectLst>
@@ -6696,9 +6820,9 @@
             <a:prstDash val="solid"/>
           </a:ln>
           <a:effectLst>
-            <a:outerShdw sx="100000" sy="100000" kx="0" ky="0" algn="bl" rotWithShape="0" blurRad="52028928200000000" dist="104057856400000000" dir="583200000000000000000">
+            <a:outerShdw sx="100000" sy="100000" kx="0" ky="0" algn="bl" rotWithShape="0" blurRad="1.0657517203310059e+29" dist="2.1315034406620118e+29" dir="1.259712e+35">
               <a:srgbClr val="0A241C">
-                <a:alpha val="13000000000000000000"/>
+                <a:alpha val="1.3e+34"/>
               </a:srgbClr>
             </a:outerShdw>
           </a:effectLst>
@@ -7922,9 +8046,9 @@
             <a:prstDash val="solid"/>
           </a:ln>
           <a:effectLst>
-            <a:outerShdw sx="100000" sy="100000" kx="0" ky="0" algn="bl" rotWithShape="0" blurRad="660767388140000000000" dist="1.32153477628e+21" dir="3.4992e+25">
+            <a:outerShdw sx="100000" sy="100000" kx="0" ky="0" algn="bl" rotWithShape="0" blurRad="1.3535046848203775e+33" dist="2.707009369640755e+33" dir="7.558272e+39">
               <a:srgbClr val="0A241C">
-                <a:alpha val="1.3e+24"/>
+                <a:alpha val="1.3e+39"/>
               </a:srgbClr>
             </a:outerShdw>
           </a:effectLst>
@@ -9073,9 +9197,9 @@
             <a:prstDash val="solid"/>
           </a:ln>
           <a:effectLst>
-            <a:outerShdw sx="100000" sy="100000" kx="0" ky="0" algn="bl" rotWithShape="0" blurRad="8.391745829378e+24" dist="1.6783491658756e+25" dir="2.09952e+30">
+            <a:outerShdw sx="100000" sy="100000" kx="0" ky="0" algn="bl" rotWithShape="0" blurRad="1.7189509497218795e+37" dist="3.437901899443759e+37" dir="4.5349632000000006e+44">
               <a:srgbClr val="0A241C">
-                <a:alpha val="1.3e+29"/>
+                <a:alpha val="1.3e+44"/>
               </a:srgbClr>
             </a:outerShdw>
           </a:effectLst>
@@ -11487,9 +11611,9 @@
             <a:prstDash val="solid"/>
           </a:ln>
           <a:effectLst>
-            <a:outerShdw sx="100000" sy="100000" kx="0" ky="0" algn="bl" rotWithShape="0" blurRad="1.0657517203310059e+29" dist="2.1315034406620118e+29" dir="1.259712e+35">
+            <a:outerShdw sx="100000" sy="100000" kx="0" ky="0" algn="bl" rotWithShape="0" blurRad="2.183067706146787e+41" dist="4.366135412293574e+41" dir="2.72097792e+49">
               <a:srgbClr val="0A241C">
-                <a:alpha val="1.3e+34"/>
+                <a:alpha val="1.3e+49"/>
               </a:srgbClr>
             </a:outerShdw>
           </a:effectLst>
@@ -12113,9 +12237,9 @@
             <a:prstDash val="solid"/>
           </a:ln>
           <a:effectLst>
-            <a:outerShdw sx="100000" sy="100000" kx="0" ky="0" algn="bl" rotWithShape="0" blurRad="1.3535046848203775e+33" dist="2.707009369640755e+33" dir="7.558272e+39">
+            <a:outerShdw sx="100000" sy="100000" kx="0" ky="0" algn="bl" rotWithShape="0" blurRad="2.7724959868064195e+45" dist="5.544991973612839e+45" dir="1.6325867520000003e+54">
               <a:srgbClr val="0A241C">
-                <a:alpha val="1.3e+39"/>
+                <a:alpha val="1.2999999999999999e+54"/>
               </a:srgbClr>
             </a:outerShdw>
           </a:effectLst>
@@ -13082,9 +13206,9 @@
             <a:prstDash val="solid"/>
           </a:ln>
           <a:effectLst>
-            <a:outerShdw sx="100000" sy="100000" kx="0" ky="0" algn="bl" rotWithShape="0" blurRad="1.7189509497218795e+37" dist="3.437901899443759e+37" dir="4.5349632000000006e+44">
+            <a:outerShdw sx="100000" sy="100000" kx="0" ky="0" algn="bl" rotWithShape="0" blurRad="3.5210699032441527e+49" dist="7.042139806488305e+49" dir="9.795520512000002e+58">
               <a:srgbClr val="0A241C">
-                <a:alpha val="1.3e+44"/>
+                <a:alpha val="1.2999999999999998e+59"/>
               </a:srgbClr>
             </a:outerShdw>
           </a:effectLst>
@@ -18264,9 +18388,9 @@
             <a:prstDash val="solid"/>
           </a:ln>
           <a:effectLst>
-            <a:outerShdw sx="100000" sy="100000" kx="0" ky="0" algn="bl" rotWithShape="0" blurRad="2.183067706146787e+41" dist="4.366135412293574e+41" dir="2.72097792e+49">
+            <a:outerShdw sx="100000" sy="100000" kx="0" ky="0" algn="bl" rotWithShape="0" blurRad="4.471758777120074e+53" dist="8.943517554240149e+53" dir="5.877312307200001e+63">
               <a:srgbClr val="0A241C">
-                <a:alpha val="1.3e+49"/>
+                <a:alpha val="1.2999999999999998e+64"/>
               </a:srgbClr>
             </a:outerShdw>
           </a:effectLst>
@@ -18796,9 +18920,9 @@
             <a:prstDash val="solid"/>
           </a:ln>
           <a:effectLst>
-            <a:outerShdw sx="100000" sy="100000" kx="0" ky="0" algn="bl" rotWithShape="0" blurRad="2.7724959868064195e+45" dist="5.544991973612839e+45" dir="1.6325867520000003e+54">
+            <a:outerShdw sx="100000" sy="100000" kx="0" ky="0" algn="bl" rotWithShape="0" blurRad="5.679133646942494e+57" dist="1.1358267293884988e+58" dir="3.526387384320001e+68">
               <a:srgbClr val="0A241C">
-                <a:alpha val="1.2999999999999999e+54"/>
+                <a:alpha val="1.2999999999999999e+69"/>
               </a:srgbClr>
             </a:outerShdw>
           </a:effectLst>

</xml_diff>

<commit_message>
docs: add food-waste cover to presentation
</commit_message>
<xml_diff>
--- a/docs/deck/FreshSaver-AI-Builders-Hackathon.pptx
+++ b/docs/deck/FreshSaver-AI-Builders-Hackathon.pptx
@@ -511,7 +511,7 @@
           <a:p>
             <a:r>
               <a:rPr lang="en-US" dirty="0"/>
-              <a:t>Open as a story: It is closing time. A neighborhood grocer has 18 cartons of milk and four days left. Discount too deeply and margin disappears; wait too long and the product may be lost. FreshSaver turns that recurring shelf decision into a reviewable intervention.</a:t>
+              <a:t>Open as a story: food can move from sellable inventory to a supermarket waste container because the intervention came too late. FreshSaver gives the owner an evidence-based action while the product still has value. Image: “Supermarket dumpster” by KVDP, public domain, Wikimedia Commons: https://commons.wikimedia.org/wiki/File:Supermarket_dumpster.jpg</a:t>
             </a:r>
             <a:endParaRPr lang="en-US" dirty="0"/>
           </a:p>
@@ -2156,7 +2156,7 @@
                 <a:ea typeface="Aptos Display" pitchFamily="34" charset="-122"/>
                 <a:cs typeface="Aptos Display" pitchFamily="34" charset="-120"/>
               </a:rPr>
-              <a:t>At closing time,</a:t>
+              <a:t>Fresh today.</a:t>
             </a:r>
             <a:endParaRPr lang="en-US" sz="3700" dirty="0"/>
           </a:p>
@@ -2173,7 +2173,7 @@
                 <a:ea typeface="Aptos Display" pitchFamily="34" charset="-122"/>
                 <a:cs typeface="Aptos Display" pitchFamily="34" charset="-120"/>
               </a:rPr>
-              <a:t>18 cartons still</a:t>
+              <a:t>Expired tomorrow.</a:t>
             </a:r>
             <a:endParaRPr lang="en-US" sz="3700" dirty="0"/>
           </a:p>
@@ -2190,7 +2190,7 @@
                 <a:ea typeface="Aptos Display" pitchFamily="34" charset="-122"/>
                 <a:cs typeface="Aptos Display" pitchFamily="34" charset="-120"/>
               </a:rPr>
-              <a:t>have value.</a:t>
+              <a:t>Wasted forever.</a:t>
             </a:r>
             <a:endParaRPr lang="en-US" sz="3700" dirty="0"/>
           </a:p>
@@ -2205,7 +2205,7 @@
         <p:spPr>
           <a:xfrm>
             <a:off x="658368" y="4407408"/>
-            <a:ext cx="5074920" cy="713232"/>
+            <a:ext cx="5138928" cy="713232"/>
           </a:xfrm>
           <a:prstGeom prst="rect">
             <a:avLst/>
@@ -2231,140 +2231,74 @@
                 <a:ea typeface="Aptos" pitchFamily="34" charset="-122"/>
                 <a:cs typeface="Aptos" pitchFamily="34" charset="-120"/>
               </a:rPr>
-              <a:t>FreshSaver helps a grocer choose the right intervention before good food becomes waste.</a:t>
+              <a:t>FreshSaver gives a grocer one more chance to protect margin and find a buyer before the expiry clock runs out.</a:t>
             </a:r>
             <a:endParaRPr lang="en-US" sz="1500" dirty="0"/>
           </a:p>
         </p:txBody>
       </p:sp>
-      <p:sp>
-        <p:nvSpPr>
-          <p:cNvPr id="11" name="Shape 9"/>
-          <p:cNvSpPr/>
-          <p:nvPr/>
-        </p:nvSpPr>
-        <p:spPr>
-          <a:xfrm>
-            <a:off x="6629400" y="1143000"/>
-            <a:ext cx="4800600" cy="4434840"/>
-          </a:xfrm>
-          <a:prstGeom prst="roundRect">
-            <a:avLst>
-              <a:gd name="adj" fmla="val 5773"/>
-            </a:avLst>
+      <p:pic>
+        <p:nvPicPr>
+          <p:cNvPr id="11" name="Image 0" descr="Discarded food from a supermarket in a waste container">    </p:cNvPr>
+          <p:cNvPicPr>
+            <a:picLocks noChangeAspect="1"/>
+          </p:cNvPicPr>
+          <p:nvPr/>
+        </p:nvPicPr>
+        <p:blipFill>
+          <a:blip r:embed="rId1"/>
+          <a:srcRect l="0" r="0" t="0" b="0"/>
+          <a:stretch/>
+        </p:blipFill>
+        <p:spPr>
+          <a:xfrm>
+            <a:off x="6565392" y="1051560"/>
+            <a:ext cx="4983480" cy="4773168"/>
+          </a:xfrm>
+          <a:prstGeom prst="rect">
+            <a:avLst/>
+          </a:prstGeom>
+        </p:spPr>
+      </p:pic>
+      <p:sp>
+        <p:nvSpPr>
+          <p:cNvPr id="12" name="Shape 9"/>
+          <p:cNvSpPr/>
+          <p:nvPr/>
+        </p:nvSpPr>
+        <p:spPr>
+          <a:xfrm>
+            <a:off x="6565392" y="4370832"/>
+            <a:ext cx="4983480" cy="1453896"/>
+          </a:xfrm>
+          <a:prstGeom prst="rect">
+            <a:avLst/>
           </a:prstGeom>
           <a:solidFill>
-            <a:srgbClr val="FFFDF7"/>
+            <a:srgbClr val="0D2B22">
+              <a:alpha val="88000"/>
+            </a:srgbClr>
           </a:solidFill>
           <a:ln w="12700">
             <a:solidFill>
-              <a:srgbClr val="FFFDF7">
+              <a:srgbClr val="0D2B22">
                 <a:alpha val="0"/>
               </a:srgbClr>
             </a:solidFill>
             <a:prstDash val="solid"/>
           </a:ln>
-          <a:effectLst>
-            <a:outerShdw sx="100000" sy="100000" kx="0" ky="0" algn="bl" rotWithShape="0" blurRad="25400" dist="50800" dir="2700000">
-              <a:srgbClr val="0A241C">
-                <a:alpha val="13000"/>
-              </a:srgbClr>
-            </a:outerShdw>
-          </a:effectLst>
-        </p:spPr>
-      </p:sp>
-      <p:sp>
-        <p:nvSpPr>
-          <p:cNvPr id="12" name="Text 10"/>
-          <p:cNvSpPr/>
-          <p:nvPr/>
-        </p:nvSpPr>
-        <p:spPr>
-          <a:xfrm>
-            <a:off x="6995160" y="1444752"/>
-            <a:ext cx="2514600" cy="228600"/>
-          </a:xfrm>
-          <a:prstGeom prst="rect">
-            <a:avLst/>
-          </a:prstGeom>
-          <a:noFill/>
-          <a:ln/>
-        </p:spPr>
-        <p:txBody>
-          <a:bodyPr wrap="square" lIns="0" tIns="0" rIns="0" bIns="0" rtlCol="0" anchor="ctr">
-            <a:normAutofit/>
-          </a:bodyPr>
-          <a:lstStyle/>
-          <a:p>
-            <a:pPr algn="l" indent="0" marL="0">
-              <a:buNone/>
-            </a:pPr>
-            <a:r>
-              <a:rPr lang="en-US" sz="900" b="1" spc="120" kern="0" dirty="0">
-                <a:solidFill>
-                  <a:srgbClr val="10B981"/>
-                </a:solidFill>
-                <a:latin typeface="Aptos" pitchFamily="34" charset="0"/>
-                <a:ea typeface="Aptos" pitchFamily="34" charset="-122"/>
-                <a:cs typeface="Aptos" pitchFamily="34" charset="-120"/>
-              </a:rPr>
-              <a:t>ILLUSTRATIVE STORE DECISION</a:t>
-            </a:r>
-            <a:endParaRPr lang="en-US" sz="900" dirty="0"/>
-          </a:p>
-        </p:txBody>
-      </p:sp>
-      <p:sp>
-        <p:nvSpPr>
-          <p:cNvPr id="13" name="Text 11"/>
-          <p:cNvSpPr/>
-          <p:nvPr/>
-        </p:nvSpPr>
-        <p:spPr>
-          <a:xfrm>
-            <a:off x="6995160" y="1810512"/>
-            <a:ext cx="3017520" cy="411480"/>
-          </a:xfrm>
-          <a:prstGeom prst="rect">
-            <a:avLst/>
-          </a:prstGeom>
-          <a:noFill/>
-          <a:ln/>
-        </p:spPr>
-        <p:txBody>
-          <a:bodyPr wrap="square" lIns="0" tIns="0" rIns="0" bIns="0" rtlCol="0" anchor="ctr">
-            <a:normAutofit/>
-          </a:bodyPr>
-          <a:lstStyle/>
-          <a:p>
-            <a:pPr algn="l" indent="0" marL="0">
-              <a:buNone/>
-            </a:pPr>
-            <a:r>
-              <a:rPr lang="en-US" sz="2200" b="1" dirty="0">
-                <a:solidFill>
-                  <a:srgbClr val="15352C"/>
-                </a:solidFill>
-                <a:latin typeface="Aptos Display" pitchFamily="34" charset="0"/>
-                <a:ea typeface="Aptos Display" pitchFamily="34" charset="-122"/>
-                <a:cs typeface="Aptos Display" pitchFamily="34" charset="-120"/>
-              </a:rPr>
-              <a:t>Organic whole milk</a:t>
-            </a:r>
-            <a:endParaRPr lang="en-US" sz="2200" dirty="0"/>
-          </a:p>
-        </p:txBody>
-      </p:sp>
-      <p:sp>
-        <p:nvSpPr>
-          <p:cNvPr id="14" name="Shape 12"/>
-          <p:cNvSpPr/>
-          <p:nvPr/>
-        </p:nvSpPr>
-        <p:spPr>
-          <a:xfrm>
-            <a:off x="10104120" y="1783080"/>
-            <a:ext cx="841248" cy="292608"/>
+        </p:spPr>
+      </p:sp>
+      <p:sp>
+        <p:nvSpPr>
+          <p:cNvPr id="13" name="Shape 10"/>
+          <p:cNvSpPr/>
+          <p:nvPr/>
+        </p:nvSpPr>
+        <p:spPr>
+          <a:xfrm>
+            <a:off x="6931152" y="4645152"/>
+            <a:ext cx="1481328" cy="292608"/>
           </a:xfrm>
           <a:prstGeom prst="roundRect">
             <a:avLst>
@@ -2372,11 +2306,11 @@
             </a:avLst>
           </a:prstGeom>
           <a:solidFill>
-            <a:srgbClr val="FFF0E7"/>
+            <a:srgbClr val="F97316"/>
           </a:solidFill>
           <a:ln w="12700">
             <a:solidFill>
-              <a:srgbClr val="FFF0E7">
+              <a:srgbClr val="F97316">
                 <a:alpha val="0"/>
               </a:srgbClr>
             </a:solidFill>
@@ -2386,14 +2320,14 @@
       </p:sp>
       <p:sp>
         <p:nvSpPr>
-          <p:cNvPr id="15" name="Text 13"/>
-          <p:cNvSpPr/>
-          <p:nvPr/>
-        </p:nvSpPr>
-        <p:spPr>
-          <a:xfrm>
-            <a:off x="10177272" y="1783080"/>
-            <a:ext cx="694944" cy="292608"/>
+          <p:cNvPr id="14" name="Text 11"/>
+          <p:cNvSpPr/>
+          <p:nvPr/>
+        </p:nvSpPr>
+        <p:spPr>
+          <a:xfrm>
+            <a:off x="7004304" y="4645152"/>
+            <a:ext cx="1335024" cy="292608"/>
           </a:xfrm>
           <a:prstGeom prst="rect">
             <a:avLst/>
@@ -2413,13 +2347,13 @@
             <a:r>
               <a:rPr lang="en-US" sz="900" b="1" dirty="0">
                 <a:solidFill>
-                  <a:srgbClr val="F97316"/>
-                </a:solidFill>
-                <a:latin typeface="Aptos" pitchFamily="34" charset="0"/>
-                <a:ea typeface="Aptos" pitchFamily="34" charset="-122"/>
-                <a:cs typeface="Aptos" pitchFamily="34" charset="-120"/>
-              </a:rPr>
-              <a:t>REVIEW</a:t>
+                  <a:srgbClr val="FFFFFF"/>
+                </a:solidFill>
+                <a:latin typeface="Aptos" pitchFamily="34" charset="0"/>
+                <a:ea typeface="Aptos" pitchFamily="34" charset="-122"/>
+                <a:cs typeface="Aptos" pitchFamily="34" charset="-120"/>
+              </a:rPr>
+              <a:t>THE COST OF WAITING</a:t>
             </a:r>
             <a:endParaRPr lang="en-US" sz="900" dirty="0"/>
           </a:p>
@@ -2427,607 +2361,106 @@
       </p:sp>
       <p:sp>
         <p:nvSpPr>
-          <p:cNvPr id="16" name="Text 14"/>
-          <p:cNvSpPr/>
-          <p:nvPr/>
-        </p:nvSpPr>
-        <p:spPr>
-          <a:xfrm>
-            <a:off x="6995160" y="2240280"/>
-            <a:ext cx="2834640" cy="256032"/>
-          </a:xfrm>
-          <a:prstGeom prst="rect">
-            <a:avLst/>
-          </a:prstGeom>
-          <a:noFill/>
-          <a:ln/>
-        </p:spPr>
-        <p:txBody>
-          <a:bodyPr wrap="square" lIns="0" tIns="0" rIns="0" bIns="0" rtlCol="0" anchor="ctr">
-            <a:normAutofit/>
-          </a:bodyPr>
-          <a:lstStyle/>
-          <a:p>
-            <a:pPr algn="l" indent="0" marL="0">
-              <a:buNone/>
-            </a:pPr>
-            <a:r>
-              <a:rPr lang="en-US" sz="1000" dirty="0">
-                <a:solidFill>
-                  <a:srgbClr val="667D75"/>
-                </a:solidFill>
-                <a:latin typeface="Aptos" pitchFamily="34" charset="0"/>
-                <a:ea typeface="Aptos" pitchFamily="34" charset="-122"/>
-                <a:cs typeface="Aptos" pitchFamily="34" charset="-120"/>
-              </a:rPr>
-              <a:t>18 units  •  4 days remaining</a:t>
-            </a:r>
-            <a:endParaRPr lang="en-US" sz="1000" dirty="0"/>
-          </a:p>
-        </p:txBody>
-      </p:sp>
-      <p:sp>
-        <p:nvSpPr>
-          <p:cNvPr id="17" name="Shape 15"/>
-          <p:cNvSpPr/>
-          <p:nvPr/>
-        </p:nvSpPr>
-        <p:spPr>
-          <a:xfrm>
-            <a:off x="6995160" y="2697480"/>
-            <a:ext cx="1188720" cy="960120"/>
-          </a:xfrm>
-          <a:prstGeom prst="roundRect">
-            <a:avLst>
-              <a:gd name="adj" fmla="val 17143"/>
-            </a:avLst>
-          </a:prstGeom>
-          <a:solidFill>
-            <a:srgbClr val="DDF7E8"/>
-          </a:solidFill>
-          <a:ln w="12700">
-            <a:solidFill>
-              <a:srgbClr val="DDF7E8">
-                <a:alpha val="0"/>
-              </a:srgbClr>
-            </a:solidFill>
-            <a:prstDash val="solid"/>
-          </a:ln>
-        </p:spPr>
-      </p:sp>
-      <p:sp>
-        <p:nvSpPr>
-          <p:cNvPr id="18" name="Text 16"/>
-          <p:cNvSpPr/>
-          <p:nvPr/>
-        </p:nvSpPr>
-        <p:spPr>
-          <a:xfrm>
-            <a:off x="7159752" y="2825496"/>
-            <a:ext cx="859536" cy="384048"/>
-          </a:xfrm>
-          <a:prstGeom prst="rect">
-            <a:avLst/>
-          </a:prstGeom>
-          <a:noFill/>
-          <a:ln/>
-        </p:spPr>
-        <p:txBody>
-          <a:bodyPr wrap="square" lIns="0" tIns="0" rIns="0" bIns="0" rtlCol="0" anchor="ctr">
-            <a:normAutofit/>
-          </a:bodyPr>
-          <a:lstStyle/>
-          <a:p>
-            <a:pPr algn="l" indent="0" marL="0">
-              <a:buNone/>
-            </a:pPr>
-            <a:r>
-              <a:rPr lang="en-US" sz="2300" b="1" dirty="0">
-                <a:solidFill>
-                  <a:srgbClr val="173D31"/>
+          <p:cNvPr id="15" name="Text 12"/>
+          <p:cNvSpPr/>
+          <p:nvPr/>
+        </p:nvSpPr>
+        <p:spPr>
+          <a:xfrm>
+            <a:off x="6931152" y="5010912"/>
+            <a:ext cx="3401568" cy="566928"/>
+          </a:xfrm>
+          <a:prstGeom prst="rect">
+            <a:avLst/>
+          </a:prstGeom>
+          <a:noFill/>
+          <a:ln/>
+        </p:spPr>
+        <p:txBody>
+          <a:bodyPr wrap="square" lIns="0" tIns="0" rIns="0" bIns="0" rtlCol="0" anchor="t">
+            <a:normAutofit/>
+          </a:bodyPr>
+          <a:lstStyle/>
+          <a:p>
+            <a:pPr algn="l" indent="0" marL="0">
+              <a:buNone/>
+            </a:pPr>
+            <a:r>
+              <a:rPr lang="en-US" sz="1900" b="1" dirty="0">
+                <a:solidFill>
+                  <a:srgbClr val="FFFFFF"/>
                 </a:solidFill>
                 <a:latin typeface="Aptos Display" pitchFamily="34" charset="0"/>
                 <a:ea typeface="Aptos Display" pitchFamily="34" charset="-122"/>
                 <a:cs typeface="Aptos Display" pitchFamily="34" charset="-120"/>
               </a:rPr>
-              <a:t>6</a:t>
-            </a:r>
-            <a:endParaRPr lang="en-US" sz="2300" dirty="0"/>
-          </a:p>
-        </p:txBody>
-      </p:sp>
-      <p:sp>
-        <p:nvSpPr>
-          <p:cNvPr id="19" name="Text 17"/>
-          <p:cNvSpPr/>
-          <p:nvPr/>
-        </p:nvSpPr>
-        <p:spPr>
-          <a:xfrm>
-            <a:off x="7159752" y="3264408"/>
-            <a:ext cx="859536" cy="219456"/>
-          </a:xfrm>
-          <a:prstGeom prst="rect">
-            <a:avLst/>
-          </a:prstGeom>
-          <a:noFill/>
-          <a:ln/>
-        </p:spPr>
-        <p:txBody>
-          <a:bodyPr wrap="square" lIns="0" tIns="0" rIns="0" bIns="0" rtlCol="0" anchor="ctr">
-            <a:normAutofit/>
-          </a:bodyPr>
-          <a:lstStyle/>
-          <a:p>
-            <a:pPr algn="l" indent="0" marL="0">
-              <a:buNone/>
-            </a:pPr>
-            <a:r>
-              <a:rPr lang="en-US" sz="900" b="1" dirty="0">
-                <a:solidFill>
-                  <a:srgbClr val="173D31">
-                    <a:alpha val="75000"/>
-                  </a:srgbClr>
-                </a:solidFill>
-                <a:latin typeface="Aptos" pitchFamily="34" charset="0"/>
-                <a:ea typeface="Aptos" pitchFamily="34" charset="-122"/>
-                <a:cs typeface="Aptos" pitchFamily="34" charset="-120"/>
-              </a:rPr>
-              <a:t>CURRENT PACE</a:t>
-            </a:r>
-            <a:endParaRPr lang="en-US" sz="900" dirty="0"/>
-          </a:p>
-        </p:txBody>
-      </p:sp>
-      <p:sp>
-        <p:nvSpPr>
-          <p:cNvPr id="20" name="Shape 18"/>
-          <p:cNvSpPr/>
-          <p:nvPr/>
-        </p:nvSpPr>
-        <p:spPr>
-          <a:xfrm>
-            <a:off x="8302752" y="2697480"/>
-            <a:ext cx="1188720" cy="960120"/>
-          </a:xfrm>
-          <a:prstGeom prst="roundRect">
-            <a:avLst>
-              <a:gd name="adj" fmla="val 17143"/>
-            </a:avLst>
-          </a:prstGeom>
-          <a:solidFill>
-            <a:srgbClr val="FFF0E7"/>
-          </a:solidFill>
-          <a:ln w="12700">
-            <a:solidFill>
-              <a:srgbClr val="FFF0E7">
-                <a:alpha val="0"/>
-              </a:srgbClr>
-            </a:solidFill>
-            <a:prstDash val="solid"/>
-          </a:ln>
-        </p:spPr>
-      </p:sp>
-      <p:sp>
-        <p:nvSpPr>
-          <p:cNvPr id="21" name="Text 19"/>
-          <p:cNvSpPr/>
-          <p:nvPr/>
-        </p:nvSpPr>
-        <p:spPr>
-          <a:xfrm>
-            <a:off x="8467344" y="2825496"/>
-            <a:ext cx="859536" cy="384048"/>
-          </a:xfrm>
-          <a:prstGeom prst="rect">
-            <a:avLst/>
-          </a:prstGeom>
-          <a:noFill/>
-          <a:ln/>
-        </p:spPr>
-        <p:txBody>
-          <a:bodyPr wrap="square" lIns="0" tIns="0" rIns="0" bIns="0" rtlCol="0" anchor="ctr">
-            <a:normAutofit/>
-          </a:bodyPr>
-          <a:lstStyle/>
-          <a:p>
-            <a:pPr algn="l" indent="0" marL="0">
-              <a:buNone/>
-            </a:pPr>
-            <a:r>
-              <a:rPr lang="en-US" sz="2300" b="1" dirty="0">
-                <a:solidFill>
-                  <a:srgbClr val="F97316"/>
+              <a:t>What was inventory</a:t>
+            </a:r>
+            <a:endParaRPr lang="en-US" sz="1900" dirty="0"/>
+          </a:p>
+          <a:p>
+            <a:pPr algn="l" indent="0" marL="0">
+              <a:buNone/>
+            </a:pPr>
+            <a:r>
+              <a:rPr lang="en-US" sz="1900" b="1" dirty="0">
+                <a:solidFill>
+                  <a:srgbClr val="FFFFFF"/>
                 </a:solidFill>
                 <a:latin typeface="Aptos Display" pitchFamily="34" charset="0"/>
                 <a:ea typeface="Aptos Display" pitchFamily="34" charset="-122"/>
                 <a:cs typeface="Aptos Display" pitchFamily="34" charset="-120"/>
               </a:rPr>
-              <a:t>12</a:t>
-            </a:r>
-            <a:endParaRPr lang="en-US" sz="2300" dirty="0"/>
-          </a:p>
-        </p:txBody>
-      </p:sp>
-      <p:sp>
-        <p:nvSpPr>
-          <p:cNvPr id="22" name="Text 20"/>
-          <p:cNvSpPr/>
-          <p:nvPr/>
-        </p:nvSpPr>
-        <p:spPr>
-          <a:xfrm>
-            <a:off x="8467344" y="3264408"/>
-            <a:ext cx="859536" cy="219456"/>
-          </a:xfrm>
-          <a:prstGeom prst="rect">
-            <a:avLst/>
-          </a:prstGeom>
-          <a:noFill/>
-          <a:ln/>
-        </p:spPr>
-        <p:txBody>
-          <a:bodyPr wrap="square" lIns="0" tIns="0" rIns="0" bIns="0" rtlCol="0" anchor="ctr">
-            <a:normAutofit/>
-          </a:bodyPr>
-          <a:lstStyle/>
-          <a:p>
-            <a:pPr algn="l" indent="0" marL="0">
-              <a:buNone/>
-            </a:pPr>
-            <a:r>
-              <a:rPr lang="en-US" sz="900" b="1" dirty="0">
-                <a:solidFill>
-                  <a:srgbClr val="F97316">
-                    <a:alpha val="75000"/>
-                  </a:srgbClr>
-                </a:solidFill>
-                <a:latin typeface="Aptos" pitchFamily="34" charset="0"/>
-                <a:ea typeface="Aptos" pitchFamily="34" charset="-122"/>
-                <a:cs typeface="Aptos" pitchFamily="34" charset="-120"/>
-              </a:rPr>
-              <a:t>LIKELY LEFT</a:t>
-            </a:r>
-            <a:endParaRPr lang="en-US" sz="900" dirty="0"/>
-          </a:p>
-        </p:txBody>
-      </p:sp>
-      <p:sp>
-        <p:nvSpPr>
-          <p:cNvPr id="23" name="Shape 21"/>
-          <p:cNvSpPr/>
-          <p:nvPr/>
-        </p:nvSpPr>
-        <p:spPr>
-          <a:xfrm>
-            <a:off x="9610344" y="2697480"/>
-            <a:ext cx="1417320" cy="960120"/>
-          </a:xfrm>
-          <a:prstGeom prst="roundRect">
-            <a:avLst>
-              <a:gd name="adj" fmla="val 17143"/>
-            </a:avLst>
-          </a:prstGeom>
-          <a:solidFill>
-            <a:srgbClr val="173D31"/>
-          </a:solidFill>
-          <a:ln w="12700">
-            <a:solidFill>
-              <a:srgbClr val="173D31">
-                <a:alpha val="0"/>
-              </a:srgbClr>
-            </a:solidFill>
-            <a:prstDash val="solid"/>
-          </a:ln>
-        </p:spPr>
-      </p:sp>
-      <p:sp>
-        <p:nvSpPr>
-          <p:cNvPr id="24" name="Text 22"/>
-          <p:cNvSpPr/>
-          <p:nvPr/>
-        </p:nvSpPr>
-        <p:spPr>
-          <a:xfrm>
-            <a:off x="9774936" y="2825496"/>
-            <a:ext cx="1088136" cy="384048"/>
-          </a:xfrm>
-          <a:prstGeom prst="rect">
-            <a:avLst/>
-          </a:prstGeom>
-          <a:noFill/>
-          <a:ln/>
-        </p:spPr>
-        <p:txBody>
-          <a:bodyPr wrap="square" lIns="0" tIns="0" rIns="0" bIns="0" rtlCol="0" anchor="ctr">
-            <a:normAutofit/>
-          </a:bodyPr>
-          <a:lstStyle/>
-          <a:p>
-            <a:pPr algn="l" indent="0" marL="0">
-              <a:buNone/>
-            </a:pPr>
-            <a:r>
-              <a:rPr lang="en-US" sz="2300" b="1" dirty="0">
-                <a:solidFill>
-                  <a:srgbClr val="FFFFFF"/>
-                </a:solidFill>
-                <a:latin typeface="Aptos Display" pitchFamily="34" charset="0"/>
-                <a:ea typeface="Aptos Display" pitchFamily="34" charset="-122"/>
-                <a:cs typeface="Aptos Display" pitchFamily="34" charset="-120"/>
-              </a:rPr>
-              <a:t>20%</a:t>
-            </a:r>
-            <a:endParaRPr lang="en-US" sz="2300" dirty="0"/>
-          </a:p>
-        </p:txBody>
-      </p:sp>
-      <p:sp>
-        <p:nvSpPr>
-          <p:cNvPr id="25" name="Text 23"/>
-          <p:cNvSpPr/>
-          <p:nvPr/>
-        </p:nvSpPr>
-        <p:spPr>
-          <a:xfrm>
-            <a:off x="9774936" y="3264408"/>
-            <a:ext cx="1088136" cy="219456"/>
-          </a:xfrm>
-          <a:prstGeom prst="rect">
-            <a:avLst/>
-          </a:prstGeom>
-          <a:noFill/>
-          <a:ln/>
-        </p:spPr>
-        <p:txBody>
-          <a:bodyPr wrap="square" lIns="0" tIns="0" rIns="0" bIns="0" rtlCol="0" anchor="ctr">
-            <a:normAutofit/>
-          </a:bodyPr>
-          <a:lstStyle/>
-          <a:p>
-            <a:pPr algn="l" indent="0" marL="0">
-              <a:buNone/>
-            </a:pPr>
-            <a:r>
-              <a:rPr lang="en-US" sz="900" b="1" dirty="0">
-                <a:solidFill>
-                  <a:srgbClr val="FFFFFF">
-                    <a:alpha val="75000"/>
-                  </a:srgbClr>
-                </a:solidFill>
-                <a:latin typeface="Aptos" pitchFamily="34" charset="0"/>
-                <a:ea typeface="Aptos" pitchFamily="34" charset="-122"/>
-                <a:cs typeface="Aptos" pitchFamily="34" charset="-120"/>
-              </a:rPr>
-              <a:t>SUGGESTED</a:t>
-            </a:r>
-            <a:endParaRPr lang="en-US" sz="900" dirty="0"/>
-          </a:p>
-        </p:txBody>
-      </p:sp>
-      <p:sp>
-        <p:nvSpPr>
-          <p:cNvPr id="26" name="Shape 24"/>
-          <p:cNvSpPr/>
-          <p:nvPr/>
-        </p:nvSpPr>
-        <p:spPr>
-          <a:xfrm>
-            <a:off x="6995160" y="3886200"/>
-            <a:ext cx="4032504" cy="777240"/>
-          </a:xfrm>
-          <a:prstGeom prst="roundRect">
-            <a:avLst>
-              <a:gd name="adj" fmla="val 16471"/>
-            </a:avLst>
-          </a:prstGeom>
-          <a:solidFill>
-            <a:srgbClr val="FFFFFF"/>
-          </a:solidFill>
-          <a:ln w="12700">
-            <a:solidFill>
-              <a:srgbClr val="D9E3DD"/>
-            </a:solidFill>
-            <a:prstDash val="solid"/>
-          </a:ln>
-        </p:spPr>
-      </p:sp>
-      <p:sp>
-        <p:nvSpPr>
-          <p:cNvPr id="27" name="Text 25"/>
-          <p:cNvSpPr/>
-          <p:nvPr/>
-        </p:nvSpPr>
-        <p:spPr>
-          <a:xfrm>
-            <a:off x="7205472" y="4041648"/>
-            <a:ext cx="1508760" cy="182880"/>
-          </a:xfrm>
-          <a:prstGeom prst="rect">
-            <a:avLst/>
-          </a:prstGeom>
-          <a:noFill/>
-          <a:ln/>
-        </p:spPr>
-        <p:txBody>
-          <a:bodyPr wrap="square" lIns="0" tIns="0" rIns="0" bIns="0" rtlCol="0" anchor="ctr">
-            <a:normAutofit/>
-          </a:bodyPr>
-          <a:lstStyle/>
-          <a:p>
-            <a:pPr algn="l" indent="0" marL="0">
-              <a:buNone/>
-            </a:pPr>
-            <a:r>
-              <a:rPr lang="en-US" sz="900" dirty="0">
-                <a:solidFill>
-                  <a:srgbClr val="667D75"/>
-                </a:solidFill>
-                <a:latin typeface="Aptos" pitchFamily="34" charset="0"/>
-                <a:ea typeface="Aptos" pitchFamily="34" charset="-122"/>
-                <a:cs typeface="Aptos" pitchFamily="34" charset="-120"/>
-              </a:rPr>
-              <a:t>Recommended price</a:t>
-            </a:r>
-            <a:endParaRPr lang="en-US" sz="900" dirty="0"/>
-          </a:p>
-        </p:txBody>
-      </p:sp>
-      <p:sp>
-        <p:nvSpPr>
-          <p:cNvPr id="28" name="Text 26"/>
-          <p:cNvSpPr/>
-          <p:nvPr/>
-        </p:nvSpPr>
-        <p:spPr>
-          <a:xfrm>
-            <a:off x="7205472" y="4251960"/>
-            <a:ext cx="1097280" cy="274320"/>
-          </a:xfrm>
-          <a:prstGeom prst="rect">
-            <a:avLst/>
-          </a:prstGeom>
-          <a:noFill/>
-          <a:ln/>
-        </p:spPr>
-        <p:txBody>
-          <a:bodyPr wrap="square" lIns="0" tIns="0" rIns="0" bIns="0" rtlCol="0" anchor="ctr">
-            <a:normAutofit/>
-          </a:bodyPr>
-          <a:lstStyle/>
-          <a:p>
-            <a:pPr algn="l" indent="0" marL="0">
-              <a:buNone/>
-            </a:pPr>
-            <a:r>
-              <a:rPr lang="en-US" sz="2200" b="1" dirty="0">
-                <a:solidFill>
-                  <a:srgbClr val="173D31"/>
-                </a:solidFill>
-                <a:latin typeface="Aptos Display" pitchFamily="34" charset="0"/>
-                <a:ea typeface="Aptos Display" pitchFamily="34" charset="-122"/>
-                <a:cs typeface="Aptos Display" pitchFamily="34" charset="-120"/>
-              </a:rPr>
-              <a:t>₹67</a:t>
-            </a:r>
-            <a:endParaRPr lang="en-US" sz="2200" dirty="0"/>
-          </a:p>
-        </p:txBody>
-      </p:sp>
-      <p:sp>
-        <p:nvSpPr>
-          <p:cNvPr id="29" name="Text 27"/>
-          <p:cNvSpPr/>
-          <p:nvPr/>
-        </p:nvSpPr>
-        <p:spPr>
-          <a:xfrm>
-            <a:off x="8247888" y="4297680"/>
-            <a:ext cx="658368" cy="182880"/>
-          </a:xfrm>
-          <a:prstGeom prst="rect">
-            <a:avLst/>
-          </a:prstGeom>
-          <a:noFill/>
-          <a:ln/>
-        </p:spPr>
-        <p:txBody>
-          <a:bodyPr wrap="square" lIns="0" tIns="0" rIns="0" bIns="0" rtlCol="0" anchor="ctr">
-            <a:normAutofit/>
-          </a:bodyPr>
-          <a:lstStyle/>
-          <a:p>
-            <a:pPr algn="l" indent="0" marL="0">
-              <a:buNone/>
-            </a:pPr>
-            <a:r>
-              <a:rPr lang="en-US" sz="1000" strike="sngStrike" dirty="0">
-                <a:solidFill>
-                  <a:srgbClr val="98A8A2"/>
-                </a:solidFill>
-                <a:latin typeface="Aptos" pitchFamily="34" charset="0"/>
-                <a:ea typeface="Aptos" pitchFamily="34" charset="-122"/>
-                <a:cs typeface="Aptos" pitchFamily="34" charset="-120"/>
-              </a:rPr>
-              <a:t>₹84</a:t>
-            </a:r>
-            <a:endParaRPr lang="en-US" sz="1000" dirty="0"/>
-          </a:p>
-        </p:txBody>
-      </p:sp>
-      <p:sp>
-        <p:nvSpPr>
-          <p:cNvPr id="30" name="Shape 28"/>
-          <p:cNvSpPr/>
-          <p:nvPr/>
-        </p:nvSpPr>
-        <p:spPr>
-          <a:xfrm>
-            <a:off x="6995160" y="4828032"/>
-            <a:ext cx="4032504" cy="438912"/>
-          </a:xfrm>
-          <a:prstGeom prst="roundRect">
-            <a:avLst>
-              <a:gd name="adj" fmla="val 29167"/>
-            </a:avLst>
-          </a:prstGeom>
-          <a:solidFill>
-            <a:srgbClr val="10B981"/>
-          </a:solidFill>
-          <a:ln w="12700">
-            <a:solidFill>
-              <a:srgbClr val="10B981">
-                <a:alpha val="0"/>
-              </a:srgbClr>
-            </a:solidFill>
-            <a:prstDash val="solid"/>
-          </a:ln>
-        </p:spPr>
-      </p:sp>
-      <p:sp>
-        <p:nvSpPr>
-          <p:cNvPr id="31" name="Text 29"/>
-          <p:cNvSpPr/>
-          <p:nvPr/>
-        </p:nvSpPr>
-        <p:spPr>
-          <a:xfrm>
-            <a:off x="7196328" y="4828032"/>
-            <a:ext cx="3611880" cy="438912"/>
-          </a:xfrm>
-          <a:prstGeom prst="rect">
-            <a:avLst/>
-          </a:prstGeom>
-          <a:noFill/>
-          <a:ln/>
-        </p:spPr>
-        <p:txBody>
-          <a:bodyPr wrap="square" lIns="0" tIns="0" rIns="0" bIns="0" rtlCol="0" anchor="ctr">
-            <a:normAutofit/>
-          </a:bodyPr>
-          <a:lstStyle/>
-          <a:p>
-            <a:pPr algn="ctr" indent="0" marL="0">
-              <a:buNone/>
-            </a:pPr>
-            <a:r>
-              <a:rPr lang="en-US" sz="1000" b="1" spc="80" kern="0" dirty="0">
-                <a:solidFill>
-                  <a:srgbClr val="FFFFFF"/>
-                </a:solidFill>
-                <a:latin typeface="Aptos" pitchFamily="34" charset="0"/>
-                <a:ea typeface="Aptos" pitchFamily="34" charset="-122"/>
-                <a:cs typeface="Aptos" pitchFamily="34" charset="-120"/>
-              </a:rPr>
-              <a:t>OWNER APPROVAL REQUIRED</a:t>
-            </a:r>
-            <a:endParaRPr lang="en-US" sz="1000" dirty="0"/>
-          </a:p>
-        </p:txBody>
-      </p:sp>
-      <p:sp>
-        <p:nvSpPr>
-          <p:cNvPr id="32" name="Text 30"/>
+              <a:t>becomes avoidable waste.</a:t>
+            </a:r>
+            <a:endParaRPr lang="en-US" sz="1900" dirty="0"/>
+          </a:p>
+        </p:txBody>
+      </p:sp>
+      <p:sp>
+        <p:nvSpPr>
+          <p:cNvPr id="16" name="Text 13"/>
+          <p:cNvSpPr/>
+          <p:nvPr/>
+        </p:nvSpPr>
+        <p:spPr>
+          <a:xfrm>
+            <a:off x="6931152" y="5614416"/>
+            <a:ext cx="3520440" cy="146304"/>
+          </a:xfrm>
+          <a:prstGeom prst="rect">
+            <a:avLst/>
+          </a:prstGeom>
+          <a:noFill/>
+          <a:ln/>
+        </p:spPr>
+        <p:txBody>
+          <a:bodyPr wrap="square" lIns="0" tIns="0" rIns="0" bIns="0" rtlCol="0" anchor="ctr">
+            <a:normAutofit/>
+          </a:bodyPr>
+          <a:lstStyle/>
+          <a:p>
+            <a:pPr algn="l" indent="0" marL="0">
+              <a:buNone/>
+            </a:pPr>
+            <a:r>
+              <a:rPr lang="en-US" sz="680" dirty="0">
+                <a:solidFill>
+                  <a:srgbClr val="D3DDD9"/>
+                </a:solidFill>
+                <a:latin typeface="Aptos" pitchFamily="34" charset="0"/>
+                <a:ea typeface="Aptos" pitchFamily="34" charset="-122"/>
+                <a:cs typeface="Aptos" pitchFamily="34" charset="-120"/>
+              </a:rPr>
+              <a:t>Public-domain image: KVDP / Wikimedia Commons</a:t>
+            </a:r>
+            <a:endParaRPr lang="en-US" sz="680" dirty="0"/>
+          </a:p>
+        </p:txBody>
+      </p:sp>
+      <p:sp>
+        <p:nvSpPr>
+          <p:cNvPr id="17" name="Text 14"/>
           <p:cNvSpPr/>
           <p:nvPr/>
         </p:nvSpPr>
@@ -3035,59 +2468,6 @@
           <a:xfrm>
             <a:off x="658368" y="5715000"/>
             <a:ext cx="1417320" cy="274320"/>
-          </a:xfrm>
-          <a:prstGeom prst="rect">
-            <a:avLst/>
-          </a:prstGeom>
-          <a:noFill/>
-          <a:ln/>
-        </p:spPr>
-        <p:txBody>
-          <a:bodyPr wrap="square" lIns="0" tIns="0" rIns="0" bIns="0" rtlCol="0" anchor="ctr">
-            <a:normAutofit/>
-          </a:bodyPr>
-          <a:lstStyle/>
-          <a:p>
-            <a:pPr algn="l" indent="0" marL="0">
-              <a:buNone/>
-            </a:pPr>
-            <a:r>
-              <a:rPr lang="en-US" sz="1000" b="1" u="sng" dirty="0">
-                <a:solidFill>
-                  <a:srgbClr val="BEF264"/>
-                </a:solidFill>
-                <a:uFill>
-                  <a:solidFill>
-                    <a:srgbClr val="BEF264"/>
-                  </a:solidFill>
-                </a:uFill>
-                <a:latin typeface="Aptos" pitchFamily="34" charset="0"/>
-                <a:ea typeface="Aptos" pitchFamily="34" charset="-122"/>
-                <a:cs typeface="Aptos" pitchFamily="34" charset="-120"/>
-                <a:hlinkClick r:id="rId1" invalidUrl="" action="" tgtFrame="" tooltip="" history="1" highlightClick="0" endSnd="0">
-                  <a:extLst>
-                    <a:ext uri="{A12FA001-AC4F-418D-AE19-62706E023703}">
-                      <ahyp:hlinkClr xmlns:ahyp="http://schemas.microsoft.com/office/drawing/2018/hyperlinkcolor" val="tx"/>
-                    </a:ext>
-                  </a:extLst>
-                </a:hlinkClick>
-              </a:rPr>
-              <a:t>LIVE DEMO  →</a:t>
-            </a:r>
-            <a:endParaRPr lang="en-US" sz="1000" dirty="0"/>
-          </a:p>
-        </p:txBody>
-      </p:sp>
-      <p:sp>
-        <p:nvSpPr>
-          <p:cNvPr id="33" name="Text 31"/>
-          <p:cNvSpPr/>
-          <p:nvPr/>
-        </p:nvSpPr>
-        <p:spPr>
-          <a:xfrm>
-            <a:off x="2331720" y="5715000"/>
-            <a:ext cx="1234440" cy="274320"/>
           </a:xfrm>
           <a:prstGeom prst="rect">
             <a:avLst/>
@@ -3125,6 +2505,59 @@
                   </a:extLst>
                 </a:hlinkClick>
               </a:rPr>
+              <a:t>LIVE DEMO  →</a:t>
+            </a:r>
+            <a:endParaRPr lang="en-US" sz="1000" dirty="0"/>
+          </a:p>
+        </p:txBody>
+      </p:sp>
+      <p:sp>
+        <p:nvSpPr>
+          <p:cNvPr id="18" name="Text 15"/>
+          <p:cNvSpPr/>
+          <p:nvPr/>
+        </p:nvSpPr>
+        <p:spPr>
+          <a:xfrm>
+            <a:off x="2331720" y="5715000"/>
+            <a:ext cx="1234440" cy="274320"/>
+          </a:xfrm>
+          <a:prstGeom prst="rect">
+            <a:avLst/>
+          </a:prstGeom>
+          <a:noFill/>
+          <a:ln/>
+        </p:spPr>
+        <p:txBody>
+          <a:bodyPr wrap="square" lIns="0" tIns="0" rIns="0" bIns="0" rtlCol="0" anchor="ctr">
+            <a:normAutofit/>
+          </a:bodyPr>
+          <a:lstStyle/>
+          <a:p>
+            <a:pPr algn="l" indent="0" marL="0">
+              <a:buNone/>
+            </a:pPr>
+            <a:r>
+              <a:rPr lang="en-US" sz="1000" b="1" u="sng" dirty="0">
+                <a:solidFill>
+                  <a:srgbClr val="BEF264"/>
+                </a:solidFill>
+                <a:uFill>
+                  <a:solidFill>
+                    <a:srgbClr val="BEF264"/>
+                  </a:solidFill>
+                </a:uFill>
+                <a:latin typeface="Aptos" pitchFamily="34" charset="0"/>
+                <a:ea typeface="Aptos" pitchFamily="34" charset="-122"/>
+                <a:cs typeface="Aptos" pitchFamily="34" charset="-120"/>
+                <a:hlinkClick r:id="rId3" invalidUrl="" action="" tgtFrame="" tooltip="" history="1" highlightClick="0" endSnd="0">
+                  <a:extLst>
+                    <a:ext uri="{A12FA001-AC4F-418D-AE19-62706E023703}">
+                      <ahyp:hlinkClr xmlns:ahyp="http://schemas.microsoft.com/office/drawing/2018/hyperlinkcolor" val="tx"/>
+                    </a:ext>
+                  </a:extLst>
+                </a:hlinkClick>
+              </a:rPr>
               <a:t>SOURCE  →</a:t>
             </a:r>
             <a:endParaRPr lang="en-US" sz="1000" dirty="0"/>
@@ -3133,7 +2566,7 @@
       </p:sp>
       <p:sp>
         <p:nvSpPr>
-          <p:cNvPr id="34" name="Shape 32"/>
+          <p:cNvPr id="19" name="Shape 16"/>
           <p:cNvSpPr/>
           <p:nvPr/>
         </p:nvSpPr>
@@ -3156,7 +2589,7 @@
       </p:sp>
       <p:sp>
         <p:nvSpPr>
-          <p:cNvPr id="35" name="Text 33"/>
+          <p:cNvPr id="20" name="Text 17"/>
           <p:cNvSpPr/>
           <p:nvPr/>
         </p:nvSpPr>
@@ -3197,7 +2630,7 @@
       </p:sp>
       <p:sp>
         <p:nvSpPr>
-          <p:cNvPr id="36" name="Text 34"/>
+          <p:cNvPr id="21" name="Text 18"/>
           <p:cNvSpPr/>
           <p:nvPr/>
         </p:nvSpPr>
@@ -3238,8 +2671,8 @@
       </p:sp>
       <p:pic>
         <p:nvPicPr>
-          <p:cNvPr id="38" name="Image 0" descr="preencoded.png">
-            <a:hlinkClick r:id="rId4" tooltip=""/>
+          <p:cNvPr id="23" name="Image 1" descr="preencoded.png">
+            <a:hlinkClick r:id="rId5" tooltip=""/>
           </p:cNvPr>
           <p:cNvPicPr>
             <a:picLocks noChangeAspect="1"/>
@@ -3247,7 +2680,7 @@
           <p:nvPr/>
         </p:nvPicPr>
         <p:blipFill>
-          <a:blip r:embed="rId3"/>
+          <a:blip r:embed="rId4"/>
           <a:stretch>
             <a:fillRect/>
           </a:stretch>
@@ -4755,6 +4188,163 @@
             <a:prstDash val="solid"/>
           </a:ln>
           <a:effectLst>
+            <a:outerShdw sx="100000" sy="100000" kx="0" ky="0" algn="bl" rotWithShape="0" blurRad="25400" dist="50800" dir="2700000">
+              <a:srgbClr val="0A241C">
+                <a:alpha val="13000"/>
+              </a:srgbClr>
+            </a:outerShdw>
+          </a:effectLst>
+        </p:spPr>
+      </p:sp>
+      <p:sp>
+        <p:nvSpPr>
+          <p:cNvPr id="6" name="Text 4"/>
+          <p:cNvSpPr/>
+          <p:nvPr/>
+        </p:nvSpPr>
+        <p:spPr>
+          <a:xfrm>
+            <a:off x="841248" y="2212848"/>
+            <a:ext cx="1600200" cy="502920"/>
+          </a:xfrm>
+          <a:prstGeom prst="rect">
+            <a:avLst/>
+          </a:prstGeom>
+          <a:noFill/>
+          <a:ln/>
+        </p:spPr>
+        <p:txBody>
+          <a:bodyPr wrap="square" lIns="0" tIns="0" rIns="0" bIns="0" rtlCol="0" anchor="ctr">
+            <a:normAutofit/>
+          </a:bodyPr>
+          <a:lstStyle/>
+          <a:p>
+            <a:pPr algn="l" indent="0" marL="0">
+              <a:buNone/>
+            </a:pPr>
+            <a:r>
+              <a:rPr lang="en-US" sz="3100" b="1" dirty="0">
+                <a:solidFill>
+                  <a:srgbClr val="BEF264"/>
+                </a:solidFill>
+                <a:latin typeface="Aptos Display" pitchFamily="34" charset="0"/>
+                <a:ea typeface="Aptos Display" pitchFamily="34" charset="-122"/>
+                <a:cs typeface="Aptos Display" pitchFamily="34" charset="-120"/>
+              </a:rPr>
+              <a:t>1.05B</a:t>
+            </a:r>
+            <a:endParaRPr lang="en-US" sz="3100" dirty="0"/>
+          </a:p>
+        </p:txBody>
+      </p:sp>
+      <p:sp>
+        <p:nvSpPr>
+          <p:cNvPr id="7" name="Text 5"/>
+          <p:cNvSpPr/>
+          <p:nvPr/>
+        </p:nvSpPr>
+        <p:spPr>
+          <a:xfrm>
+            <a:off x="2359152" y="2414016"/>
+            <a:ext cx="914400" cy="219456"/>
+          </a:xfrm>
+          <a:prstGeom prst="rect">
+            <a:avLst/>
+          </a:prstGeom>
+          <a:noFill/>
+          <a:ln/>
+        </p:spPr>
+        <p:txBody>
+          <a:bodyPr wrap="square" lIns="0" tIns="0" rIns="0" bIns="0" rtlCol="0" anchor="ctr">
+            <a:normAutofit/>
+          </a:bodyPr>
+          <a:lstStyle/>
+          <a:p>
+            <a:pPr algn="r" indent="0" marL="0">
+              <a:buNone/>
+            </a:pPr>
+            <a:r>
+              <a:rPr lang="en-US" sz="1000" b="1" dirty="0">
+                <a:solidFill>
+                  <a:srgbClr val="FFFFFF"/>
+                </a:solidFill>
+                <a:latin typeface="Aptos" pitchFamily="34" charset="0"/>
+                <a:ea typeface="Aptos" pitchFamily="34" charset="-122"/>
+                <a:cs typeface="Aptos" pitchFamily="34" charset="-120"/>
+              </a:rPr>
+              <a:t>tonnes</a:t>
+            </a:r>
+            <a:endParaRPr lang="en-US" sz="1000" dirty="0"/>
+          </a:p>
+        </p:txBody>
+      </p:sp>
+      <p:sp>
+        <p:nvSpPr>
+          <p:cNvPr id="8" name="Text 6"/>
+          <p:cNvSpPr/>
+          <p:nvPr/>
+        </p:nvSpPr>
+        <p:spPr>
+          <a:xfrm>
+            <a:off x="841248" y="2852928"/>
+            <a:ext cx="2468880" cy="530352"/>
+          </a:xfrm>
+          <a:prstGeom prst="rect">
+            <a:avLst/>
+          </a:prstGeom>
+          <a:noFill/>
+          <a:ln/>
+        </p:spPr>
+        <p:txBody>
+          <a:bodyPr wrap="square" lIns="0" tIns="0" rIns="0" bIns="0" rtlCol="0" anchor="t">
+            <a:normAutofit/>
+          </a:bodyPr>
+          <a:lstStyle/>
+          <a:p>
+            <a:pPr algn="l" indent="0" marL="0">
+              <a:buNone/>
+            </a:pPr>
+            <a:r>
+              <a:rPr lang="en-US" sz="1050" dirty="0">
+                <a:solidFill>
+                  <a:srgbClr val="CAD9D3"/>
+                </a:solidFill>
+                <a:latin typeface="Aptos" pitchFamily="34" charset="0"/>
+                <a:ea typeface="Aptos" pitchFamily="34" charset="-122"/>
+                <a:cs typeface="Aptos" pitchFamily="34" charset="-120"/>
+              </a:rPr>
+              <a:t>food waste generated at retail, food service and household level in 2022</a:t>
+            </a:r>
+            <a:endParaRPr lang="en-US" sz="1050" dirty="0"/>
+          </a:p>
+        </p:txBody>
+      </p:sp>
+      <p:sp>
+        <p:nvSpPr>
+          <p:cNvPr id="9" name="Shape 7"/>
+          <p:cNvSpPr/>
+          <p:nvPr/>
+        </p:nvSpPr>
+        <p:spPr>
+          <a:xfrm>
+            <a:off x="3986784" y="1975104"/>
+            <a:ext cx="2971800" cy="1627632"/>
+          </a:xfrm>
+          <a:prstGeom prst="roundRect">
+            <a:avLst>
+              <a:gd name="adj" fmla="val 12921"/>
+            </a:avLst>
+          </a:prstGeom>
+          <a:solidFill>
+            <a:srgbClr val="F2ECFF"/>
+          </a:solidFill>
+          <a:ln w="12700">
+            <a:solidFill>
+              <a:srgbClr val="D9E3DD"/>
+            </a:solidFill>
+            <a:prstDash val="solid"/>
+          </a:ln>
+          <a:effectLst>
             <a:outerShdw sx="100000" sy="100000" kx="0" ky="0" algn="bl" rotWithShape="0" blurRad="322580000" dist="645160000" dir="162000000000">
               <a:srgbClr val="0A241C">
                 <a:alpha val="1300000000"/>
@@ -4765,13 +4355,13 @@
       </p:sp>
       <p:sp>
         <p:nvSpPr>
-          <p:cNvPr id="6" name="Text 4"/>
-          <p:cNvSpPr/>
-          <p:nvPr/>
-        </p:nvSpPr>
-        <p:spPr>
-          <a:xfrm>
-            <a:off x="841248" y="2212848"/>
+          <p:cNvPr id="10" name="Text 8"/>
+          <p:cNvSpPr/>
+          <p:nvPr/>
+        </p:nvSpPr>
+        <p:spPr>
+          <a:xfrm>
+            <a:off x="4206240" y="2212848"/>
             <a:ext cx="1600200" cy="502920"/>
           </a:xfrm>
           <a:prstGeom prst="rect">
@@ -4792,13 +4382,13 @@
             <a:r>
               <a:rPr lang="en-US" sz="3100" b="1" dirty="0">
                 <a:solidFill>
-                  <a:srgbClr val="BEF264"/>
+                  <a:srgbClr val="7C3AED"/>
                 </a:solidFill>
                 <a:latin typeface="Aptos Display" pitchFamily="34" charset="0"/>
                 <a:ea typeface="Aptos Display" pitchFamily="34" charset="-122"/>
                 <a:cs typeface="Aptos Display" pitchFamily="34" charset="-120"/>
               </a:rPr>
-              <a:t>1.05B</a:t>
+              <a:t>~$1T</a:t>
             </a:r>
             <a:endParaRPr lang="en-US" sz="3100" dirty="0"/>
           </a:p>
@@ -4806,13 +4396,13 @@
       </p:sp>
       <p:sp>
         <p:nvSpPr>
-          <p:cNvPr id="7" name="Text 5"/>
-          <p:cNvSpPr/>
-          <p:nvPr/>
-        </p:nvSpPr>
-        <p:spPr>
-          <a:xfrm>
-            <a:off x="2359152" y="2414016"/>
+          <p:cNvPr id="11" name="Text 9"/>
+          <p:cNvSpPr/>
+          <p:nvPr/>
+        </p:nvSpPr>
+        <p:spPr>
+          <a:xfrm>
+            <a:off x="5724144" y="2414016"/>
             <a:ext cx="914400" cy="219456"/>
           </a:xfrm>
           <a:prstGeom prst="rect">
@@ -4833,13 +4423,13 @@
             <a:r>
               <a:rPr lang="en-US" sz="1000" b="1" dirty="0">
                 <a:solidFill>
-                  <a:srgbClr val="FFFFFF"/>
-                </a:solidFill>
-                <a:latin typeface="Aptos" pitchFamily="34" charset="0"/>
-                <a:ea typeface="Aptos" pitchFamily="34" charset="-122"/>
-                <a:cs typeface="Aptos" pitchFamily="34" charset="-120"/>
-              </a:rPr>
-              <a:t>tonnes</a:t>
+                  <a:srgbClr val="7C3AED"/>
+                </a:solidFill>
+                <a:latin typeface="Aptos" pitchFamily="34" charset="0"/>
+                <a:ea typeface="Aptos" pitchFamily="34" charset="-122"/>
+                <a:cs typeface="Aptos" pitchFamily="34" charset="-120"/>
+              </a:rPr>
+              <a:t>each year</a:t>
             </a:r>
             <a:endParaRPr lang="en-US" sz="1000" dirty="0"/>
           </a:p>
@@ -4847,13 +4437,13 @@
       </p:sp>
       <p:sp>
         <p:nvSpPr>
-          <p:cNvPr id="8" name="Text 6"/>
-          <p:cNvSpPr/>
-          <p:nvPr/>
-        </p:nvSpPr>
-        <p:spPr>
-          <a:xfrm>
-            <a:off x="841248" y="2852928"/>
+          <p:cNvPr id="12" name="Text 10"/>
+          <p:cNvSpPr/>
+          <p:nvPr/>
+        </p:nvSpPr>
+        <p:spPr>
+          <a:xfrm>
+            <a:off x="4206240" y="2852928"/>
             <a:ext cx="2468880" cy="530352"/>
           </a:xfrm>
           <a:prstGeom prst="rect">
@@ -4874,13 +4464,13 @@
             <a:r>
               <a:rPr lang="en-US" sz="1050" dirty="0">
                 <a:solidFill>
-                  <a:srgbClr val="CAD9D3"/>
-                </a:solidFill>
-                <a:latin typeface="Aptos" pitchFamily="34" charset="0"/>
-                <a:ea typeface="Aptos" pitchFamily="34" charset="-122"/>
-                <a:cs typeface="Aptos" pitchFamily="34" charset="-120"/>
-              </a:rPr>
-              <a:t>food waste generated at retail, food service and household level in 2022</a:t>
+                  <a:srgbClr val="667D75"/>
+                </a:solidFill>
+                <a:latin typeface="Aptos" pitchFamily="34" charset="0"/>
+                <a:ea typeface="Aptos" pitchFamily="34" charset="-122"/>
+                <a:cs typeface="Aptos" pitchFamily="34" charset="-120"/>
+              </a:rPr>
+              <a:t>estimated global economic toll of food loss and waste</a:t>
             </a:r>
             <a:endParaRPr lang="en-US" sz="1050" dirty="0"/>
           </a:p>
@@ -4888,13 +4478,13 @@
       </p:sp>
       <p:sp>
         <p:nvSpPr>
-          <p:cNvPr id="9" name="Shape 7"/>
-          <p:cNvSpPr/>
-          <p:nvPr/>
-        </p:nvSpPr>
-        <p:spPr>
-          <a:xfrm>
-            <a:off x="3986784" y="1975104"/>
+          <p:cNvPr id="13" name="Shape 11"/>
+          <p:cNvSpPr/>
+          <p:nvPr/>
+        </p:nvSpPr>
+        <p:spPr>
+          <a:xfrm>
+            <a:off x="7351776" y="1975104"/>
             <a:ext cx="2971800" cy="1627632"/>
           </a:xfrm>
           <a:prstGeom prst="roundRect">
@@ -4903,7 +4493,7 @@
             </a:avLst>
           </a:prstGeom>
           <a:solidFill>
-            <a:srgbClr val="F2ECFF"/>
+            <a:srgbClr val="FFF0E7"/>
           </a:solidFill>
           <a:ln w="12700">
             <a:solidFill>
@@ -4922,13 +4512,13 @@
       </p:sp>
       <p:sp>
         <p:nvSpPr>
-          <p:cNvPr id="10" name="Text 8"/>
-          <p:cNvSpPr/>
-          <p:nvPr/>
-        </p:nvSpPr>
-        <p:spPr>
-          <a:xfrm>
-            <a:off x="4206240" y="2212848"/>
+          <p:cNvPr id="14" name="Text 12"/>
+          <p:cNvSpPr/>
+          <p:nvPr/>
+        </p:nvSpPr>
+        <p:spPr>
+          <a:xfrm>
+            <a:off x="7571232" y="2212848"/>
             <a:ext cx="1600200" cy="502920"/>
           </a:xfrm>
           <a:prstGeom prst="rect">
@@ -4949,13 +4539,13 @@
             <a:r>
               <a:rPr lang="en-US" sz="3100" b="1" dirty="0">
                 <a:solidFill>
-                  <a:srgbClr val="7C3AED"/>
+                  <a:srgbClr val="F97316"/>
                 </a:solidFill>
                 <a:latin typeface="Aptos Display" pitchFamily="34" charset="0"/>
                 <a:ea typeface="Aptos Display" pitchFamily="34" charset="-122"/>
                 <a:cs typeface="Aptos Display" pitchFamily="34" charset="-120"/>
               </a:rPr>
-              <a:t>~$1T</a:t>
+              <a:t>8–10%</a:t>
             </a:r>
             <a:endParaRPr lang="en-US" sz="3100" dirty="0"/>
           </a:p>
@@ -4963,13 +4553,13 @@
       </p:sp>
       <p:sp>
         <p:nvSpPr>
-          <p:cNvPr id="11" name="Text 9"/>
-          <p:cNvSpPr/>
-          <p:nvPr/>
-        </p:nvSpPr>
-        <p:spPr>
-          <a:xfrm>
-            <a:off x="5724144" y="2414016"/>
+          <p:cNvPr id="15" name="Text 13"/>
+          <p:cNvSpPr/>
+          <p:nvPr/>
+        </p:nvSpPr>
+        <p:spPr>
+          <a:xfrm>
+            <a:off x="9089136" y="2414016"/>
             <a:ext cx="914400" cy="219456"/>
           </a:xfrm>
           <a:prstGeom prst="rect">
@@ -4990,13 +4580,13 @@
             <a:r>
               <a:rPr lang="en-US" sz="1000" b="1" dirty="0">
                 <a:solidFill>
-                  <a:srgbClr val="7C3AED"/>
-                </a:solidFill>
-                <a:latin typeface="Aptos" pitchFamily="34" charset="0"/>
-                <a:ea typeface="Aptos" pitchFamily="34" charset="-122"/>
-                <a:cs typeface="Aptos" pitchFamily="34" charset="-120"/>
-              </a:rPr>
-              <a:t>each year</a:t>
+                  <a:srgbClr val="F97316"/>
+                </a:solidFill>
+                <a:latin typeface="Aptos" pitchFamily="34" charset="0"/>
+                <a:ea typeface="Aptos" pitchFamily="34" charset="-122"/>
+                <a:cs typeface="Aptos" pitchFamily="34" charset="-120"/>
+              </a:rPr>
+              <a:t>of GHGs</a:t>
             </a:r>
             <a:endParaRPr lang="en-US" sz="1000" dirty="0"/>
           </a:p>
@@ -5004,13 +4594,13 @@
       </p:sp>
       <p:sp>
         <p:nvSpPr>
-          <p:cNvPr id="12" name="Text 10"/>
-          <p:cNvSpPr/>
-          <p:nvPr/>
-        </p:nvSpPr>
-        <p:spPr>
-          <a:xfrm>
-            <a:off x="4206240" y="2852928"/>
+          <p:cNvPr id="16" name="Text 14"/>
+          <p:cNvSpPr/>
+          <p:nvPr/>
+        </p:nvSpPr>
+        <p:spPr>
+          <a:xfrm>
+            <a:off x="7571232" y="2852928"/>
             <a:ext cx="2468880" cy="530352"/>
           </a:xfrm>
           <a:prstGeom prst="rect">
@@ -5037,7 +4627,7 @@
                 <a:ea typeface="Aptos" pitchFamily="34" charset="-122"/>
                 <a:cs typeface="Aptos" pitchFamily="34" charset="-120"/>
               </a:rPr>
-              <a:t>estimated global economic toll of food loss and waste</a:t>
+              <a:t>annual global emissions attributed to food loss and waste</a:t>
             </a:r>
             <a:endParaRPr lang="en-US" sz="1050" dirty="0"/>
           </a:p>
@@ -5045,22 +4635,244 @@
       </p:sp>
       <p:sp>
         <p:nvSpPr>
-          <p:cNvPr id="13" name="Shape 11"/>
-          <p:cNvSpPr/>
-          <p:nvPr/>
-        </p:nvSpPr>
-        <p:spPr>
-          <a:xfrm>
-            <a:off x="7351776" y="1975104"/>
-            <a:ext cx="2971800" cy="1627632"/>
+          <p:cNvPr id="17" name="Shape 15"/>
+          <p:cNvSpPr/>
+          <p:nvPr/>
+        </p:nvSpPr>
+        <p:spPr>
+          <a:xfrm>
+            <a:off x="621792" y="3858768"/>
+            <a:ext cx="5349240" cy="1444752"/>
           </a:xfrm>
           <a:prstGeom prst="roundRect">
             <a:avLst>
-              <a:gd name="adj" fmla="val 12921"/>
+              <a:gd name="adj" fmla="val 14557"/>
             </a:avLst>
           </a:prstGeom>
           <a:solidFill>
-            <a:srgbClr val="FFF0E7"/>
+            <a:srgbClr val="173D31"/>
+          </a:solidFill>
+          <a:ln w="12700">
+            <a:solidFill>
+              <a:srgbClr val="173D31">
+                <a:alpha val="0"/>
+              </a:srgbClr>
+            </a:solidFill>
+            <a:prstDash val="solid"/>
+          </a:ln>
+        </p:spPr>
+      </p:sp>
+      <p:sp>
+        <p:nvSpPr>
+          <p:cNvPr id="18" name="Text 16"/>
+          <p:cNvSpPr/>
+          <p:nvPr/>
+        </p:nvSpPr>
+        <p:spPr>
+          <a:xfrm>
+            <a:off x="914400" y="4114800"/>
+            <a:ext cx="1207008" cy="502920"/>
+          </a:xfrm>
+          <a:prstGeom prst="rect">
+            <a:avLst/>
+          </a:prstGeom>
+          <a:noFill/>
+          <a:ln/>
+        </p:spPr>
+        <p:txBody>
+          <a:bodyPr wrap="square" lIns="0" tIns="0" rIns="0" bIns="0" rtlCol="0" anchor="ctr">
+            <a:normAutofit/>
+          </a:bodyPr>
+          <a:lstStyle/>
+          <a:p>
+            <a:pPr algn="l" indent="0" marL="0">
+              <a:buNone/>
+            </a:pPr>
+            <a:r>
+              <a:rPr lang="en-US" sz="3100" b="1" dirty="0">
+                <a:solidFill>
+                  <a:srgbClr val="BEF264"/>
+                </a:solidFill>
+                <a:latin typeface="Aptos Display" pitchFamily="34" charset="0"/>
+                <a:ea typeface="Aptos Display" pitchFamily="34" charset="-122"/>
+                <a:cs typeface="Aptos Display" pitchFamily="34" charset="-120"/>
+              </a:rPr>
+              <a:t>12%</a:t>
+            </a:r>
+            <a:endParaRPr lang="en-US" sz="3100" dirty="0"/>
+          </a:p>
+        </p:txBody>
+      </p:sp>
+      <p:sp>
+        <p:nvSpPr>
+          <p:cNvPr id="19" name="Text 17"/>
+          <p:cNvSpPr/>
+          <p:nvPr/>
+        </p:nvSpPr>
+        <p:spPr>
+          <a:xfrm>
+            <a:off x="2057400" y="4142232"/>
+            <a:ext cx="3401568" cy="292608"/>
+          </a:xfrm>
+          <a:prstGeom prst="rect">
+            <a:avLst/>
+          </a:prstGeom>
+          <a:noFill/>
+          <a:ln/>
+        </p:spPr>
+        <p:txBody>
+          <a:bodyPr wrap="square" lIns="0" tIns="0" rIns="0" bIns="0" rtlCol="0" anchor="ctr">
+            <a:normAutofit/>
+          </a:bodyPr>
+          <a:lstStyle/>
+          <a:p>
+            <a:pPr algn="l" indent="0" marL="0">
+              <a:buNone/>
+            </a:pPr>
+            <a:r>
+              <a:rPr lang="en-US" sz="1400" b="1" dirty="0">
+                <a:solidFill>
+                  <a:srgbClr val="FFFFFF"/>
+                </a:solidFill>
+                <a:latin typeface="Aptos" pitchFamily="34" charset="0"/>
+                <a:ea typeface="Aptos" pitchFamily="34" charset="-122"/>
+                <a:cs typeface="Aptos" pitchFamily="34" charset="-120"/>
+              </a:rPr>
+              <a:t>of 2022 food waste occurred at retail.</a:t>
+            </a:r>
+            <a:endParaRPr lang="en-US" sz="1400" dirty="0"/>
+          </a:p>
+        </p:txBody>
+      </p:sp>
+      <p:sp>
+        <p:nvSpPr>
+          <p:cNvPr id="20" name="Shape 18"/>
+          <p:cNvSpPr/>
+          <p:nvPr/>
+        </p:nvSpPr>
+        <p:spPr>
+          <a:xfrm>
+            <a:off x="914400" y="4718304"/>
+            <a:ext cx="868680" cy="292608"/>
+          </a:xfrm>
+          <a:prstGeom prst="roundRect">
+            <a:avLst>
+              <a:gd name="adj" fmla="val 50000"/>
+            </a:avLst>
+          </a:prstGeom>
+          <a:solidFill>
+            <a:srgbClr val="2B5548"/>
+          </a:solidFill>
+          <a:ln w="12700">
+            <a:solidFill>
+              <a:srgbClr val="2B5548">
+                <a:alpha val="0"/>
+              </a:srgbClr>
+            </a:solidFill>
+            <a:prstDash val="solid"/>
+          </a:ln>
+        </p:spPr>
+      </p:sp>
+      <p:sp>
+        <p:nvSpPr>
+          <p:cNvPr id="21" name="Text 19"/>
+          <p:cNvSpPr/>
+          <p:nvPr/>
+        </p:nvSpPr>
+        <p:spPr>
+          <a:xfrm>
+            <a:off x="987552" y="4718304"/>
+            <a:ext cx="722376" cy="292608"/>
+          </a:xfrm>
+          <a:prstGeom prst="rect">
+            <a:avLst/>
+          </a:prstGeom>
+          <a:noFill/>
+          <a:ln/>
+        </p:spPr>
+        <p:txBody>
+          <a:bodyPr wrap="square" lIns="0" tIns="0" rIns="0" bIns="0" rtlCol="0" anchor="ctr">
+            <a:normAutofit/>
+          </a:bodyPr>
+          <a:lstStyle/>
+          <a:p>
+            <a:pPr algn="ctr" indent="0" marL="0">
+              <a:buNone/>
+            </a:pPr>
+            <a:r>
+              <a:rPr lang="en-US" sz="900" b="1" dirty="0">
+                <a:solidFill>
+                  <a:srgbClr val="BEF264"/>
+                </a:solidFill>
+                <a:latin typeface="Aptos" pitchFamily="34" charset="0"/>
+                <a:ea typeface="Aptos" pitchFamily="34" charset="-122"/>
+                <a:cs typeface="Aptos" pitchFamily="34" charset="-120"/>
+              </a:rPr>
+              <a:t>OUR WEDGE</a:t>
+            </a:r>
+            <a:endParaRPr lang="en-US" sz="900" dirty="0"/>
+          </a:p>
+        </p:txBody>
+      </p:sp>
+      <p:sp>
+        <p:nvSpPr>
+          <p:cNvPr id="22" name="Text 20"/>
+          <p:cNvSpPr/>
+          <p:nvPr/>
+        </p:nvSpPr>
+        <p:spPr>
+          <a:xfrm>
+            <a:off x="1965960" y="4690872"/>
+            <a:ext cx="3456432" cy="310896"/>
+          </a:xfrm>
+          <a:prstGeom prst="rect">
+            <a:avLst/>
+          </a:prstGeom>
+          <a:noFill/>
+          <a:ln/>
+        </p:spPr>
+        <p:txBody>
+          <a:bodyPr wrap="square" lIns="0" tIns="0" rIns="0" bIns="0" rtlCol="0" anchor="ctr">
+            <a:normAutofit/>
+          </a:bodyPr>
+          <a:lstStyle/>
+          <a:p>
+            <a:pPr algn="l" indent="0" marL="0">
+              <a:buNone/>
+            </a:pPr>
+            <a:r>
+              <a:rPr lang="en-US" sz="1050" dirty="0">
+                <a:solidFill>
+                  <a:srgbClr val="C5D7D0"/>
+                </a:solidFill>
+                <a:latin typeface="Aptos" pitchFamily="34" charset="0"/>
+                <a:ea typeface="Aptos" pitchFamily="34" charset="-122"/>
+                <a:cs typeface="Aptos" pitchFamily="34" charset="-120"/>
+              </a:rPr>
+              <a:t>Independent grocers making product-level decisions every day.</a:t>
+            </a:r>
+            <a:endParaRPr lang="en-US" sz="1050" dirty="0"/>
+          </a:p>
+        </p:txBody>
+      </p:sp>
+      <p:sp>
+        <p:nvSpPr>
+          <p:cNvPr id="23" name="Shape 21"/>
+          <p:cNvSpPr/>
+          <p:nvPr/>
+        </p:nvSpPr>
+        <p:spPr>
+          <a:xfrm>
+            <a:off x="6199632" y="3858768"/>
+            <a:ext cx="5330952" cy="1444752"/>
+          </a:xfrm>
+          <a:prstGeom prst="roundRect">
+            <a:avLst>
+              <a:gd name="adj" fmla="val 14557"/>
+            </a:avLst>
+          </a:prstGeom>
+          <a:solidFill>
+            <a:srgbClr val="FFFFFF"/>
           </a:solidFill>
           <a:ln w="12700">
             <a:solidFill>
@@ -5072,385 +4884,6 @@
             <a:outerShdw sx="100000" sy="100000" kx="0" ky="0" algn="bl" rotWithShape="0" blurRad="52028928200000000" dist="104057856400000000" dir="583200000000000000000">
               <a:srgbClr val="0A241C">
                 <a:alpha val="13000000000000000000"/>
-              </a:srgbClr>
-            </a:outerShdw>
-          </a:effectLst>
-        </p:spPr>
-      </p:sp>
-      <p:sp>
-        <p:nvSpPr>
-          <p:cNvPr id="14" name="Text 12"/>
-          <p:cNvSpPr/>
-          <p:nvPr/>
-        </p:nvSpPr>
-        <p:spPr>
-          <a:xfrm>
-            <a:off x="7571232" y="2212848"/>
-            <a:ext cx="1600200" cy="502920"/>
-          </a:xfrm>
-          <a:prstGeom prst="rect">
-            <a:avLst/>
-          </a:prstGeom>
-          <a:noFill/>
-          <a:ln/>
-        </p:spPr>
-        <p:txBody>
-          <a:bodyPr wrap="square" lIns="0" tIns="0" rIns="0" bIns="0" rtlCol="0" anchor="ctr">
-            <a:normAutofit/>
-          </a:bodyPr>
-          <a:lstStyle/>
-          <a:p>
-            <a:pPr algn="l" indent="0" marL="0">
-              <a:buNone/>
-            </a:pPr>
-            <a:r>
-              <a:rPr lang="en-US" sz="3100" b="1" dirty="0">
-                <a:solidFill>
-                  <a:srgbClr val="F97316"/>
-                </a:solidFill>
-                <a:latin typeface="Aptos Display" pitchFamily="34" charset="0"/>
-                <a:ea typeface="Aptos Display" pitchFamily="34" charset="-122"/>
-                <a:cs typeface="Aptos Display" pitchFamily="34" charset="-120"/>
-              </a:rPr>
-              <a:t>8–10%</a:t>
-            </a:r>
-            <a:endParaRPr lang="en-US" sz="3100" dirty="0"/>
-          </a:p>
-        </p:txBody>
-      </p:sp>
-      <p:sp>
-        <p:nvSpPr>
-          <p:cNvPr id="15" name="Text 13"/>
-          <p:cNvSpPr/>
-          <p:nvPr/>
-        </p:nvSpPr>
-        <p:spPr>
-          <a:xfrm>
-            <a:off x="9089136" y="2414016"/>
-            <a:ext cx="914400" cy="219456"/>
-          </a:xfrm>
-          <a:prstGeom prst="rect">
-            <a:avLst/>
-          </a:prstGeom>
-          <a:noFill/>
-          <a:ln/>
-        </p:spPr>
-        <p:txBody>
-          <a:bodyPr wrap="square" lIns="0" tIns="0" rIns="0" bIns="0" rtlCol="0" anchor="ctr">
-            <a:normAutofit/>
-          </a:bodyPr>
-          <a:lstStyle/>
-          <a:p>
-            <a:pPr algn="r" indent="0" marL="0">
-              <a:buNone/>
-            </a:pPr>
-            <a:r>
-              <a:rPr lang="en-US" sz="1000" b="1" dirty="0">
-                <a:solidFill>
-                  <a:srgbClr val="F97316"/>
-                </a:solidFill>
-                <a:latin typeface="Aptos" pitchFamily="34" charset="0"/>
-                <a:ea typeface="Aptos" pitchFamily="34" charset="-122"/>
-                <a:cs typeface="Aptos" pitchFamily="34" charset="-120"/>
-              </a:rPr>
-              <a:t>of GHGs</a:t>
-            </a:r>
-            <a:endParaRPr lang="en-US" sz="1000" dirty="0"/>
-          </a:p>
-        </p:txBody>
-      </p:sp>
-      <p:sp>
-        <p:nvSpPr>
-          <p:cNvPr id="16" name="Text 14"/>
-          <p:cNvSpPr/>
-          <p:nvPr/>
-        </p:nvSpPr>
-        <p:spPr>
-          <a:xfrm>
-            <a:off x="7571232" y="2852928"/>
-            <a:ext cx="2468880" cy="530352"/>
-          </a:xfrm>
-          <a:prstGeom prst="rect">
-            <a:avLst/>
-          </a:prstGeom>
-          <a:noFill/>
-          <a:ln/>
-        </p:spPr>
-        <p:txBody>
-          <a:bodyPr wrap="square" lIns="0" tIns="0" rIns="0" bIns="0" rtlCol="0" anchor="t">
-            <a:normAutofit/>
-          </a:bodyPr>
-          <a:lstStyle/>
-          <a:p>
-            <a:pPr algn="l" indent="0" marL="0">
-              <a:buNone/>
-            </a:pPr>
-            <a:r>
-              <a:rPr lang="en-US" sz="1050" dirty="0">
-                <a:solidFill>
-                  <a:srgbClr val="667D75"/>
-                </a:solidFill>
-                <a:latin typeface="Aptos" pitchFamily="34" charset="0"/>
-                <a:ea typeface="Aptos" pitchFamily="34" charset="-122"/>
-                <a:cs typeface="Aptos" pitchFamily="34" charset="-120"/>
-              </a:rPr>
-              <a:t>annual global emissions attributed to food loss and waste</a:t>
-            </a:r>
-            <a:endParaRPr lang="en-US" sz="1050" dirty="0"/>
-          </a:p>
-        </p:txBody>
-      </p:sp>
-      <p:sp>
-        <p:nvSpPr>
-          <p:cNvPr id="17" name="Shape 15"/>
-          <p:cNvSpPr/>
-          <p:nvPr/>
-        </p:nvSpPr>
-        <p:spPr>
-          <a:xfrm>
-            <a:off x="621792" y="3858768"/>
-            <a:ext cx="5349240" cy="1444752"/>
-          </a:xfrm>
-          <a:prstGeom prst="roundRect">
-            <a:avLst>
-              <a:gd name="adj" fmla="val 14557"/>
-            </a:avLst>
-          </a:prstGeom>
-          <a:solidFill>
-            <a:srgbClr val="173D31"/>
-          </a:solidFill>
-          <a:ln w="12700">
-            <a:solidFill>
-              <a:srgbClr val="173D31">
-                <a:alpha val="0"/>
-              </a:srgbClr>
-            </a:solidFill>
-            <a:prstDash val="solid"/>
-          </a:ln>
-        </p:spPr>
-      </p:sp>
-      <p:sp>
-        <p:nvSpPr>
-          <p:cNvPr id="18" name="Text 16"/>
-          <p:cNvSpPr/>
-          <p:nvPr/>
-        </p:nvSpPr>
-        <p:spPr>
-          <a:xfrm>
-            <a:off x="914400" y="4114800"/>
-            <a:ext cx="1207008" cy="502920"/>
-          </a:xfrm>
-          <a:prstGeom prst="rect">
-            <a:avLst/>
-          </a:prstGeom>
-          <a:noFill/>
-          <a:ln/>
-        </p:spPr>
-        <p:txBody>
-          <a:bodyPr wrap="square" lIns="0" tIns="0" rIns="0" bIns="0" rtlCol="0" anchor="ctr">
-            <a:normAutofit/>
-          </a:bodyPr>
-          <a:lstStyle/>
-          <a:p>
-            <a:pPr algn="l" indent="0" marL="0">
-              <a:buNone/>
-            </a:pPr>
-            <a:r>
-              <a:rPr lang="en-US" sz="3100" b="1" dirty="0">
-                <a:solidFill>
-                  <a:srgbClr val="BEF264"/>
-                </a:solidFill>
-                <a:latin typeface="Aptos Display" pitchFamily="34" charset="0"/>
-                <a:ea typeface="Aptos Display" pitchFamily="34" charset="-122"/>
-                <a:cs typeface="Aptos Display" pitchFamily="34" charset="-120"/>
-              </a:rPr>
-              <a:t>12%</a:t>
-            </a:r>
-            <a:endParaRPr lang="en-US" sz="3100" dirty="0"/>
-          </a:p>
-        </p:txBody>
-      </p:sp>
-      <p:sp>
-        <p:nvSpPr>
-          <p:cNvPr id="19" name="Text 17"/>
-          <p:cNvSpPr/>
-          <p:nvPr/>
-        </p:nvSpPr>
-        <p:spPr>
-          <a:xfrm>
-            <a:off x="2057400" y="4142232"/>
-            <a:ext cx="3401568" cy="292608"/>
-          </a:xfrm>
-          <a:prstGeom prst="rect">
-            <a:avLst/>
-          </a:prstGeom>
-          <a:noFill/>
-          <a:ln/>
-        </p:spPr>
-        <p:txBody>
-          <a:bodyPr wrap="square" lIns="0" tIns="0" rIns="0" bIns="0" rtlCol="0" anchor="ctr">
-            <a:normAutofit/>
-          </a:bodyPr>
-          <a:lstStyle/>
-          <a:p>
-            <a:pPr algn="l" indent="0" marL="0">
-              <a:buNone/>
-            </a:pPr>
-            <a:r>
-              <a:rPr lang="en-US" sz="1400" b="1" dirty="0">
-                <a:solidFill>
-                  <a:srgbClr val="FFFFFF"/>
-                </a:solidFill>
-                <a:latin typeface="Aptos" pitchFamily="34" charset="0"/>
-                <a:ea typeface="Aptos" pitchFamily="34" charset="-122"/>
-                <a:cs typeface="Aptos" pitchFamily="34" charset="-120"/>
-              </a:rPr>
-              <a:t>of 2022 food waste occurred at retail.</a:t>
-            </a:r>
-            <a:endParaRPr lang="en-US" sz="1400" dirty="0"/>
-          </a:p>
-        </p:txBody>
-      </p:sp>
-      <p:sp>
-        <p:nvSpPr>
-          <p:cNvPr id="20" name="Shape 18"/>
-          <p:cNvSpPr/>
-          <p:nvPr/>
-        </p:nvSpPr>
-        <p:spPr>
-          <a:xfrm>
-            <a:off x="914400" y="4718304"/>
-            <a:ext cx="868680" cy="292608"/>
-          </a:xfrm>
-          <a:prstGeom prst="roundRect">
-            <a:avLst>
-              <a:gd name="adj" fmla="val 50000"/>
-            </a:avLst>
-          </a:prstGeom>
-          <a:solidFill>
-            <a:srgbClr val="2B5548"/>
-          </a:solidFill>
-          <a:ln w="12700">
-            <a:solidFill>
-              <a:srgbClr val="2B5548">
-                <a:alpha val="0"/>
-              </a:srgbClr>
-            </a:solidFill>
-            <a:prstDash val="solid"/>
-          </a:ln>
-        </p:spPr>
-      </p:sp>
-      <p:sp>
-        <p:nvSpPr>
-          <p:cNvPr id="21" name="Text 19"/>
-          <p:cNvSpPr/>
-          <p:nvPr/>
-        </p:nvSpPr>
-        <p:spPr>
-          <a:xfrm>
-            <a:off x="987552" y="4718304"/>
-            <a:ext cx="722376" cy="292608"/>
-          </a:xfrm>
-          <a:prstGeom prst="rect">
-            <a:avLst/>
-          </a:prstGeom>
-          <a:noFill/>
-          <a:ln/>
-        </p:spPr>
-        <p:txBody>
-          <a:bodyPr wrap="square" lIns="0" tIns="0" rIns="0" bIns="0" rtlCol="0" anchor="ctr">
-            <a:normAutofit/>
-          </a:bodyPr>
-          <a:lstStyle/>
-          <a:p>
-            <a:pPr algn="ctr" indent="0" marL="0">
-              <a:buNone/>
-            </a:pPr>
-            <a:r>
-              <a:rPr lang="en-US" sz="900" b="1" dirty="0">
-                <a:solidFill>
-                  <a:srgbClr val="BEF264"/>
-                </a:solidFill>
-                <a:latin typeface="Aptos" pitchFamily="34" charset="0"/>
-                <a:ea typeface="Aptos" pitchFamily="34" charset="-122"/>
-                <a:cs typeface="Aptos" pitchFamily="34" charset="-120"/>
-              </a:rPr>
-              <a:t>OUR WEDGE</a:t>
-            </a:r>
-            <a:endParaRPr lang="en-US" sz="900" dirty="0"/>
-          </a:p>
-        </p:txBody>
-      </p:sp>
-      <p:sp>
-        <p:nvSpPr>
-          <p:cNvPr id="22" name="Text 20"/>
-          <p:cNvSpPr/>
-          <p:nvPr/>
-        </p:nvSpPr>
-        <p:spPr>
-          <a:xfrm>
-            <a:off x="1965960" y="4690872"/>
-            <a:ext cx="3456432" cy="310896"/>
-          </a:xfrm>
-          <a:prstGeom prst="rect">
-            <a:avLst/>
-          </a:prstGeom>
-          <a:noFill/>
-          <a:ln/>
-        </p:spPr>
-        <p:txBody>
-          <a:bodyPr wrap="square" lIns="0" tIns="0" rIns="0" bIns="0" rtlCol="0" anchor="ctr">
-            <a:normAutofit/>
-          </a:bodyPr>
-          <a:lstStyle/>
-          <a:p>
-            <a:pPr algn="l" indent="0" marL="0">
-              <a:buNone/>
-            </a:pPr>
-            <a:r>
-              <a:rPr lang="en-US" sz="1050" dirty="0">
-                <a:solidFill>
-                  <a:srgbClr val="C5D7D0"/>
-                </a:solidFill>
-                <a:latin typeface="Aptos" pitchFamily="34" charset="0"/>
-                <a:ea typeface="Aptos" pitchFamily="34" charset="-122"/>
-                <a:cs typeface="Aptos" pitchFamily="34" charset="-120"/>
-              </a:rPr>
-              <a:t>Independent grocers making product-level decisions every day.</a:t>
-            </a:r>
-            <a:endParaRPr lang="en-US" sz="1050" dirty="0"/>
-          </a:p>
-        </p:txBody>
-      </p:sp>
-      <p:sp>
-        <p:nvSpPr>
-          <p:cNvPr id="23" name="Shape 21"/>
-          <p:cNvSpPr/>
-          <p:nvPr/>
-        </p:nvSpPr>
-        <p:spPr>
-          <a:xfrm>
-            <a:off x="6199632" y="3858768"/>
-            <a:ext cx="5330952" cy="1444752"/>
-          </a:xfrm>
-          <a:prstGeom prst="roundRect">
-            <a:avLst>
-              <a:gd name="adj" fmla="val 14557"/>
-            </a:avLst>
-          </a:prstGeom>
-          <a:solidFill>
-            <a:srgbClr val="FFFFFF"/>
-          </a:solidFill>
-          <a:ln w="12700">
-            <a:solidFill>
-              <a:srgbClr val="D9E3DD"/>
-            </a:solidFill>
-            <a:prstDash val="solid"/>
-          </a:ln>
-          <a:effectLst>
-            <a:outerShdw sx="100000" sy="100000" kx="0" ky="0" algn="bl" rotWithShape="0" blurRad="660767388140000000000" dist="1.32153477628e+21" dir="3.4992e+25">
-              <a:srgbClr val="0A241C">
-                <a:alpha val="1.3e+24"/>
               </a:srgbClr>
             </a:outerShdw>
           </a:effectLst>
@@ -6570,9 +6003,9 @@
             <a:prstDash val="solid"/>
           </a:ln>
           <a:effectLst>
-            <a:outerShdw sx="100000" sy="100000" kx="0" ky="0" algn="bl" rotWithShape="0" blurRad="8.391745829378e+24" dist="1.6783491658756e+25" dir="2.09952e+30">
+            <a:outerShdw sx="100000" sy="100000" kx="0" ky="0" algn="bl" rotWithShape="0" blurRad="660767388140000000000" dist="1.32153477628e+21" dir="3.4992e+25">
               <a:srgbClr val="0A241C">
-                <a:alpha val="1.3e+29"/>
+                <a:alpha val="1.3e+24"/>
               </a:srgbClr>
             </a:outerShdw>
           </a:effectLst>
@@ -6820,9 +6253,9 @@
             <a:prstDash val="solid"/>
           </a:ln>
           <a:effectLst>
-            <a:outerShdw sx="100000" sy="100000" kx="0" ky="0" algn="bl" rotWithShape="0" blurRad="1.0657517203310059e+29" dist="2.1315034406620118e+29" dir="1.259712e+35">
+            <a:outerShdw sx="100000" sy="100000" kx="0" ky="0" algn="bl" rotWithShape="0" blurRad="8.391745829378e+24" dist="1.6783491658756e+25" dir="2.09952e+30">
               <a:srgbClr val="0A241C">
-                <a:alpha val="1.3e+34"/>
+                <a:alpha val="1.3e+29"/>
               </a:srgbClr>
             </a:outerShdw>
           </a:effectLst>
@@ -8046,9 +7479,9 @@
             <a:prstDash val="solid"/>
           </a:ln>
           <a:effectLst>
-            <a:outerShdw sx="100000" sy="100000" kx="0" ky="0" algn="bl" rotWithShape="0" blurRad="1.3535046848203775e+33" dist="2.707009369640755e+33" dir="7.558272e+39">
+            <a:outerShdw sx="100000" sy="100000" kx="0" ky="0" algn="bl" rotWithShape="0" blurRad="1.0657517203310059e+29" dist="2.1315034406620118e+29" dir="1.259712e+35">
               <a:srgbClr val="0A241C">
-                <a:alpha val="1.3e+39"/>
+                <a:alpha val="1.3e+34"/>
               </a:srgbClr>
             </a:outerShdw>
           </a:effectLst>
@@ -9197,9 +8630,9 @@
             <a:prstDash val="solid"/>
           </a:ln>
           <a:effectLst>
-            <a:outerShdw sx="100000" sy="100000" kx="0" ky="0" algn="bl" rotWithShape="0" blurRad="1.7189509497218795e+37" dist="3.437901899443759e+37" dir="4.5349632000000006e+44">
+            <a:outerShdw sx="100000" sy="100000" kx="0" ky="0" algn="bl" rotWithShape="0" blurRad="1.3535046848203775e+33" dist="2.707009369640755e+33" dir="7.558272e+39">
               <a:srgbClr val="0A241C">
-                <a:alpha val="1.3e+44"/>
+                <a:alpha val="1.3e+39"/>
               </a:srgbClr>
             </a:outerShdw>
           </a:effectLst>
@@ -11611,9 +11044,9 @@
             <a:prstDash val="solid"/>
           </a:ln>
           <a:effectLst>
-            <a:outerShdw sx="100000" sy="100000" kx="0" ky="0" algn="bl" rotWithShape="0" blurRad="2.183067706146787e+41" dist="4.366135412293574e+41" dir="2.72097792e+49">
+            <a:outerShdw sx="100000" sy="100000" kx="0" ky="0" algn="bl" rotWithShape="0" blurRad="1.7189509497218795e+37" dist="3.437901899443759e+37" dir="4.5349632000000006e+44">
               <a:srgbClr val="0A241C">
-                <a:alpha val="1.3e+49"/>
+                <a:alpha val="1.3e+44"/>
               </a:srgbClr>
             </a:outerShdw>
           </a:effectLst>
@@ -12237,9 +11670,9 @@
             <a:prstDash val="solid"/>
           </a:ln>
           <a:effectLst>
-            <a:outerShdw sx="100000" sy="100000" kx="0" ky="0" algn="bl" rotWithShape="0" blurRad="2.7724959868064195e+45" dist="5.544991973612839e+45" dir="1.6325867520000003e+54">
+            <a:outerShdw sx="100000" sy="100000" kx="0" ky="0" algn="bl" rotWithShape="0" blurRad="2.183067706146787e+41" dist="4.366135412293574e+41" dir="2.72097792e+49">
               <a:srgbClr val="0A241C">
-                <a:alpha val="1.2999999999999999e+54"/>
+                <a:alpha val="1.3e+49"/>
               </a:srgbClr>
             </a:outerShdw>
           </a:effectLst>
@@ -13206,9 +12639,9 @@
             <a:prstDash val="solid"/>
           </a:ln>
           <a:effectLst>
-            <a:outerShdw sx="100000" sy="100000" kx="0" ky="0" algn="bl" rotWithShape="0" blurRad="3.5210699032441527e+49" dist="7.042139806488305e+49" dir="9.795520512000002e+58">
+            <a:outerShdw sx="100000" sy="100000" kx="0" ky="0" algn="bl" rotWithShape="0" blurRad="2.7724959868064195e+45" dist="5.544991973612839e+45" dir="1.6325867520000003e+54">
               <a:srgbClr val="0A241C">
-                <a:alpha val="1.2999999999999998e+59"/>
+                <a:alpha val="1.2999999999999999e+54"/>
               </a:srgbClr>
             </a:outerShdw>
           </a:effectLst>
@@ -18388,9 +17821,9 @@
             <a:prstDash val="solid"/>
           </a:ln>
           <a:effectLst>
-            <a:outerShdw sx="100000" sy="100000" kx="0" ky="0" algn="bl" rotWithShape="0" blurRad="4.471758777120074e+53" dist="8.943517554240149e+53" dir="5.877312307200001e+63">
+            <a:outerShdw sx="100000" sy="100000" kx="0" ky="0" algn="bl" rotWithShape="0" blurRad="3.5210699032441527e+49" dist="7.042139806488305e+49" dir="9.795520512000002e+58">
               <a:srgbClr val="0A241C">
-                <a:alpha val="1.2999999999999998e+64"/>
+                <a:alpha val="1.2999999999999998e+59"/>
               </a:srgbClr>
             </a:outerShdw>
           </a:effectLst>
@@ -18920,9 +18353,9 @@
             <a:prstDash val="solid"/>
           </a:ln>
           <a:effectLst>
-            <a:outerShdw sx="100000" sy="100000" kx="0" ky="0" algn="bl" rotWithShape="0" blurRad="5.679133646942494e+57" dist="1.1358267293884988e+58" dir="3.526387384320001e+68">
+            <a:outerShdw sx="100000" sy="100000" kx="0" ky="0" algn="bl" rotWithShape="0" blurRad="4.471758777120074e+53" dist="8.943517554240149e+53" dir="5.877312307200001e+63">
               <a:srgbClr val="0A241C">
-                <a:alpha val="1.2999999999999999e+69"/>
+                <a:alpha val="1.2999999999999998e+64"/>
               </a:srgbClr>
             </a:outerShdw>
           </a:effectLst>

</xml_diff>

<commit_message>
docs: clarify AI roles in presentation
</commit_message>
<xml_diff>
--- a/docs/deck/FreshSaver-AI-Builders-Hackathon.pptx
+++ b/docs/deck/FreshSaver-AI-Builders-Hackathon.pptx
@@ -951,7 +951,7 @@
           <a:p>
             <a:r>
               <a:rPr lang="en-US" dirty="0"/>
-              <a:t>Lead with XGBoost as the live primary AI. Gemini is an evidence-grounded adapter with a safe template fallback; it never calculates prices.</a:t>
+              <a:t>Say this explicitly: We use XGBoost because pricing demand is a nonlinear tabular prediction problem. We use Gemini because explanations and campaigns are language tasks. The optimizer is not AI; it is deterministic policy that enforces business and safety rules. The owner remains the final authority. XGBoost is live. Gemini is optional and has a template fallback.</a:t>
             </a:r>
             <a:endParaRPr lang="en-US" dirty="0"/>
           </a:p>
@@ -9439,7 +9439,7 @@
                 <a:ea typeface="Aptos" pitchFamily="34" charset="-122"/>
                 <a:cs typeface="Aptos" pitchFamily="34" charset="-120"/>
               </a:rPr>
-              <a:t>HYBRID AI ARCHITECTURE</a:t>
+              <a:t>WHAT AI WE USE — AND WHY</a:t>
             </a:r>
             <a:endParaRPr lang="en-US" sz="900" dirty="0"/>
           </a:p>
@@ -9480,7 +9480,7 @@
                 <a:ea typeface="Aptos Display" pitchFamily="34" charset="-122"/>
                 <a:cs typeface="Aptos Display" pitchFamily="34" charset="-120"/>
               </a:rPr>
-              <a:t>Use AI for uncertainty. Use policy for control.</a:t>
+              <a:t>Two AIs. Two jobs. One controlled decision.</a:t>
             </a:r>
             <a:endParaRPr lang="en-US" sz="2700" dirty="0"/>
           </a:p>
@@ -9521,7 +9521,7 @@
                 <a:ea typeface="Aptos" pitchFamily="34" charset="-122"/>
                 <a:cs typeface="Aptos" pitchFamily="34" charset="-120"/>
               </a:rPr>
-              <a:t>Prediction, optimization, generation, and human review are intentionally separated.</a:t>
+              <a:t>XGBoost handles numerical uncertainty. Gemini handles language. Neither gets unchecked authority.</a:t>
             </a:r>
             <a:endParaRPr lang="en-US" sz="1250" dirty="0"/>
           </a:p>
@@ -9535,8 +9535,8 @@
         </p:nvSpPr>
         <p:spPr>
           <a:xfrm>
-            <a:off x="621792" y="2194560"/>
-            <a:ext cx="2359152" cy="2606040"/>
+            <a:off x="621792" y="2103120"/>
+            <a:ext cx="2359152" cy="2907792"/>
           </a:xfrm>
           <a:prstGeom prst="roundRect">
             <a:avLst>
@@ -9562,8 +9562,8 @@
         </p:nvSpPr>
         <p:spPr>
           <a:xfrm>
-            <a:off x="841248" y="2468880"/>
-            <a:ext cx="438912" cy="438912"/>
+            <a:off x="822960" y="2350008"/>
+            <a:ext cx="420624" cy="420624"/>
           </a:xfrm>
           <a:prstGeom prst="ellipse">
             <a:avLst/>
@@ -9587,8 +9587,8 @@
         </p:nvSpPr>
         <p:spPr>
           <a:xfrm>
-            <a:off x="841248" y="2468880"/>
-            <a:ext cx="438912" cy="438912"/>
+            <a:off x="822960" y="2350008"/>
+            <a:ext cx="420624" cy="420624"/>
           </a:xfrm>
           <a:prstGeom prst="rect">
             <a:avLst/>
@@ -9606,7 +9606,7 @@
               <a:buNone/>
             </a:pPr>
             <a:r>
-              <a:rPr lang="en-US" sz="1300" b="1" dirty="0">
+              <a:rPr lang="en-US" sz="1200" b="1" dirty="0">
                 <a:solidFill>
                   <a:srgbClr val="FFFFFF"/>
                 </a:solidFill>
@@ -9616,7 +9616,7 @@
               </a:rPr>
               <a:t>1</a:t>
             </a:r>
-            <a:endParaRPr lang="en-US" sz="1300" dirty="0"/>
+            <a:endParaRPr lang="en-US" sz="1200" dirty="0"/>
           </a:p>
         </p:txBody>
       </p:sp>
@@ -9628,26 +9628,26 @@
         </p:nvSpPr>
         <p:spPr>
           <a:xfrm>
-            <a:off x="1389888" y="2523744"/>
-            <a:ext cx="1170432" cy="182880"/>
-          </a:xfrm>
-          <a:prstGeom prst="rect">
-            <a:avLst/>
-          </a:prstGeom>
-          <a:noFill/>
-          <a:ln/>
-        </p:spPr>
-        <p:txBody>
-          <a:bodyPr wrap="square" lIns="0" tIns="0" rIns="0" bIns="0" rtlCol="0" anchor="ctr">
-            <a:normAutofit/>
-          </a:bodyPr>
-          <a:lstStyle/>
-          <a:p>
-            <a:pPr algn="l" indent="0" marL="0">
-              <a:buNone/>
-            </a:pPr>
-            <a:r>
-              <a:rPr lang="en-US" sz="800" b="1" spc="120" kern="0" dirty="0">
+            <a:off x="1344168" y="2395728"/>
+            <a:ext cx="1417320" cy="182880"/>
+          </a:xfrm>
+          <a:prstGeom prst="rect">
+            <a:avLst/>
+          </a:prstGeom>
+          <a:noFill/>
+          <a:ln/>
+        </p:spPr>
+        <p:txBody>
+          <a:bodyPr wrap="square" lIns="0" tIns="0" rIns="0" bIns="0" rtlCol="0" anchor="ctr">
+            <a:normAutofit/>
+          </a:bodyPr>
+          <a:lstStyle/>
+          <a:p>
+            <a:pPr algn="l" indent="0" marL="0">
+              <a:buNone/>
+            </a:pPr>
+            <a:r>
+              <a:rPr lang="en-US" sz="750" b="1" spc="75" kern="0" dirty="0">
                 <a:solidFill>
                   <a:srgbClr val="7C3AED"/>
                 </a:solidFill>
@@ -9655,9 +9655,9 @@
                 <a:ea typeface="Aptos" pitchFamily="34" charset="-122"/>
                 <a:cs typeface="Aptos" pitchFamily="34" charset="-120"/>
               </a:rPr>
-              <a:t>MODEL</a:t>
-            </a:r>
-            <a:endParaRPr lang="en-US" sz="800" dirty="0"/>
+              <a:t>AI #1 · PREDICTION</a:t>
+            </a:r>
+            <a:endParaRPr lang="en-US" sz="750" dirty="0"/>
           </a:p>
         </p:txBody>
       </p:sp>
@@ -9669,26 +9669,26 @@
         </p:nvSpPr>
         <p:spPr>
           <a:xfrm>
-            <a:off x="841248" y="3127248"/>
-            <a:ext cx="1901952" cy="365760"/>
-          </a:xfrm>
-          <a:prstGeom prst="rect">
-            <a:avLst/>
-          </a:prstGeom>
-          <a:noFill/>
-          <a:ln/>
-        </p:spPr>
-        <p:txBody>
-          <a:bodyPr wrap="square" lIns="0" tIns="0" rIns="0" bIns="0" rtlCol="0" anchor="ctr">
-            <a:normAutofit/>
-          </a:bodyPr>
-          <a:lstStyle/>
-          <a:p>
-            <a:pPr algn="l" indent="0" marL="0">
-              <a:buNone/>
-            </a:pPr>
-            <a:r>
-              <a:rPr lang="en-US" sz="2100" b="1" dirty="0">
+            <a:off x="822960" y="2907792"/>
+            <a:ext cx="1920240" cy="347472"/>
+          </a:xfrm>
+          <a:prstGeom prst="rect">
+            <a:avLst/>
+          </a:prstGeom>
+          <a:noFill/>
+          <a:ln/>
+        </p:spPr>
+        <p:txBody>
+          <a:bodyPr wrap="square" lIns="0" tIns="0" rIns="0" bIns="0" rtlCol="0" anchor="ctr">
+            <a:normAutofit/>
+          </a:bodyPr>
+          <a:lstStyle/>
+          <a:p>
+            <a:pPr algn="l" indent="0" marL="0">
+              <a:buNone/>
+            </a:pPr>
+            <a:r>
+              <a:rPr lang="en-US" sz="2000" b="1" dirty="0">
                 <a:solidFill>
                   <a:srgbClr val="FFFFFF"/>
                 </a:solidFill>
@@ -9698,7 +9698,7 @@
               </a:rPr>
               <a:t>XGBoost</a:t>
             </a:r>
-            <a:endParaRPr lang="en-US" sz="2100" dirty="0"/>
+            <a:endParaRPr lang="en-US" sz="2000" dirty="0"/>
           </a:p>
         </p:txBody>
       </p:sp>
@@ -9710,8 +9710,49 @@
         </p:nvSpPr>
         <p:spPr>
           <a:xfrm>
-            <a:off x="841248" y="3657600"/>
-            <a:ext cx="1901952" cy="749808"/>
+            <a:off x="822960" y="3429000"/>
+            <a:ext cx="475488" cy="164592"/>
+          </a:xfrm>
+          <a:prstGeom prst="rect">
+            <a:avLst/>
+          </a:prstGeom>
+          <a:noFill/>
+          <a:ln/>
+        </p:spPr>
+        <p:txBody>
+          <a:bodyPr wrap="square" lIns="0" tIns="0" rIns="0" bIns="0" rtlCol="0" anchor="ctr">
+            <a:normAutofit/>
+          </a:bodyPr>
+          <a:lstStyle/>
+          <a:p>
+            <a:pPr algn="l" indent="0" marL="0">
+              <a:buNone/>
+            </a:pPr>
+            <a:r>
+              <a:rPr lang="en-US" sz="750" b="1" spc="100" kern="0" dirty="0">
+                <a:solidFill>
+                  <a:srgbClr val="7C3AED"/>
+                </a:solidFill>
+                <a:latin typeface="Aptos" pitchFamily="34" charset="0"/>
+                <a:ea typeface="Aptos" pitchFamily="34" charset="-122"/>
+                <a:cs typeface="Aptos" pitchFamily="34" charset="-120"/>
+              </a:rPr>
+              <a:t>WHAT</a:t>
+            </a:r>
+            <a:endParaRPr lang="en-US" sz="750" dirty="0"/>
+          </a:p>
+        </p:txBody>
+      </p:sp>
+      <p:sp>
+        <p:nvSpPr>
+          <p:cNvPr id="11" name="Text 9"/>
+          <p:cNvSpPr/>
+          <p:nvPr/>
+        </p:nvSpPr>
+        <p:spPr>
+          <a:xfrm>
+            <a:off x="822960" y="3639312"/>
+            <a:ext cx="1920240" cy="438912"/>
           </a:xfrm>
           <a:prstGeom prst="rect">
             <a:avLst/>
@@ -9729,7 +9770,89 @@
               <a:buNone/>
             </a:pPr>
             <a:r>
-              <a:rPr lang="en-US" sz="1150" dirty="0">
+              <a:rPr lang="en-US" sz="1020" b="1" dirty="0">
+                <a:solidFill>
+                  <a:srgbClr val="FFFFFF"/>
+                </a:solidFill>
+                <a:latin typeface="Aptos" pitchFamily="34" charset="0"/>
+                <a:ea typeface="Aptos" pitchFamily="34" charset="-122"/>
+                <a:cs typeface="Aptos" pitchFamily="34" charset="-120"/>
+              </a:rPr>
+              <a:t>Predicts sell-through at every candidate price.</a:t>
+            </a:r>
+            <a:endParaRPr lang="en-US" sz="1020" dirty="0"/>
+          </a:p>
+        </p:txBody>
+      </p:sp>
+      <p:sp>
+        <p:nvSpPr>
+          <p:cNvPr id="12" name="Text 10"/>
+          <p:cNvSpPr/>
+          <p:nvPr/>
+        </p:nvSpPr>
+        <p:spPr>
+          <a:xfrm>
+            <a:off x="822960" y="4224528"/>
+            <a:ext cx="475488" cy="164592"/>
+          </a:xfrm>
+          <a:prstGeom prst="rect">
+            <a:avLst/>
+          </a:prstGeom>
+          <a:noFill/>
+          <a:ln/>
+        </p:spPr>
+        <p:txBody>
+          <a:bodyPr wrap="square" lIns="0" tIns="0" rIns="0" bIns="0" rtlCol="0" anchor="ctr">
+            <a:normAutofit/>
+          </a:bodyPr>
+          <a:lstStyle/>
+          <a:p>
+            <a:pPr algn="l" indent="0" marL="0">
+              <a:buNone/>
+            </a:pPr>
+            <a:r>
+              <a:rPr lang="en-US" sz="750" b="1" spc="100" kern="0" dirty="0">
+                <a:solidFill>
+                  <a:srgbClr val="7C3AED"/>
+                </a:solidFill>
+                <a:latin typeface="Aptos" pitchFamily="34" charset="0"/>
+                <a:ea typeface="Aptos" pitchFamily="34" charset="-122"/>
+                <a:cs typeface="Aptos" pitchFamily="34" charset="-120"/>
+              </a:rPr>
+              <a:t>WHY</a:t>
+            </a:r>
+            <a:endParaRPr lang="en-US" sz="750" dirty="0"/>
+          </a:p>
+        </p:txBody>
+      </p:sp>
+      <p:sp>
+        <p:nvSpPr>
+          <p:cNvPr id="13" name="Text 11"/>
+          <p:cNvSpPr/>
+          <p:nvPr/>
+        </p:nvSpPr>
+        <p:spPr>
+          <a:xfrm>
+            <a:off x="822960" y="4425696"/>
+            <a:ext cx="1920240" cy="438912"/>
+          </a:xfrm>
+          <a:prstGeom prst="rect">
+            <a:avLst/>
+          </a:prstGeom>
+          <a:noFill/>
+          <a:ln/>
+        </p:spPr>
+        <p:txBody>
+          <a:bodyPr wrap="square" lIns="0" tIns="0" rIns="0" bIns="0" rtlCol="0" anchor="t">
+            <a:normAutofit/>
+          </a:bodyPr>
+          <a:lstStyle/>
+          <a:p>
+            <a:pPr algn="l" indent="0" marL="0">
+              <a:buNone/>
+            </a:pPr>
+            <a:r>
+              <a:rPr lang="en-US" sz="940" dirty="0">
                 <a:solidFill>
                   <a:srgbClr val="BBD0C8"/>
                 </a:solidFill>
@@ -9737,15 +9860,15 @@
                 <a:ea typeface="Aptos" pitchFamily="34" charset="-122"/>
                 <a:cs typeface="Aptos" pitchFamily="34" charset="-120"/>
               </a:rPr>
-              <a:t>Predicts low / expected / high sell-through for each candidate price.</a:t>
-            </a:r>
-            <a:endParaRPr lang="en-US" sz="1150" dirty="0"/>
-          </a:p>
-        </p:txBody>
-      </p:sp>
-      <p:sp>
-        <p:nvSpPr>
-          <p:cNvPr id="11" name="Shape 9"/>
+              <a:t>Built for nonlinear tabular data: stock, price, expiry and sales velocity.</a:t>
+            </a:r>
+            <a:endParaRPr lang="en-US" sz="940" dirty="0"/>
+          </a:p>
+        </p:txBody>
+      </p:sp>
+      <p:sp>
+        <p:nvSpPr>
+          <p:cNvPr id="14" name="Shape 12"/>
           <p:cNvSpPr/>
           <p:nvPr/>
         </p:nvSpPr>
@@ -9770,14 +9893,14 @@
       </p:sp>
       <p:sp>
         <p:nvSpPr>
-          <p:cNvPr id="12" name="Shape 10"/>
-          <p:cNvSpPr/>
-          <p:nvPr/>
-        </p:nvSpPr>
-        <p:spPr>
-          <a:xfrm>
-            <a:off x="3456432" y="2194560"/>
-            <a:ext cx="2359152" cy="2606040"/>
+          <p:cNvPr id="15" name="Shape 13"/>
+          <p:cNvSpPr/>
+          <p:nvPr/>
+        </p:nvSpPr>
+        <p:spPr>
+          <a:xfrm>
+            <a:off x="3456432" y="2103120"/>
+            <a:ext cx="2359152" cy="2907792"/>
           </a:xfrm>
           <a:prstGeom prst="roundRect">
             <a:avLst>
@@ -9797,14 +9920,14 @@
       </p:sp>
       <p:sp>
         <p:nvSpPr>
-          <p:cNvPr id="13" name="Shape 11"/>
-          <p:cNvSpPr/>
-          <p:nvPr/>
-        </p:nvSpPr>
-        <p:spPr>
-          <a:xfrm>
-            <a:off x="3675888" y="2468880"/>
-            <a:ext cx="438912" cy="438912"/>
+          <p:cNvPr id="16" name="Shape 14"/>
+          <p:cNvSpPr/>
+          <p:nvPr/>
+        </p:nvSpPr>
+        <p:spPr>
+          <a:xfrm>
+            <a:off x="3657600" y="2350008"/>
+            <a:ext cx="420624" cy="420624"/>
           </a:xfrm>
           <a:prstGeom prst="ellipse">
             <a:avLst/>
@@ -9822,14 +9945,14 @@
       </p:sp>
       <p:sp>
         <p:nvSpPr>
-          <p:cNvPr id="14" name="Text 12"/>
-          <p:cNvSpPr/>
-          <p:nvPr/>
-        </p:nvSpPr>
-        <p:spPr>
-          <a:xfrm>
-            <a:off x="3675888" y="2468880"/>
-            <a:ext cx="438912" cy="438912"/>
+          <p:cNvPr id="17" name="Text 15"/>
+          <p:cNvSpPr/>
+          <p:nvPr/>
+        </p:nvSpPr>
+        <p:spPr>
+          <a:xfrm>
+            <a:off x="3657600" y="2350008"/>
+            <a:ext cx="420624" cy="420624"/>
           </a:xfrm>
           <a:prstGeom prst="rect">
             <a:avLst/>
@@ -9847,7 +9970,7 @@
               <a:buNone/>
             </a:pPr>
             <a:r>
-              <a:rPr lang="en-US" sz="1300" b="1" dirty="0">
+              <a:rPr lang="en-US" sz="1200" b="1" dirty="0">
                 <a:solidFill>
                   <a:srgbClr val="FFFFFF"/>
                 </a:solidFill>
@@ -9857,38 +9980,38 @@
               </a:rPr>
               <a:t>2</a:t>
             </a:r>
-            <a:endParaRPr lang="en-US" sz="1300" dirty="0"/>
-          </a:p>
-        </p:txBody>
-      </p:sp>
-      <p:sp>
-        <p:nvSpPr>
-          <p:cNvPr id="15" name="Text 13"/>
-          <p:cNvSpPr/>
-          <p:nvPr/>
-        </p:nvSpPr>
-        <p:spPr>
-          <a:xfrm>
-            <a:off x="4224528" y="2523744"/>
-            <a:ext cx="1170432" cy="182880"/>
-          </a:xfrm>
-          <a:prstGeom prst="rect">
-            <a:avLst/>
-          </a:prstGeom>
-          <a:noFill/>
-          <a:ln/>
-        </p:spPr>
-        <p:txBody>
-          <a:bodyPr wrap="square" lIns="0" tIns="0" rIns="0" bIns="0" rtlCol="0" anchor="ctr">
-            <a:normAutofit/>
-          </a:bodyPr>
-          <a:lstStyle/>
-          <a:p>
-            <a:pPr algn="l" indent="0" marL="0">
-              <a:buNone/>
-            </a:pPr>
-            <a:r>
-              <a:rPr lang="en-US" sz="800" b="1" spc="120" kern="0" dirty="0">
+            <a:endParaRPr lang="en-US" sz="1200" dirty="0"/>
+          </a:p>
+        </p:txBody>
+      </p:sp>
+      <p:sp>
+        <p:nvSpPr>
+          <p:cNvPr id="18" name="Text 16"/>
+          <p:cNvSpPr/>
+          <p:nvPr/>
+        </p:nvSpPr>
+        <p:spPr>
+          <a:xfrm>
+            <a:off x="4178808" y="2395728"/>
+            <a:ext cx="1417320" cy="182880"/>
+          </a:xfrm>
+          <a:prstGeom prst="rect">
+            <a:avLst/>
+          </a:prstGeom>
+          <a:noFill/>
+          <a:ln/>
+        </p:spPr>
+        <p:txBody>
+          <a:bodyPr wrap="square" lIns="0" tIns="0" rIns="0" bIns="0" rtlCol="0" anchor="ctr">
+            <a:normAutofit/>
+          </a:bodyPr>
+          <a:lstStyle/>
+          <a:p>
+            <a:pPr algn="l" indent="0" marL="0">
+              <a:buNone/>
+            </a:pPr>
+            <a:r>
+              <a:rPr lang="en-US" sz="750" b="1" spc="75" kern="0" dirty="0">
                 <a:solidFill>
                   <a:srgbClr val="F97316"/>
                 </a:solidFill>
@@ -9896,40 +10019,40 @@
                 <a:ea typeface="Aptos" pitchFamily="34" charset="-122"/>
                 <a:cs typeface="Aptos" pitchFamily="34" charset="-120"/>
               </a:rPr>
-              <a:t>POLICY</a:t>
-            </a:r>
-            <a:endParaRPr lang="en-US" sz="800" dirty="0"/>
-          </a:p>
-        </p:txBody>
-      </p:sp>
-      <p:sp>
-        <p:nvSpPr>
-          <p:cNvPr id="16" name="Text 14"/>
-          <p:cNvSpPr/>
-          <p:nvPr/>
-        </p:nvSpPr>
-        <p:spPr>
-          <a:xfrm>
-            <a:off x="3675888" y="3127248"/>
-            <a:ext cx="1901952" cy="365760"/>
-          </a:xfrm>
-          <a:prstGeom prst="rect">
-            <a:avLst/>
-          </a:prstGeom>
-          <a:noFill/>
-          <a:ln/>
-        </p:spPr>
-        <p:txBody>
-          <a:bodyPr wrap="square" lIns="0" tIns="0" rIns="0" bIns="0" rtlCol="0" anchor="ctr">
-            <a:normAutofit/>
-          </a:bodyPr>
-          <a:lstStyle/>
-          <a:p>
-            <a:pPr algn="l" indent="0" marL="0">
-              <a:buNone/>
-            </a:pPr>
-            <a:r>
-              <a:rPr lang="en-US" sz="2100" b="1" dirty="0">
+              <a:t>NOT AI · POLICY</a:t>
+            </a:r>
+            <a:endParaRPr lang="en-US" sz="750" dirty="0"/>
+          </a:p>
+        </p:txBody>
+      </p:sp>
+      <p:sp>
+        <p:nvSpPr>
+          <p:cNvPr id="19" name="Text 17"/>
+          <p:cNvSpPr/>
+          <p:nvPr/>
+        </p:nvSpPr>
+        <p:spPr>
+          <a:xfrm>
+            <a:off x="3657600" y="2907792"/>
+            <a:ext cx="1920240" cy="347472"/>
+          </a:xfrm>
+          <a:prstGeom prst="rect">
+            <a:avLst/>
+          </a:prstGeom>
+          <a:noFill/>
+          <a:ln/>
+        </p:spPr>
+        <p:txBody>
+          <a:bodyPr wrap="square" lIns="0" tIns="0" rIns="0" bIns="0" rtlCol="0" anchor="ctr">
+            <a:normAutofit/>
+          </a:bodyPr>
+          <a:lstStyle/>
+          <a:p>
+            <a:pPr algn="l" indent="0" marL="0">
+              <a:buNone/>
+            </a:pPr>
+            <a:r>
+              <a:rPr lang="en-US" sz="2000" b="1" dirty="0">
                 <a:solidFill>
                   <a:srgbClr val="FFFFFF"/>
                 </a:solidFill>
@@ -9939,20 +10062,61 @@
               </a:rPr>
               <a:t>Optimizer</a:t>
             </a:r>
-            <a:endParaRPr lang="en-US" sz="2100" dirty="0"/>
-          </a:p>
-        </p:txBody>
-      </p:sp>
-      <p:sp>
-        <p:nvSpPr>
-          <p:cNvPr id="17" name="Text 15"/>
-          <p:cNvSpPr/>
-          <p:nvPr/>
-        </p:nvSpPr>
-        <p:spPr>
-          <a:xfrm>
-            <a:off x="3675888" y="3657600"/>
-            <a:ext cx="1901952" cy="749808"/>
+            <a:endParaRPr lang="en-US" sz="2000" dirty="0"/>
+          </a:p>
+        </p:txBody>
+      </p:sp>
+      <p:sp>
+        <p:nvSpPr>
+          <p:cNvPr id="20" name="Text 18"/>
+          <p:cNvSpPr/>
+          <p:nvPr/>
+        </p:nvSpPr>
+        <p:spPr>
+          <a:xfrm>
+            <a:off x="3657600" y="3429000"/>
+            <a:ext cx="475488" cy="164592"/>
+          </a:xfrm>
+          <a:prstGeom prst="rect">
+            <a:avLst/>
+          </a:prstGeom>
+          <a:noFill/>
+          <a:ln/>
+        </p:spPr>
+        <p:txBody>
+          <a:bodyPr wrap="square" lIns="0" tIns="0" rIns="0" bIns="0" rtlCol="0" anchor="ctr">
+            <a:normAutofit/>
+          </a:bodyPr>
+          <a:lstStyle/>
+          <a:p>
+            <a:pPr algn="l" indent="0" marL="0">
+              <a:buNone/>
+            </a:pPr>
+            <a:r>
+              <a:rPr lang="en-US" sz="750" b="1" spc="100" kern="0" dirty="0">
+                <a:solidFill>
+                  <a:srgbClr val="F97316"/>
+                </a:solidFill>
+                <a:latin typeface="Aptos" pitchFamily="34" charset="0"/>
+                <a:ea typeface="Aptos" pitchFamily="34" charset="-122"/>
+                <a:cs typeface="Aptos" pitchFamily="34" charset="-120"/>
+              </a:rPr>
+              <a:t>WHAT</a:t>
+            </a:r>
+            <a:endParaRPr lang="en-US" sz="750" dirty="0"/>
+          </a:p>
+        </p:txBody>
+      </p:sp>
+      <p:sp>
+        <p:nvSpPr>
+          <p:cNvPr id="21" name="Text 19"/>
+          <p:cNvSpPr/>
+          <p:nvPr/>
+        </p:nvSpPr>
+        <p:spPr>
+          <a:xfrm>
+            <a:off x="3657600" y="3639312"/>
+            <a:ext cx="1920240" cy="438912"/>
           </a:xfrm>
           <a:prstGeom prst="rect">
             <a:avLst/>
@@ -9970,7 +10134,89 @@
               <a:buNone/>
             </a:pPr>
             <a:r>
-              <a:rPr lang="en-US" sz="1150" dirty="0">
+              <a:rPr lang="en-US" sz="1020" b="1" dirty="0">
+                <a:solidFill>
+                  <a:srgbClr val="FFFFFF"/>
+                </a:solidFill>
+                <a:latin typeface="Aptos" pitchFamily="34" charset="0"/>
+                <a:ea typeface="Aptos" pitchFamily="34" charset="-122"/>
+                <a:cs typeface="Aptos" pitchFamily="34" charset="-120"/>
+              </a:rPr>
+              <a:t>Selects the strongest eligible contribution score.</a:t>
+            </a:r>
+            <a:endParaRPr lang="en-US" sz="1020" dirty="0"/>
+          </a:p>
+        </p:txBody>
+      </p:sp>
+      <p:sp>
+        <p:nvSpPr>
+          <p:cNvPr id="22" name="Text 20"/>
+          <p:cNvSpPr/>
+          <p:nvPr/>
+        </p:nvSpPr>
+        <p:spPr>
+          <a:xfrm>
+            <a:off x="3657600" y="4224528"/>
+            <a:ext cx="475488" cy="164592"/>
+          </a:xfrm>
+          <a:prstGeom prst="rect">
+            <a:avLst/>
+          </a:prstGeom>
+          <a:noFill/>
+          <a:ln/>
+        </p:spPr>
+        <p:txBody>
+          <a:bodyPr wrap="square" lIns="0" tIns="0" rIns="0" bIns="0" rtlCol="0" anchor="ctr">
+            <a:normAutofit/>
+          </a:bodyPr>
+          <a:lstStyle/>
+          <a:p>
+            <a:pPr algn="l" indent="0" marL="0">
+              <a:buNone/>
+            </a:pPr>
+            <a:r>
+              <a:rPr lang="en-US" sz="750" b="1" spc="100" kern="0" dirty="0">
+                <a:solidFill>
+                  <a:srgbClr val="F97316"/>
+                </a:solidFill>
+                <a:latin typeface="Aptos" pitchFamily="34" charset="0"/>
+                <a:ea typeface="Aptos" pitchFamily="34" charset="-122"/>
+                <a:cs typeface="Aptos" pitchFamily="34" charset="-120"/>
+              </a:rPr>
+              <a:t>WHY</a:t>
+            </a:r>
+            <a:endParaRPr lang="en-US" sz="750" dirty="0"/>
+          </a:p>
+        </p:txBody>
+      </p:sp>
+      <p:sp>
+        <p:nvSpPr>
+          <p:cNvPr id="23" name="Text 21"/>
+          <p:cNvSpPr/>
+          <p:nvPr/>
+        </p:nvSpPr>
+        <p:spPr>
+          <a:xfrm>
+            <a:off x="3657600" y="4425696"/>
+            <a:ext cx="1920240" cy="438912"/>
+          </a:xfrm>
+          <a:prstGeom prst="rect">
+            <a:avLst/>
+          </a:prstGeom>
+          <a:noFill/>
+          <a:ln/>
+        </p:spPr>
+        <p:txBody>
+          <a:bodyPr wrap="square" lIns="0" tIns="0" rIns="0" bIns="0" rtlCol="0" anchor="t">
+            <a:normAutofit/>
+          </a:bodyPr>
+          <a:lstStyle/>
+          <a:p>
+            <a:pPr algn="l" indent="0" marL="0">
+              <a:buNone/>
+            </a:pPr>
+            <a:r>
+              <a:rPr lang="en-US" sz="940" dirty="0">
                 <a:solidFill>
                   <a:srgbClr val="BBD0C8"/>
                 </a:solidFill>
@@ -9978,15 +10224,15 @@
                 <a:ea typeface="Aptos" pitchFamily="34" charset="-122"/>
                 <a:cs typeface="Aptos" pitchFamily="34" charset="-120"/>
               </a:rPr>
-              <a:t>Maximizes expected contribution under price floors and expiry rules.</a:t>
-            </a:r>
-            <a:endParaRPr lang="en-US" sz="1150" dirty="0"/>
-          </a:p>
-        </p:txBody>
-      </p:sp>
-      <p:sp>
-        <p:nvSpPr>
-          <p:cNvPr id="18" name="Shape 16"/>
+              <a:t>Keeps price floors, expiry blocks and overrides deterministic.</a:t>
+            </a:r>
+            <a:endParaRPr lang="en-US" sz="940" dirty="0"/>
+          </a:p>
+        </p:txBody>
+      </p:sp>
+      <p:sp>
+        <p:nvSpPr>
+          <p:cNvPr id="24" name="Shape 22"/>
           <p:cNvSpPr/>
           <p:nvPr/>
         </p:nvSpPr>
@@ -10011,14 +10257,14 @@
       </p:sp>
       <p:sp>
         <p:nvSpPr>
-          <p:cNvPr id="19" name="Shape 17"/>
-          <p:cNvSpPr/>
-          <p:nvPr/>
-        </p:nvSpPr>
-        <p:spPr>
-          <a:xfrm>
-            <a:off x="6291072" y="2194560"/>
-            <a:ext cx="2359152" cy="2606040"/>
+          <p:cNvPr id="25" name="Shape 23"/>
+          <p:cNvSpPr/>
+          <p:nvPr/>
+        </p:nvSpPr>
+        <p:spPr>
+          <a:xfrm>
+            <a:off x="6291072" y="2103120"/>
+            <a:ext cx="2359152" cy="2907792"/>
           </a:xfrm>
           <a:prstGeom prst="roundRect">
             <a:avLst>
@@ -10038,14 +10284,14 @@
       </p:sp>
       <p:sp>
         <p:nvSpPr>
-          <p:cNvPr id="20" name="Shape 18"/>
-          <p:cNvSpPr/>
-          <p:nvPr/>
-        </p:nvSpPr>
-        <p:spPr>
-          <a:xfrm>
-            <a:off x="6510528" y="2468880"/>
-            <a:ext cx="438912" cy="438912"/>
+          <p:cNvPr id="26" name="Shape 24"/>
+          <p:cNvSpPr/>
+          <p:nvPr/>
+        </p:nvSpPr>
+        <p:spPr>
+          <a:xfrm>
+            <a:off x="6492240" y="2350008"/>
+            <a:ext cx="420624" cy="420624"/>
           </a:xfrm>
           <a:prstGeom prst="ellipse">
             <a:avLst/>
@@ -10063,14 +10309,14 @@
       </p:sp>
       <p:sp>
         <p:nvSpPr>
-          <p:cNvPr id="21" name="Text 19"/>
-          <p:cNvSpPr/>
-          <p:nvPr/>
-        </p:nvSpPr>
-        <p:spPr>
-          <a:xfrm>
-            <a:off x="6510528" y="2468880"/>
-            <a:ext cx="438912" cy="438912"/>
+          <p:cNvPr id="27" name="Text 25"/>
+          <p:cNvSpPr/>
+          <p:nvPr/>
+        </p:nvSpPr>
+        <p:spPr>
+          <a:xfrm>
+            <a:off x="6492240" y="2350008"/>
+            <a:ext cx="420624" cy="420624"/>
           </a:xfrm>
           <a:prstGeom prst="rect">
             <a:avLst/>
@@ -10088,7 +10334,7 @@
               <a:buNone/>
             </a:pPr>
             <a:r>
-              <a:rPr lang="en-US" sz="1300" b="1" dirty="0">
+              <a:rPr lang="en-US" sz="1200" b="1" dirty="0">
                 <a:solidFill>
                   <a:srgbClr val="FFFFFF"/>
                 </a:solidFill>
@@ -10098,38 +10344,38 @@
               </a:rPr>
               <a:t>3</a:t>
             </a:r>
-            <a:endParaRPr lang="en-US" sz="1300" dirty="0"/>
-          </a:p>
-        </p:txBody>
-      </p:sp>
-      <p:sp>
-        <p:nvSpPr>
-          <p:cNvPr id="22" name="Text 20"/>
-          <p:cNvSpPr/>
-          <p:nvPr/>
-        </p:nvSpPr>
-        <p:spPr>
-          <a:xfrm>
-            <a:off x="7059168" y="2523744"/>
-            <a:ext cx="1170432" cy="182880"/>
-          </a:xfrm>
-          <a:prstGeom prst="rect">
-            <a:avLst/>
-          </a:prstGeom>
-          <a:noFill/>
-          <a:ln/>
-        </p:spPr>
-        <p:txBody>
-          <a:bodyPr wrap="square" lIns="0" tIns="0" rIns="0" bIns="0" rtlCol="0" anchor="ctr">
-            <a:normAutofit/>
-          </a:bodyPr>
-          <a:lstStyle/>
-          <a:p>
-            <a:pPr algn="l" indent="0" marL="0">
-              <a:buNone/>
-            </a:pPr>
-            <a:r>
-              <a:rPr lang="en-US" sz="800" b="1" spc="120" kern="0" dirty="0">
+            <a:endParaRPr lang="en-US" sz="1200" dirty="0"/>
+          </a:p>
+        </p:txBody>
+      </p:sp>
+      <p:sp>
+        <p:nvSpPr>
+          <p:cNvPr id="28" name="Text 26"/>
+          <p:cNvSpPr/>
+          <p:nvPr/>
+        </p:nvSpPr>
+        <p:spPr>
+          <a:xfrm>
+            <a:off x="7013448" y="2395728"/>
+            <a:ext cx="1417320" cy="182880"/>
+          </a:xfrm>
+          <a:prstGeom prst="rect">
+            <a:avLst/>
+          </a:prstGeom>
+          <a:noFill/>
+          <a:ln/>
+        </p:spPr>
+        <p:txBody>
+          <a:bodyPr wrap="square" lIns="0" tIns="0" rIns="0" bIns="0" rtlCol="0" anchor="ctr">
+            <a:normAutofit/>
+          </a:bodyPr>
+          <a:lstStyle/>
+          <a:p>
+            <a:pPr algn="l" indent="0" marL="0">
+              <a:buNone/>
+            </a:pPr>
+            <a:r>
+              <a:rPr lang="en-US" sz="750" b="1" spc="75" kern="0" dirty="0">
                 <a:solidFill>
                   <a:srgbClr val="10B981"/>
                 </a:solidFill>
@@ -10137,40 +10383,40 @@
                 <a:ea typeface="Aptos" pitchFamily="34" charset="-122"/>
                 <a:cs typeface="Aptos" pitchFamily="34" charset="-120"/>
               </a:rPr>
-              <a:t>LANGUAGE</a:t>
-            </a:r>
-            <a:endParaRPr lang="en-US" sz="800" dirty="0"/>
-          </a:p>
-        </p:txBody>
-      </p:sp>
-      <p:sp>
-        <p:nvSpPr>
-          <p:cNvPr id="23" name="Text 21"/>
-          <p:cNvSpPr/>
-          <p:nvPr/>
-        </p:nvSpPr>
-        <p:spPr>
-          <a:xfrm>
-            <a:off x="6510528" y="3127248"/>
-            <a:ext cx="1901952" cy="365760"/>
-          </a:xfrm>
-          <a:prstGeom prst="rect">
-            <a:avLst/>
-          </a:prstGeom>
-          <a:noFill/>
-          <a:ln/>
-        </p:spPr>
-        <p:txBody>
-          <a:bodyPr wrap="square" lIns="0" tIns="0" rIns="0" bIns="0" rtlCol="0" anchor="ctr">
-            <a:normAutofit/>
-          </a:bodyPr>
-          <a:lstStyle/>
-          <a:p>
-            <a:pPr algn="l" indent="0" marL="0">
-              <a:buNone/>
-            </a:pPr>
-            <a:r>
-              <a:rPr lang="en-US" sz="2100" b="1" dirty="0">
+              <a:t>AI #2 · LANGUAGE</a:t>
+            </a:r>
+            <a:endParaRPr lang="en-US" sz="750" dirty="0"/>
+          </a:p>
+        </p:txBody>
+      </p:sp>
+      <p:sp>
+        <p:nvSpPr>
+          <p:cNvPr id="29" name="Text 27"/>
+          <p:cNvSpPr/>
+          <p:nvPr/>
+        </p:nvSpPr>
+        <p:spPr>
+          <a:xfrm>
+            <a:off x="6492240" y="2907792"/>
+            <a:ext cx="1920240" cy="347472"/>
+          </a:xfrm>
+          <a:prstGeom prst="rect">
+            <a:avLst/>
+          </a:prstGeom>
+          <a:noFill/>
+          <a:ln/>
+        </p:spPr>
+        <p:txBody>
+          <a:bodyPr wrap="square" lIns="0" tIns="0" rIns="0" bIns="0" rtlCol="0" anchor="ctr">
+            <a:normAutofit/>
+          </a:bodyPr>
+          <a:lstStyle/>
+          <a:p>
+            <a:pPr algn="l" indent="0" marL="0">
+              <a:buNone/>
+            </a:pPr>
+            <a:r>
+              <a:rPr lang="en-US" sz="2000" b="1" dirty="0">
                 <a:solidFill>
                   <a:srgbClr val="FFFFFF"/>
                 </a:solidFill>
@@ -10178,22 +10424,63 @@
                 <a:ea typeface="Aptos Display" pitchFamily="34" charset="-122"/>
                 <a:cs typeface="Aptos Display" pitchFamily="34" charset="-120"/>
               </a:rPr>
-              <a:t>Gemini adapter</a:t>
-            </a:r>
-            <a:endParaRPr lang="en-US" sz="2100" dirty="0"/>
-          </a:p>
-        </p:txBody>
-      </p:sp>
-      <p:sp>
-        <p:nvSpPr>
-          <p:cNvPr id="24" name="Text 22"/>
-          <p:cNvSpPr/>
-          <p:nvPr/>
-        </p:nvSpPr>
-        <p:spPr>
-          <a:xfrm>
-            <a:off x="6510528" y="3657600"/>
-            <a:ext cx="1901952" cy="749808"/>
+              <a:t>Gemini</a:t>
+            </a:r>
+            <a:endParaRPr lang="en-US" sz="2000" dirty="0"/>
+          </a:p>
+        </p:txBody>
+      </p:sp>
+      <p:sp>
+        <p:nvSpPr>
+          <p:cNvPr id="30" name="Text 28"/>
+          <p:cNvSpPr/>
+          <p:nvPr/>
+        </p:nvSpPr>
+        <p:spPr>
+          <a:xfrm>
+            <a:off x="6492240" y="3429000"/>
+            <a:ext cx="475488" cy="164592"/>
+          </a:xfrm>
+          <a:prstGeom prst="rect">
+            <a:avLst/>
+          </a:prstGeom>
+          <a:noFill/>
+          <a:ln/>
+        </p:spPr>
+        <p:txBody>
+          <a:bodyPr wrap="square" lIns="0" tIns="0" rIns="0" bIns="0" rtlCol="0" anchor="ctr">
+            <a:normAutofit/>
+          </a:bodyPr>
+          <a:lstStyle/>
+          <a:p>
+            <a:pPr algn="l" indent="0" marL="0">
+              <a:buNone/>
+            </a:pPr>
+            <a:r>
+              <a:rPr lang="en-US" sz="750" b="1" spc="100" kern="0" dirty="0">
+                <a:solidFill>
+                  <a:srgbClr val="10B981"/>
+                </a:solidFill>
+                <a:latin typeface="Aptos" pitchFamily="34" charset="0"/>
+                <a:ea typeface="Aptos" pitchFamily="34" charset="-122"/>
+                <a:cs typeface="Aptos" pitchFamily="34" charset="-120"/>
+              </a:rPr>
+              <a:t>WHAT</a:t>
+            </a:r>
+            <a:endParaRPr lang="en-US" sz="750" dirty="0"/>
+          </a:p>
+        </p:txBody>
+      </p:sp>
+      <p:sp>
+        <p:nvSpPr>
+          <p:cNvPr id="31" name="Text 29"/>
+          <p:cNvSpPr/>
+          <p:nvPr/>
+        </p:nvSpPr>
+        <p:spPr>
+          <a:xfrm>
+            <a:off x="6492240" y="3639312"/>
+            <a:ext cx="1920240" cy="438912"/>
           </a:xfrm>
           <a:prstGeom prst="rect">
             <a:avLst/>
@@ -10211,7 +10498,89 @@
               <a:buNone/>
             </a:pPr>
             <a:r>
-              <a:rPr lang="en-US" sz="1150" dirty="0">
+              <a:rPr lang="en-US" sz="1020" b="1" dirty="0">
+                <a:solidFill>
+                  <a:srgbClr val="FFFFFF"/>
+                </a:solidFill>
+                <a:latin typeface="Aptos" pitchFamily="34" charset="0"/>
+                <a:ea typeface="Aptos" pitchFamily="34" charset="-122"/>
+                <a:cs typeface="Aptos" pitchFamily="34" charset="-120"/>
+              </a:rPr>
+              <a:t>Explains fixed evidence and writes campaign copy.</a:t>
+            </a:r>
+            <a:endParaRPr lang="en-US" sz="1020" dirty="0"/>
+          </a:p>
+        </p:txBody>
+      </p:sp>
+      <p:sp>
+        <p:nvSpPr>
+          <p:cNvPr id="32" name="Text 30"/>
+          <p:cNvSpPr/>
+          <p:nvPr/>
+        </p:nvSpPr>
+        <p:spPr>
+          <a:xfrm>
+            <a:off x="6492240" y="4224528"/>
+            <a:ext cx="475488" cy="164592"/>
+          </a:xfrm>
+          <a:prstGeom prst="rect">
+            <a:avLst/>
+          </a:prstGeom>
+          <a:noFill/>
+          <a:ln/>
+        </p:spPr>
+        <p:txBody>
+          <a:bodyPr wrap="square" lIns="0" tIns="0" rIns="0" bIns="0" rtlCol="0" anchor="ctr">
+            <a:normAutofit/>
+          </a:bodyPr>
+          <a:lstStyle/>
+          <a:p>
+            <a:pPr algn="l" indent="0" marL="0">
+              <a:buNone/>
+            </a:pPr>
+            <a:r>
+              <a:rPr lang="en-US" sz="750" b="1" spc="100" kern="0" dirty="0">
+                <a:solidFill>
+                  <a:srgbClr val="10B981"/>
+                </a:solidFill>
+                <a:latin typeface="Aptos" pitchFamily="34" charset="0"/>
+                <a:ea typeface="Aptos" pitchFamily="34" charset="-122"/>
+                <a:cs typeface="Aptos" pitchFamily="34" charset="-120"/>
+              </a:rPr>
+              <a:t>WHY</a:t>
+            </a:r>
+            <a:endParaRPr lang="en-US" sz="750" dirty="0"/>
+          </a:p>
+        </p:txBody>
+      </p:sp>
+      <p:sp>
+        <p:nvSpPr>
+          <p:cNvPr id="33" name="Text 31"/>
+          <p:cNvSpPr/>
+          <p:nvPr/>
+        </p:nvSpPr>
+        <p:spPr>
+          <a:xfrm>
+            <a:off x="6492240" y="4425696"/>
+            <a:ext cx="1920240" cy="438912"/>
+          </a:xfrm>
+          <a:prstGeom prst="rect">
+            <a:avLst/>
+          </a:prstGeom>
+          <a:noFill/>
+          <a:ln/>
+        </p:spPr>
+        <p:txBody>
+          <a:bodyPr wrap="square" lIns="0" tIns="0" rIns="0" bIns="0" rtlCol="0" anchor="t">
+            <a:normAutofit/>
+          </a:bodyPr>
+          <a:lstStyle/>
+          <a:p>
+            <a:pPr algn="l" indent="0" marL="0">
+              <a:buNone/>
+            </a:pPr>
+            <a:r>
+              <a:rPr lang="en-US" sz="940" dirty="0">
                 <a:solidFill>
                   <a:srgbClr val="BBD0C8"/>
                 </a:solidFill>
@@ -10219,15 +10588,15 @@
                 <a:ea typeface="Aptos" pitchFamily="34" charset="-122"/>
                 <a:cs typeface="Aptos" pitchFamily="34" charset="-120"/>
               </a:rPr>
-              <a:t>Turns fixed evidence into manager rationale and campaign copy.</a:t>
-            </a:r>
-            <a:endParaRPr lang="en-US" sz="1150" dirty="0"/>
-          </a:p>
-        </p:txBody>
-      </p:sp>
-      <p:sp>
-        <p:nvSpPr>
-          <p:cNvPr id="25" name="Shape 23"/>
+              <a:t>Natural language is its strength; it never calculates the price.</a:t>
+            </a:r>
+            <a:endParaRPr lang="en-US" sz="940" dirty="0"/>
+          </a:p>
+        </p:txBody>
+      </p:sp>
+      <p:sp>
+        <p:nvSpPr>
+          <p:cNvPr id="34" name="Shape 32"/>
           <p:cNvSpPr/>
           <p:nvPr/>
         </p:nvSpPr>
@@ -10252,14 +10621,14 @@
       </p:sp>
       <p:sp>
         <p:nvSpPr>
-          <p:cNvPr id="26" name="Shape 24"/>
-          <p:cNvSpPr/>
-          <p:nvPr/>
-        </p:nvSpPr>
-        <p:spPr>
-          <a:xfrm>
-            <a:off x="9125712" y="2194560"/>
-            <a:ext cx="2359152" cy="2606040"/>
+          <p:cNvPr id="35" name="Shape 33"/>
+          <p:cNvSpPr/>
+          <p:nvPr/>
+        </p:nvSpPr>
+        <p:spPr>
+          <a:xfrm>
+            <a:off x="9125712" y="2103120"/>
+            <a:ext cx="2359152" cy="2907792"/>
           </a:xfrm>
           <a:prstGeom prst="roundRect">
             <a:avLst>
@@ -10279,14 +10648,14 @@
       </p:sp>
       <p:sp>
         <p:nvSpPr>
-          <p:cNvPr id="27" name="Shape 25"/>
-          <p:cNvSpPr/>
-          <p:nvPr/>
-        </p:nvSpPr>
-        <p:spPr>
-          <a:xfrm>
-            <a:off x="9345168" y="2468880"/>
-            <a:ext cx="438912" cy="438912"/>
+          <p:cNvPr id="36" name="Shape 34"/>
+          <p:cNvSpPr/>
+          <p:nvPr/>
+        </p:nvSpPr>
+        <p:spPr>
+          <a:xfrm>
+            <a:off x="9326880" y="2350008"/>
+            <a:ext cx="420624" cy="420624"/>
           </a:xfrm>
           <a:prstGeom prst="ellipse">
             <a:avLst/>
@@ -10304,14 +10673,14 @@
       </p:sp>
       <p:sp>
         <p:nvSpPr>
-          <p:cNvPr id="28" name="Text 26"/>
-          <p:cNvSpPr/>
-          <p:nvPr/>
-        </p:nvSpPr>
-        <p:spPr>
-          <a:xfrm>
-            <a:off x="9345168" y="2468880"/>
-            <a:ext cx="438912" cy="438912"/>
+          <p:cNvPr id="37" name="Text 35"/>
+          <p:cNvSpPr/>
+          <p:nvPr/>
+        </p:nvSpPr>
+        <p:spPr>
+          <a:xfrm>
+            <a:off x="9326880" y="2350008"/>
+            <a:ext cx="420624" cy="420624"/>
           </a:xfrm>
           <a:prstGeom prst="rect">
             <a:avLst/>
@@ -10329,7 +10698,7 @@
               <a:buNone/>
             </a:pPr>
             <a:r>
-              <a:rPr lang="en-US" sz="1300" b="1" dirty="0">
+              <a:rPr lang="en-US" sz="1200" b="1" dirty="0">
                 <a:solidFill>
                   <a:srgbClr val="173D31"/>
                 </a:solidFill>
@@ -10339,38 +10708,38 @@
               </a:rPr>
               <a:t>4</a:t>
             </a:r>
-            <a:endParaRPr lang="en-US" sz="1300" dirty="0"/>
-          </a:p>
-        </p:txBody>
-      </p:sp>
-      <p:sp>
-        <p:nvSpPr>
-          <p:cNvPr id="29" name="Text 27"/>
-          <p:cNvSpPr/>
-          <p:nvPr/>
-        </p:nvSpPr>
-        <p:spPr>
-          <a:xfrm>
-            <a:off x="9893808" y="2523744"/>
-            <a:ext cx="1170432" cy="182880"/>
-          </a:xfrm>
-          <a:prstGeom prst="rect">
-            <a:avLst/>
-          </a:prstGeom>
-          <a:noFill/>
-          <a:ln/>
-        </p:spPr>
-        <p:txBody>
-          <a:bodyPr wrap="square" lIns="0" tIns="0" rIns="0" bIns="0" rtlCol="0" anchor="ctr">
-            <a:normAutofit/>
-          </a:bodyPr>
-          <a:lstStyle/>
-          <a:p>
-            <a:pPr algn="l" indent="0" marL="0">
-              <a:buNone/>
-            </a:pPr>
-            <a:r>
-              <a:rPr lang="en-US" sz="800" b="1" spc="120" kern="0" dirty="0">
+            <a:endParaRPr lang="en-US" sz="1200" dirty="0"/>
+          </a:p>
+        </p:txBody>
+      </p:sp>
+      <p:sp>
+        <p:nvSpPr>
+          <p:cNvPr id="38" name="Text 36"/>
+          <p:cNvSpPr/>
+          <p:nvPr/>
+        </p:nvSpPr>
+        <p:spPr>
+          <a:xfrm>
+            <a:off x="9848088" y="2395728"/>
+            <a:ext cx="1417320" cy="182880"/>
+          </a:xfrm>
+          <a:prstGeom prst="rect">
+            <a:avLst/>
+          </a:prstGeom>
+          <a:noFill/>
+          <a:ln/>
+        </p:spPr>
+        <p:txBody>
+          <a:bodyPr wrap="square" lIns="0" tIns="0" rIns="0" bIns="0" rtlCol="0" anchor="ctr">
+            <a:normAutofit/>
+          </a:bodyPr>
+          <a:lstStyle/>
+          <a:p>
+            <a:pPr algn="l" indent="0" marL="0">
+              <a:buNone/>
+            </a:pPr>
+            <a:r>
+              <a:rPr lang="en-US" sz="750" b="1" spc="75" kern="0" dirty="0">
                 <a:solidFill>
                   <a:srgbClr val="BEF264"/>
                 </a:solidFill>
@@ -10378,40 +10747,40 @@
                 <a:ea typeface="Aptos" pitchFamily="34" charset="-122"/>
                 <a:cs typeface="Aptos" pitchFamily="34" charset="-120"/>
               </a:rPr>
-              <a:t>CONTROL</a:t>
-            </a:r>
-            <a:endParaRPr lang="en-US" sz="800" dirty="0"/>
-          </a:p>
-        </p:txBody>
-      </p:sp>
-      <p:sp>
-        <p:nvSpPr>
-          <p:cNvPr id="30" name="Text 28"/>
-          <p:cNvSpPr/>
-          <p:nvPr/>
-        </p:nvSpPr>
-        <p:spPr>
-          <a:xfrm>
-            <a:off x="9345168" y="3127248"/>
-            <a:ext cx="1901952" cy="365760"/>
-          </a:xfrm>
-          <a:prstGeom prst="rect">
-            <a:avLst/>
-          </a:prstGeom>
-          <a:noFill/>
-          <a:ln/>
-        </p:spPr>
-        <p:txBody>
-          <a:bodyPr wrap="square" lIns="0" tIns="0" rIns="0" bIns="0" rtlCol="0" anchor="ctr">
-            <a:normAutofit/>
-          </a:bodyPr>
-          <a:lstStyle/>
-          <a:p>
-            <a:pPr algn="l" indent="0" marL="0">
-              <a:buNone/>
-            </a:pPr>
-            <a:r>
-              <a:rPr lang="en-US" sz="2100" b="1" dirty="0">
+              <a:t>HUMAN · AUTHORITY</a:t>
+            </a:r>
+            <a:endParaRPr lang="en-US" sz="750" dirty="0"/>
+          </a:p>
+        </p:txBody>
+      </p:sp>
+      <p:sp>
+        <p:nvSpPr>
+          <p:cNvPr id="39" name="Text 37"/>
+          <p:cNvSpPr/>
+          <p:nvPr/>
+        </p:nvSpPr>
+        <p:spPr>
+          <a:xfrm>
+            <a:off x="9326880" y="2907792"/>
+            <a:ext cx="1920240" cy="347472"/>
+          </a:xfrm>
+          <a:prstGeom prst="rect">
+            <a:avLst/>
+          </a:prstGeom>
+          <a:noFill/>
+          <a:ln/>
+        </p:spPr>
+        <p:txBody>
+          <a:bodyPr wrap="square" lIns="0" tIns="0" rIns="0" bIns="0" rtlCol="0" anchor="ctr">
+            <a:normAutofit/>
+          </a:bodyPr>
+          <a:lstStyle/>
+          <a:p>
+            <a:pPr algn="l" indent="0" marL="0">
+              <a:buNone/>
+            </a:pPr>
+            <a:r>
+              <a:rPr lang="en-US" sz="2000" b="1" dirty="0">
                 <a:solidFill>
                   <a:srgbClr val="FFFFFF"/>
                 </a:solidFill>
@@ -10419,22 +10788,63 @@
                 <a:ea typeface="Aptos Display" pitchFamily="34" charset="-122"/>
                 <a:cs typeface="Aptos Display" pitchFamily="34" charset="-120"/>
               </a:rPr>
-              <a:t>Owner approval</a:t>
-            </a:r>
-            <a:endParaRPr lang="en-US" sz="2100" dirty="0"/>
-          </a:p>
-        </p:txBody>
-      </p:sp>
-      <p:sp>
-        <p:nvSpPr>
-          <p:cNvPr id="31" name="Text 29"/>
-          <p:cNvSpPr/>
-          <p:nvPr/>
-        </p:nvSpPr>
-        <p:spPr>
-          <a:xfrm>
-            <a:off x="9345168" y="3657600"/>
-            <a:ext cx="1901952" cy="749808"/>
+              <a:t>Store owner</a:t>
+            </a:r>
+            <a:endParaRPr lang="en-US" sz="2000" dirty="0"/>
+          </a:p>
+        </p:txBody>
+      </p:sp>
+      <p:sp>
+        <p:nvSpPr>
+          <p:cNvPr id="40" name="Text 38"/>
+          <p:cNvSpPr/>
+          <p:nvPr/>
+        </p:nvSpPr>
+        <p:spPr>
+          <a:xfrm>
+            <a:off x="9326880" y="3429000"/>
+            <a:ext cx="475488" cy="164592"/>
+          </a:xfrm>
+          <a:prstGeom prst="rect">
+            <a:avLst/>
+          </a:prstGeom>
+          <a:noFill/>
+          <a:ln/>
+        </p:spPr>
+        <p:txBody>
+          <a:bodyPr wrap="square" lIns="0" tIns="0" rIns="0" bIns="0" rtlCol="0" anchor="ctr">
+            <a:normAutofit/>
+          </a:bodyPr>
+          <a:lstStyle/>
+          <a:p>
+            <a:pPr algn="l" indent="0" marL="0">
+              <a:buNone/>
+            </a:pPr>
+            <a:r>
+              <a:rPr lang="en-US" sz="750" b="1" spc="100" kern="0" dirty="0">
+                <a:solidFill>
+                  <a:srgbClr val="BEF264"/>
+                </a:solidFill>
+                <a:latin typeface="Aptos" pitchFamily="34" charset="0"/>
+                <a:ea typeface="Aptos" pitchFamily="34" charset="-122"/>
+                <a:cs typeface="Aptos" pitchFamily="34" charset="-120"/>
+              </a:rPr>
+              <a:t>WHAT</a:t>
+            </a:r>
+            <a:endParaRPr lang="en-US" sz="750" dirty="0"/>
+          </a:p>
+        </p:txBody>
+      </p:sp>
+      <p:sp>
+        <p:nvSpPr>
+          <p:cNvPr id="41" name="Text 39"/>
+          <p:cNvSpPr/>
+          <p:nvPr/>
+        </p:nvSpPr>
+        <p:spPr>
+          <a:xfrm>
+            <a:off x="9326880" y="3639312"/>
+            <a:ext cx="1920240" cy="438912"/>
           </a:xfrm>
           <a:prstGeom prst="rect">
             <a:avLst/>
@@ -10452,7 +10862,89 @@
               <a:buNone/>
             </a:pPr>
             <a:r>
-              <a:rPr lang="en-US" sz="1150" dirty="0">
+              <a:rPr lang="en-US" sz="1020" b="1" dirty="0">
+                <a:solidFill>
+                  <a:srgbClr val="FFFFFF"/>
+                </a:solidFill>
+                <a:latin typeface="Aptos" pitchFamily="34" charset="0"/>
+                <a:ea typeface="Aptos" pitchFamily="34" charset="-122"/>
+                <a:cs typeface="Aptos" pitchFamily="34" charset="-120"/>
+              </a:rPr>
+              <a:t>Approves or rejects the pending recommendation.</a:t>
+            </a:r>
+            <a:endParaRPr lang="en-US" sz="1020" dirty="0"/>
+          </a:p>
+        </p:txBody>
+      </p:sp>
+      <p:sp>
+        <p:nvSpPr>
+          <p:cNvPr id="42" name="Text 40"/>
+          <p:cNvSpPr/>
+          <p:nvPr/>
+        </p:nvSpPr>
+        <p:spPr>
+          <a:xfrm>
+            <a:off x="9326880" y="4224528"/>
+            <a:ext cx="475488" cy="164592"/>
+          </a:xfrm>
+          <a:prstGeom prst="rect">
+            <a:avLst/>
+          </a:prstGeom>
+          <a:noFill/>
+          <a:ln/>
+        </p:spPr>
+        <p:txBody>
+          <a:bodyPr wrap="square" lIns="0" tIns="0" rIns="0" bIns="0" rtlCol="0" anchor="ctr">
+            <a:normAutofit/>
+          </a:bodyPr>
+          <a:lstStyle/>
+          <a:p>
+            <a:pPr algn="l" indent="0" marL="0">
+              <a:buNone/>
+            </a:pPr>
+            <a:r>
+              <a:rPr lang="en-US" sz="750" b="1" spc="100" kern="0" dirty="0">
+                <a:solidFill>
+                  <a:srgbClr val="BEF264"/>
+                </a:solidFill>
+                <a:latin typeface="Aptos" pitchFamily="34" charset="0"/>
+                <a:ea typeface="Aptos" pitchFamily="34" charset="-122"/>
+                <a:cs typeface="Aptos" pitchFamily="34" charset="-120"/>
+              </a:rPr>
+              <a:t>WHY</a:t>
+            </a:r>
+            <a:endParaRPr lang="en-US" sz="750" dirty="0"/>
+          </a:p>
+        </p:txBody>
+      </p:sp>
+      <p:sp>
+        <p:nvSpPr>
+          <p:cNvPr id="43" name="Text 41"/>
+          <p:cNvSpPr/>
+          <p:nvPr/>
+        </p:nvSpPr>
+        <p:spPr>
+          <a:xfrm>
+            <a:off x="9326880" y="4425696"/>
+            <a:ext cx="1920240" cy="438912"/>
+          </a:xfrm>
+          <a:prstGeom prst="rect">
+            <a:avLst/>
+          </a:prstGeom>
+          <a:noFill/>
+          <a:ln/>
+        </p:spPr>
+        <p:txBody>
+          <a:bodyPr wrap="square" lIns="0" tIns="0" rIns="0" bIns="0" rtlCol="0" anchor="t">
+            <a:normAutofit/>
+          </a:bodyPr>
+          <a:lstStyle/>
+          <a:p>
+            <a:pPr algn="l" indent="0" marL="0">
+              <a:buNone/>
+            </a:pPr>
+            <a:r>
+              <a:rPr lang="en-US" sz="940" dirty="0">
                 <a:solidFill>
                   <a:srgbClr val="BBD0C8"/>
                 </a:solidFill>
@@ -10460,26 +10952,26 @@
                 <a:ea typeface="Aptos" pitchFamily="34" charset="-122"/>
                 <a:cs typeface="Aptos" pitchFamily="34" charset="-120"/>
               </a:rPr>
-              <a:t>Publishes the price and activates opted-in shoppers.</a:t>
-            </a:r>
-            <a:endParaRPr lang="en-US" sz="1150" dirty="0"/>
-          </a:p>
-        </p:txBody>
-      </p:sp>
-      <p:sp>
-        <p:nvSpPr>
-          <p:cNvPr id="32" name="Shape 30"/>
-          <p:cNvSpPr/>
-          <p:nvPr/>
-        </p:nvSpPr>
-        <p:spPr>
-          <a:xfrm>
-            <a:off x="1097280" y="5257800"/>
-            <a:ext cx="9985248" cy="530352"/>
+              <a:t>Pricing accountability remains with the merchant.</a:t>
+            </a:r>
+            <a:endParaRPr lang="en-US" sz="940" dirty="0"/>
+          </a:p>
+        </p:txBody>
+      </p:sp>
+      <p:sp>
+        <p:nvSpPr>
+          <p:cNvPr id="44" name="Shape 42"/>
+          <p:cNvSpPr/>
+          <p:nvPr/>
+        </p:nvSpPr>
+        <p:spPr>
+          <a:xfrm>
+            <a:off x="1078992" y="5276088"/>
+            <a:ext cx="10012680" cy="566928"/>
           </a:xfrm>
           <a:prstGeom prst="roundRect">
             <a:avLst>
-              <a:gd name="adj" fmla="val 27586"/>
+              <a:gd name="adj" fmla="val 25806"/>
             </a:avLst>
           </a:prstGeom>
           <a:solidFill>
@@ -10497,32 +10989,73 @@
       </p:sp>
       <p:sp>
         <p:nvSpPr>
-          <p:cNvPr id="33" name="Text 31"/>
-          <p:cNvSpPr/>
-          <p:nvPr/>
-        </p:nvSpPr>
-        <p:spPr>
-          <a:xfrm>
-            <a:off x="1353312" y="5422392"/>
-            <a:ext cx="1078992" cy="164592"/>
-          </a:xfrm>
-          <a:prstGeom prst="rect">
-            <a:avLst/>
-          </a:prstGeom>
-          <a:noFill/>
-          <a:ln/>
-        </p:spPr>
-        <p:txBody>
-          <a:bodyPr wrap="square" lIns="0" tIns="0" rIns="0" bIns="0" rtlCol="0" anchor="ctr">
-            <a:normAutofit/>
-          </a:bodyPr>
-          <a:lstStyle/>
-          <a:p>
-            <a:pPr algn="l" indent="0" marL="0">
-              <a:buNone/>
-            </a:pPr>
-            <a:r>
-              <a:rPr lang="en-US" sz="850" b="1" spc="100" kern="0" dirty="0">
+          <p:cNvPr id="45" name="Text 43"/>
+          <p:cNvSpPr/>
+          <p:nvPr/>
+        </p:nvSpPr>
+        <p:spPr>
+          <a:xfrm>
+            <a:off x="1307592" y="5458968"/>
+            <a:ext cx="1444752" cy="164592"/>
+          </a:xfrm>
+          <a:prstGeom prst="rect">
+            <a:avLst/>
+          </a:prstGeom>
+          <a:noFill/>
+          <a:ln/>
+        </p:spPr>
+        <p:txBody>
+          <a:bodyPr wrap="square" lIns="0" tIns="0" rIns="0" bIns="0" rtlCol="0" anchor="ctr">
+            <a:normAutofit/>
+          </a:bodyPr>
+          <a:lstStyle/>
+          <a:p>
+            <a:pPr algn="l" indent="0" marL="0">
+              <a:buNone/>
+            </a:pPr>
+            <a:r>
+              <a:rPr lang="en-US" sz="820" b="1" spc="70" kern="0" dirty="0">
+                <a:solidFill>
+                  <a:srgbClr val="7C3AED"/>
+                </a:solidFill>
+                <a:latin typeface="Aptos" pitchFamily="34" charset="0"/>
+                <a:ea typeface="Aptos" pitchFamily="34" charset="-122"/>
+                <a:cs typeface="Aptos" pitchFamily="34" charset="-120"/>
+              </a:rPr>
+              <a:t>XGBOOST PREDICTS</a:t>
+            </a:r>
+            <a:endParaRPr lang="en-US" sz="820" dirty="0"/>
+          </a:p>
+        </p:txBody>
+      </p:sp>
+      <p:sp>
+        <p:nvSpPr>
+          <p:cNvPr id="46" name="Text 44"/>
+          <p:cNvSpPr/>
+          <p:nvPr/>
+        </p:nvSpPr>
+        <p:spPr>
+          <a:xfrm>
+            <a:off x="2761488" y="5394960"/>
+            <a:ext cx="320040" cy="274320"/>
+          </a:xfrm>
+          <a:prstGeom prst="rect">
+            <a:avLst/>
+          </a:prstGeom>
+          <a:noFill/>
+          <a:ln/>
+        </p:spPr>
+        <p:txBody>
+          <a:bodyPr wrap="square" lIns="0" tIns="0" rIns="0" bIns="0" rtlCol="0" anchor="ctr">
+            <a:normAutofit/>
+          </a:bodyPr>
+          <a:lstStyle/>
+          <a:p>
+            <a:pPr algn="ctr" indent="0" marL="0">
+              <a:buNone/>
+            </a:pPr>
+            <a:r>
+              <a:rPr lang="en-US" sz="1700" b="1" dirty="0">
                 <a:solidFill>
                   <a:srgbClr val="BEF264"/>
                 </a:solidFill>
@@ -10530,63 +11063,227 @@
                 <a:ea typeface="Aptos" pitchFamily="34" charset="-122"/>
                 <a:cs typeface="Aptos" pitchFamily="34" charset="-120"/>
               </a:rPr>
-              <a:t>GEMINI CANNOT</a:t>
-            </a:r>
-            <a:endParaRPr lang="en-US" sz="850" dirty="0"/>
-          </a:p>
-        </p:txBody>
-      </p:sp>
-      <p:sp>
-        <p:nvSpPr>
-          <p:cNvPr id="34" name="Text 32"/>
-          <p:cNvSpPr/>
-          <p:nvPr/>
-        </p:nvSpPr>
-        <p:spPr>
-          <a:xfrm>
-            <a:off x="2514600" y="5367528"/>
-            <a:ext cx="8092440" cy="274320"/>
-          </a:xfrm>
-          <a:prstGeom prst="rect">
-            <a:avLst/>
-          </a:prstGeom>
-          <a:noFill/>
-          <a:ln/>
-        </p:spPr>
-        <p:txBody>
-          <a:bodyPr wrap="square" lIns="0" tIns="0" rIns="0" bIns="0" rtlCol="0" anchor="ctr">
-            <a:normAutofit/>
-          </a:bodyPr>
-          <a:lstStyle/>
-          <a:p>
-            <a:pPr algn="l" indent="0" marL="0">
-              <a:buNone/>
-            </a:pPr>
-            <a:r>
-              <a:rPr lang="en-US" sz="1100" b="1" dirty="0">
-                <a:solidFill>
-                  <a:srgbClr val="FFFFFF"/>
-                </a:solidFill>
-                <a:latin typeface="Aptos" pitchFamily="34" charset="0"/>
-                <a:ea typeface="Aptos" pitchFamily="34" charset="-122"/>
-                <a:cs typeface="Aptos" pitchFamily="34" charset="-120"/>
-              </a:rPr>
-              <a:t>change price  •  change expiry  •  override guardrails  •  consume customer identity</a:t>
-            </a:r>
-            <a:endParaRPr lang="en-US" sz="1100" dirty="0"/>
-          </a:p>
-        </p:txBody>
-      </p:sp>
-      <p:sp>
-        <p:nvSpPr>
-          <p:cNvPr id="35" name="Shape 33"/>
+              <a:t>→</a:t>
+            </a:r>
+            <a:endParaRPr lang="en-US" sz="1700" dirty="0"/>
+          </a:p>
+        </p:txBody>
+      </p:sp>
+      <p:sp>
+        <p:nvSpPr>
+          <p:cNvPr id="47" name="Text 45"/>
+          <p:cNvSpPr/>
+          <p:nvPr/>
+        </p:nvSpPr>
+        <p:spPr>
+          <a:xfrm>
+            <a:off x="3136392" y="5458968"/>
+            <a:ext cx="1444752" cy="164592"/>
+          </a:xfrm>
+          <a:prstGeom prst="rect">
+            <a:avLst/>
+          </a:prstGeom>
+          <a:noFill/>
+          <a:ln/>
+        </p:spPr>
+        <p:txBody>
+          <a:bodyPr wrap="square" lIns="0" tIns="0" rIns="0" bIns="0" rtlCol="0" anchor="ctr">
+            <a:normAutofit/>
+          </a:bodyPr>
+          <a:lstStyle/>
+          <a:p>
+            <a:pPr algn="l" indent="0" marL="0">
+              <a:buNone/>
+            </a:pPr>
+            <a:r>
+              <a:rPr lang="en-US" sz="820" b="1" spc="70" kern="0" dirty="0">
+                <a:solidFill>
+                  <a:srgbClr val="F97316"/>
+                </a:solidFill>
+                <a:latin typeface="Aptos" pitchFamily="34" charset="0"/>
+                <a:ea typeface="Aptos" pitchFamily="34" charset="-122"/>
+                <a:cs typeface="Aptos" pitchFamily="34" charset="-120"/>
+              </a:rPr>
+              <a:t>POLICY CONSTRAINS</a:t>
+            </a:r>
+            <a:endParaRPr lang="en-US" sz="820" dirty="0"/>
+          </a:p>
+        </p:txBody>
+      </p:sp>
+      <p:sp>
+        <p:nvSpPr>
+          <p:cNvPr id="48" name="Text 46"/>
+          <p:cNvSpPr/>
+          <p:nvPr/>
+        </p:nvSpPr>
+        <p:spPr>
+          <a:xfrm>
+            <a:off x="4617720" y="5394960"/>
+            <a:ext cx="320040" cy="274320"/>
+          </a:xfrm>
+          <a:prstGeom prst="rect">
+            <a:avLst/>
+          </a:prstGeom>
+          <a:noFill/>
+          <a:ln/>
+        </p:spPr>
+        <p:txBody>
+          <a:bodyPr wrap="square" lIns="0" tIns="0" rIns="0" bIns="0" rtlCol="0" anchor="ctr">
+            <a:normAutofit/>
+          </a:bodyPr>
+          <a:lstStyle/>
+          <a:p>
+            <a:pPr algn="ctr" indent="0" marL="0">
+              <a:buNone/>
+            </a:pPr>
+            <a:r>
+              <a:rPr lang="en-US" sz="1700" b="1" dirty="0">
+                <a:solidFill>
+                  <a:srgbClr val="BEF264"/>
+                </a:solidFill>
+                <a:latin typeface="Aptos" pitchFamily="34" charset="0"/>
+                <a:ea typeface="Aptos" pitchFamily="34" charset="-122"/>
+                <a:cs typeface="Aptos" pitchFamily="34" charset="-120"/>
+              </a:rPr>
+              <a:t>→</a:t>
+            </a:r>
+            <a:endParaRPr lang="en-US" sz="1700" dirty="0"/>
+          </a:p>
+        </p:txBody>
+      </p:sp>
+      <p:sp>
+        <p:nvSpPr>
+          <p:cNvPr id="49" name="Text 47"/>
+          <p:cNvSpPr/>
+          <p:nvPr/>
+        </p:nvSpPr>
+        <p:spPr>
+          <a:xfrm>
+            <a:off x="4983480" y="5458968"/>
+            <a:ext cx="1737360" cy="164592"/>
+          </a:xfrm>
+          <a:prstGeom prst="rect">
+            <a:avLst/>
+          </a:prstGeom>
+          <a:noFill/>
+          <a:ln/>
+        </p:spPr>
+        <p:txBody>
+          <a:bodyPr wrap="square" lIns="0" tIns="0" rIns="0" bIns="0" rtlCol="0" anchor="ctr">
+            <a:normAutofit/>
+          </a:bodyPr>
+          <a:lstStyle/>
+          <a:p>
+            <a:pPr algn="l" indent="0" marL="0">
+              <a:buNone/>
+            </a:pPr>
+            <a:r>
+              <a:rPr lang="en-US" sz="820" b="1" spc="70" kern="0" dirty="0">
+                <a:solidFill>
+                  <a:srgbClr val="10B981"/>
+                </a:solidFill>
+                <a:latin typeface="Aptos" pitchFamily="34" charset="0"/>
+                <a:ea typeface="Aptos" pitchFamily="34" charset="-122"/>
+                <a:cs typeface="Aptos" pitchFamily="34" charset="-120"/>
+              </a:rPr>
+              <a:t>GEMINI COMMUNICATES</a:t>
+            </a:r>
+            <a:endParaRPr lang="en-US" sz="820" dirty="0"/>
+          </a:p>
+        </p:txBody>
+      </p:sp>
+      <p:sp>
+        <p:nvSpPr>
+          <p:cNvPr id="50" name="Text 48"/>
+          <p:cNvSpPr/>
+          <p:nvPr/>
+        </p:nvSpPr>
+        <p:spPr>
+          <a:xfrm>
+            <a:off x="6793992" y="5394960"/>
+            <a:ext cx="320040" cy="274320"/>
+          </a:xfrm>
+          <a:prstGeom prst="rect">
+            <a:avLst/>
+          </a:prstGeom>
+          <a:noFill/>
+          <a:ln/>
+        </p:spPr>
+        <p:txBody>
+          <a:bodyPr wrap="square" lIns="0" tIns="0" rIns="0" bIns="0" rtlCol="0" anchor="ctr">
+            <a:normAutofit/>
+          </a:bodyPr>
+          <a:lstStyle/>
+          <a:p>
+            <a:pPr algn="ctr" indent="0" marL="0">
+              <a:buNone/>
+            </a:pPr>
+            <a:r>
+              <a:rPr lang="en-US" sz="1700" b="1" dirty="0">
+                <a:solidFill>
+                  <a:srgbClr val="BEF264"/>
+                </a:solidFill>
+                <a:latin typeface="Aptos" pitchFamily="34" charset="0"/>
+                <a:ea typeface="Aptos" pitchFamily="34" charset="-122"/>
+                <a:cs typeface="Aptos" pitchFamily="34" charset="-120"/>
+              </a:rPr>
+              <a:t>→</a:t>
+            </a:r>
+            <a:endParaRPr lang="en-US" sz="1700" dirty="0"/>
+          </a:p>
+        </p:txBody>
+      </p:sp>
+      <p:sp>
+        <p:nvSpPr>
+          <p:cNvPr id="51" name="Text 49"/>
+          <p:cNvSpPr/>
+          <p:nvPr/>
+        </p:nvSpPr>
+        <p:spPr>
+          <a:xfrm>
+            <a:off x="7205472" y="5458968"/>
+            <a:ext cx="1371600" cy="164592"/>
+          </a:xfrm>
+          <a:prstGeom prst="rect">
+            <a:avLst/>
+          </a:prstGeom>
+          <a:noFill/>
+          <a:ln/>
+        </p:spPr>
+        <p:txBody>
+          <a:bodyPr wrap="square" lIns="0" tIns="0" rIns="0" bIns="0" rtlCol="0" anchor="ctr">
+            <a:normAutofit/>
+          </a:bodyPr>
+          <a:lstStyle/>
+          <a:p>
+            <a:pPr algn="l" indent="0" marL="0">
+              <a:buNone/>
+            </a:pPr>
+            <a:r>
+              <a:rPr lang="en-US" sz="820" b="1" spc="70" kern="0" dirty="0">
+                <a:solidFill>
+                  <a:srgbClr val="BEF264"/>
+                </a:solidFill>
+                <a:latin typeface="Aptos" pitchFamily="34" charset="0"/>
+                <a:ea typeface="Aptos" pitchFamily="34" charset="-122"/>
+                <a:cs typeface="Aptos" pitchFamily="34" charset="-120"/>
+              </a:rPr>
+              <a:t>OWNER DECIDES</a:t>
+            </a:r>
+            <a:endParaRPr lang="en-US" sz="820" dirty="0"/>
+          </a:p>
+        </p:txBody>
+      </p:sp>
+      <p:sp>
+        <p:nvSpPr>
+          <p:cNvPr id="52" name="Shape 50"/>
           <p:cNvSpPr/>
           <p:nvPr/>
         </p:nvSpPr>
         <p:spPr>
           <a:xfrm>
             <a:off x="640080" y="6035040"/>
-            <a:ext cx="1143000" cy="292608"/>
+            <a:ext cx="1664208" cy="292608"/>
           </a:xfrm>
           <a:prstGeom prst="roundRect">
             <a:avLst>
@@ -10608,14 +11305,14 @@
       </p:sp>
       <p:sp>
         <p:nvSpPr>
-          <p:cNvPr id="36" name="Text 34"/>
+          <p:cNvPr id="53" name="Text 51"/>
           <p:cNvSpPr/>
           <p:nvPr/>
         </p:nvSpPr>
         <p:spPr>
           <a:xfrm>
             <a:off x="713232" y="6035040"/>
-            <a:ext cx="996696" cy="292608"/>
+            <a:ext cx="1517904" cy="292608"/>
           </a:xfrm>
           <a:prstGeom prst="rect">
             <a:avLst/>
@@ -10641,7 +11338,7 @@
                 <a:ea typeface="Aptos" pitchFamily="34" charset="-122"/>
                 <a:cs typeface="Aptos" pitchFamily="34" charset="-120"/>
               </a:rPr>
-              <a:t>LIVE: XGBOOST</a:t>
+              <a:t>LIVE PRIMARY AI: XGBOOST</a:t>
             </a:r>
             <a:endParaRPr lang="en-US" sz="900" dirty="0"/>
           </a:p>
@@ -10649,14 +11346,84 @@
       </p:sp>
       <p:sp>
         <p:nvSpPr>
-          <p:cNvPr id="37" name="Shape 35"/>
-          <p:cNvSpPr/>
-          <p:nvPr/>
-        </p:nvSpPr>
-        <p:spPr>
-          <a:xfrm>
-            <a:off x="1938528" y="6035040"/>
-            <a:ext cx="1965960" cy="292608"/>
+          <p:cNvPr id="54" name="Shape 52"/>
+          <p:cNvSpPr/>
+          <p:nvPr/>
+        </p:nvSpPr>
+        <p:spPr>
+          <a:xfrm>
+            <a:off x="2468880" y="6035040"/>
+            <a:ext cx="1664208" cy="292608"/>
+          </a:xfrm>
+          <a:prstGeom prst="roundRect">
+            <a:avLst>
+              <a:gd name="adj" fmla="val 50000"/>
+            </a:avLst>
+          </a:prstGeom>
+          <a:solidFill>
+            <a:srgbClr val="10B981"/>
+          </a:solidFill>
+          <a:ln w="12700">
+            <a:solidFill>
+              <a:srgbClr val="10B981">
+                <a:alpha val="0"/>
+              </a:srgbClr>
+            </a:solidFill>
+            <a:prstDash val="solid"/>
+          </a:ln>
+        </p:spPr>
+      </p:sp>
+      <p:sp>
+        <p:nvSpPr>
+          <p:cNvPr id="55" name="Text 53"/>
+          <p:cNvSpPr/>
+          <p:nvPr/>
+        </p:nvSpPr>
+        <p:spPr>
+          <a:xfrm>
+            <a:off x="2542032" y="6035040"/>
+            <a:ext cx="1517904" cy="292608"/>
+          </a:xfrm>
+          <a:prstGeom prst="rect">
+            <a:avLst/>
+          </a:prstGeom>
+          <a:noFill/>
+          <a:ln/>
+        </p:spPr>
+        <p:txBody>
+          <a:bodyPr wrap="square" lIns="0" tIns="0" rIns="0" bIns="0" rtlCol="0" anchor="ctr">
+            <a:normAutofit/>
+          </a:bodyPr>
+          <a:lstStyle/>
+          <a:p>
+            <a:pPr algn="ctr" indent="0" marL="0">
+              <a:buNone/>
+            </a:pPr>
+            <a:r>
+              <a:rPr lang="en-US" sz="900" b="1" dirty="0">
+                <a:solidFill>
+                  <a:srgbClr val="FFFFFF"/>
+                </a:solidFill>
+                <a:latin typeface="Aptos" pitchFamily="34" charset="0"/>
+                <a:ea typeface="Aptos" pitchFamily="34" charset="-122"/>
+                <a:cs typeface="Aptos" pitchFamily="34" charset="-120"/>
+              </a:rPr>
+              <a:t>OPTIONAL GEN AI: GEMINI</a:t>
+            </a:r>
+            <a:endParaRPr lang="en-US" sz="900" dirty="0"/>
+          </a:p>
+        </p:txBody>
+      </p:sp>
+      <p:sp>
+        <p:nvSpPr>
+          <p:cNvPr id="56" name="Shape 54"/>
+          <p:cNvSpPr/>
+          <p:nvPr/>
+        </p:nvSpPr>
+        <p:spPr>
+          <a:xfrm>
+            <a:off x="4297680" y="6035040"/>
+            <a:ext cx="1847088" cy="292608"/>
           </a:xfrm>
           <a:prstGeom prst="roundRect">
             <a:avLst>
@@ -10678,14 +11445,14 @@
       </p:sp>
       <p:sp>
         <p:nvSpPr>
-          <p:cNvPr id="38" name="Text 36"/>
-          <p:cNvSpPr/>
-          <p:nvPr/>
-        </p:nvSpPr>
-        <p:spPr>
-          <a:xfrm>
-            <a:off x="2011680" y="6035040"/>
-            <a:ext cx="1819656" cy="292608"/>
+          <p:cNvPr id="57" name="Text 55"/>
+          <p:cNvSpPr/>
+          <p:nvPr/>
+        </p:nvSpPr>
+        <p:spPr>
+          <a:xfrm>
+            <a:off x="4370832" y="6035040"/>
+            <a:ext cx="1700784" cy="292608"/>
           </a:xfrm>
           <a:prstGeom prst="rect">
             <a:avLst/>
@@ -10719,7 +11486,7 @@
       </p:sp>
       <p:sp>
         <p:nvSpPr>
-          <p:cNvPr id="39" name="Shape 37"/>
+          <p:cNvPr id="58" name="Shape 56"/>
           <p:cNvSpPr/>
           <p:nvPr/>
         </p:nvSpPr>
@@ -10742,7 +11509,7 @@
       </p:sp>
       <p:sp>
         <p:nvSpPr>
-          <p:cNvPr id="40" name="Text 38"/>
+          <p:cNvPr id="59" name="Text 57"/>
           <p:cNvSpPr/>
           <p:nvPr/>
         </p:nvSpPr>
@@ -10783,7 +11550,7 @@
       </p:sp>
       <p:sp>
         <p:nvSpPr>
-          <p:cNvPr id="41" name="Text 39"/>
+          <p:cNvPr id="60" name="Text 58"/>
           <p:cNvSpPr/>
           <p:nvPr/>
         </p:nvSpPr>

</xml_diff>